<commit_message>
increased font size on some slides.
</commit_message>
<xml_diff>
--- a/slides/Lecture_Chapter06.pptx
+++ b/slides/Lecture_Chapter06.pptx
@@ -4601,8 +4601,8 @@
           </a:p>
         </p:txBody>
       </p:sp>
-      <mc:AlternateContent xmlns:mc="http://schemas.openxmlformats.org/markup-compatibility/2006" xmlns:a14="http://schemas.microsoft.com/office/drawing/2010/main">
-        <mc:Choice Requires="a14">
+      <mc:AlternateContent xmlns:mc="http://schemas.openxmlformats.org/markup-compatibility/2006">
+        <mc:Choice xmlns:a14="http://schemas.microsoft.com/office/drawing/2010/main" Requires="a14">
           <p:sp>
             <p:nvSpPr>
               <p:cNvPr id="3" name="Content Placeholder 2">
@@ -4627,7 +4627,7 @@
             </p:spPr>
             <p:txBody>
               <a:bodyPr>
-                <a:normAutofit/>
+                <a:normAutofit lnSpcReduction="10000"/>
               </a:bodyPr>
               <a:lstStyle/>
               <a:p>
@@ -4757,13 +4757,27 @@
                 </a:r>
                 <a:r>
                   <a:rPr lang="en-US" sz="2400" dirty="0"/>
-                  <a:t>: Converges typically faster than MC prediction.</a:t>
+                  <a:t>: Converges typically faster than MC prediction. Reasons: </a:t>
+                </a:r>
+              </a:p>
+              <a:p>
+                <a:pPr lvl="1"/>
+                <a:r>
+                  <a:rPr lang="en-US" sz="2000" dirty="0"/>
+                  <a:t>Less variance: Stochasticity in the environment produces large variance in the return of sampled episodes used by MC, but TD only samples the next reward and state.</a:t>
+                </a:r>
+              </a:p>
+              <a:p>
+                <a:pPr lvl="1"/>
+                <a:r>
+                  <a:rPr lang="en-US" sz="2000" dirty="0"/>
+                  <a:t>More frequent updates.</a:t>
                 </a:r>
               </a:p>
             </p:txBody>
           </p:sp>
         </mc:Choice>
-        <mc:Fallback xmlns="">
+        <mc:Fallback>
           <p:sp>
             <p:nvSpPr>
               <p:cNvPr id="3" name="Content Placeholder 2">
@@ -4788,7 +4802,7 @@
               <a:blipFill>
                 <a:blip r:embed="rId2"/>
                 <a:stretch>
-                  <a:fillRect l="-1224" t="-1658" r="-1573"/>
+                  <a:fillRect l="-1224" t="-2296" r="-1573"/>
                 </a:stretch>
               </a:blipFill>
             </p:spPr>
@@ -4821,8 +4835,8 @@
         </p:nvSpPr>
         <p:spPr>
           <a:xfrm>
-            <a:off x="8198620" y="1584649"/>
-            <a:ext cx="3094220" cy="923330"/>
+            <a:off x="8259580" y="1384631"/>
+            <a:ext cx="3094220" cy="1200329"/>
           </a:xfrm>
           <a:prstGeom prst="rect">
             <a:avLst/>
@@ -4848,9 +4862,23 @@
           </a:bodyPr>
           <a:lstStyle/>
           <a:p>
+            <a:pPr marL="285750" indent="-285750">
+              <a:buFont typeface="Arial" panose="020B0604020202020204" pitchFamily="34" charset="0"/>
+              <a:buChar char="•"/>
+            </a:pPr>
             <a:r>
               <a:rPr lang="en-US" dirty="0"/>
-              <a:t>TD plans and MC waits for the end of the episode for an unbiased estimate.</a:t>
+              <a:t>DP plans using the model </a:t>
+            </a:r>
+          </a:p>
+          <a:p>
+            <a:pPr marL="285750" indent="-285750">
+              <a:buFont typeface="Arial" panose="020B0604020202020204" pitchFamily="34" charset="0"/>
+              <a:buChar char="•"/>
+            </a:pPr>
+            <a:r>
+              <a:rPr lang="en-US" dirty="0"/>
+              <a:t>MC waits for the end of the episode for an unbiased estimate.</a:t>
             </a:r>
           </a:p>
         </p:txBody>
@@ -4869,7 +4897,7 @@
         </p:nvSpPr>
         <p:spPr>
           <a:xfrm>
-            <a:off x="8198620" y="2845393"/>
+            <a:off x="8259580" y="2912505"/>
             <a:ext cx="3094220" cy="646331"/>
           </a:xfrm>
           <a:prstGeom prst="rect">
@@ -4896,9 +4924,23 @@
           </a:bodyPr>
           <a:lstStyle/>
           <a:p>
+            <a:pPr marL="285750" indent="-285750">
+              <a:buFont typeface="Arial" panose="020B0604020202020204" pitchFamily="34" charset="0"/>
+              <a:buChar char="•"/>
+            </a:pPr>
             <a:r>
               <a:rPr lang="en-US" dirty="0"/>
-              <a:t>Same for MC, but TD needs the model.</a:t>
+              <a:t>Same as MC</a:t>
+            </a:r>
+          </a:p>
+          <a:p>
+            <a:pPr marL="285750" indent="-285750">
+              <a:buFont typeface="Arial" panose="020B0604020202020204" pitchFamily="34" charset="0"/>
+              <a:buChar char="•"/>
+            </a:pPr>
+            <a:r>
+              <a:rPr lang="en-US" dirty="0"/>
+              <a:t>DP needs the model</a:t>
             </a:r>
           </a:p>
         </p:txBody>
@@ -5135,8 +5177,8 @@
           </a:p>
         </p:txBody>
       </p:sp>
-      <mc:AlternateContent xmlns:mc="http://schemas.openxmlformats.org/markup-compatibility/2006">
-        <mc:Choice xmlns:a14="http://schemas.microsoft.com/office/drawing/2010/main" Requires="a14">
+      <mc:AlternateContent xmlns:mc="http://schemas.openxmlformats.org/markup-compatibility/2006" xmlns:a14="http://schemas.microsoft.com/office/drawing/2010/main">
+        <mc:Choice Requires="a14">
           <p:sp>
             <p:nvSpPr>
               <p:cNvPr id="3" name="Content Placeholder 2">
@@ -5827,7 +5869,7 @@
                   </m:oMath>
                 </a14:m>
                 <a:r>
-                  <a:rPr lang="en-US"/>
+                  <a:rPr lang="en-US" dirty="0"/>
                   <a:t>. </a:t>
                 </a:r>
               </a:p>
@@ -6152,7 +6194,7 @@
             </p:txBody>
           </p:sp>
         </mc:Choice>
-        <mc:Fallback>
+        <mc:Fallback xmlns="">
           <p:sp>
             <p:nvSpPr>
               <p:cNvPr id="3" name="Content Placeholder 2">
@@ -7570,6 +7612,129 @@
           </p:sp>
         </mc:Fallback>
       </mc:AlternateContent>
+      <mc:AlternateContent xmlns:mc="http://schemas.openxmlformats.org/markup-compatibility/2006">
+        <mc:Choice xmlns:a14="http://schemas.microsoft.com/office/drawing/2010/main" Requires="a14">
+          <p:sp>
+            <p:nvSpPr>
+              <p:cNvPr id="10" name="TextBox 9">
+                <a:extLst>
+                  <a:ext uri="{FF2B5EF4-FFF2-40B4-BE49-F238E27FC236}">
+                    <a16:creationId xmlns:a16="http://schemas.microsoft.com/office/drawing/2014/main" id="{0BB9E2F2-E6A8-1691-D5E9-CD18B9FFD151}"/>
+                  </a:ext>
+                </a:extLst>
+              </p:cNvPr>
+              <p:cNvSpPr txBox="1"/>
+              <p:nvPr/>
+            </p:nvSpPr>
+            <p:spPr>
+              <a:xfrm>
+                <a:off x="3338814" y="6123542"/>
+                <a:ext cx="2009163" cy="369332"/>
+              </a:xfrm>
+              <a:prstGeom prst="rect">
+                <a:avLst/>
+              </a:prstGeom>
+            </p:spPr>
+            <p:style>
+              <a:lnRef idx="2">
+                <a:schemeClr val="accent1">
+                  <a:shade val="15000"/>
+                </a:schemeClr>
+              </a:lnRef>
+              <a:fillRef idx="1">
+                <a:schemeClr val="accent1"/>
+              </a:fillRef>
+              <a:effectRef idx="0">
+                <a:schemeClr val="accent1"/>
+              </a:effectRef>
+              <a:fontRef idx="minor">
+                <a:schemeClr val="lt1"/>
+              </a:fontRef>
+            </p:style>
+            <p:txBody>
+              <a:bodyPr wrap="square" rtlCol="0">
+                <a:spAutoFit/>
+              </a:bodyPr>
+              <a:lstStyle/>
+              <a:p>
+                <a:r>
+                  <a:rPr lang="en-US" dirty="0"/>
+                  <a:t>+ extract </a:t>
+                </a:r>
+                <a14:m>
+                  <m:oMath xmlns:m="http://schemas.openxmlformats.org/officeDocument/2006/math">
+                    <m:r>
+                      <a:rPr lang="en-US" b="0" i="1" smtClean="0">
+                        <a:latin typeface="Cambria Math" panose="02040503050406030204" pitchFamily="18" charset="0"/>
+                      </a:rPr>
+                      <m:t>𝜋</m:t>
+                    </m:r>
+                  </m:oMath>
+                </a14:m>
+                <a:r>
+                  <a:rPr lang="en-US" dirty="0"/>
+                  <a:t> from </a:t>
+                </a:r>
+                <a14:m>
+                  <m:oMath xmlns:m="http://schemas.openxmlformats.org/officeDocument/2006/math">
+                    <m:r>
+                      <a:rPr lang="en-US" b="0" i="1" smtClean="0">
+                        <a:latin typeface="Cambria Math" panose="02040503050406030204" pitchFamily="18" charset="0"/>
+                      </a:rPr>
+                      <m:t>𝑄</m:t>
+                    </m:r>
+                  </m:oMath>
+                </a14:m>
+                <a:endParaRPr lang="en-US" dirty="0"/>
+              </a:p>
+            </p:txBody>
+          </p:sp>
+        </mc:Choice>
+        <mc:Fallback>
+          <p:sp>
+            <p:nvSpPr>
+              <p:cNvPr id="10" name="TextBox 9">
+                <a:extLst>
+                  <a:ext uri="{FF2B5EF4-FFF2-40B4-BE49-F238E27FC236}">
+                    <a16:creationId xmlns:a16="http://schemas.microsoft.com/office/drawing/2014/main" id="{0BB9E2F2-E6A8-1691-D5E9-CD18B9FFD151}"/>
+                  </a:ext>
+                </a:extLst>
+              </p:cNvPr>
+              <p:cNvSpPr txBox="1">
+                <a:spLocks noRot="1" noChangeAspect="1" noMove="1" noResize="1" noEditPoints="1" noAdjustHandles="1" noChangeArrowheads="1" noChangeShapeType="1" noTextEdit="1"/>
+              </p:cNvSpPr>
+              <p:nvPr/>
+            </p:nvSpPr>
+            <p:spPr>
+              <a:xfrm>
+                <a:off x="3338814" y="6123542"/>
+                <a:ext cx="2009163" cy="369332"/>
+              </a:xfrm>
+              <a:prstGeom prst="rect">
+                <a:avLst/>
+              </a:prstGeom>
+              <a:blipFill>
+                <a:blip r:embed="rId6"/>
+                <a:stretch>
+                  <a:fillRect l="-2410" t="-6349" b="-23810"/>
+                </a:stretch>
+              </a:blipFill>
+            </p:spPr>
+            <p:txBody>
+              <a:bodyPr/>
+              <a:lstStyle/>
+              <a:p>
+                <a:r>
+                  <a:rPr lang="en-US">
+                    <a:noFill/>
+                  </a:rPr>
+                  <a:t> </a:t>
+                </a:r>
+              </a:p>
+            </p:txBody>
+          </p:sp>
+        </mc:Fallback>
+      </mc:AlternateContent>
     </p:spTree>
     <p:extLst>
       <p:ext uri="{BB962C8B-B14F-4D97-AF65-F5344CB8AC3E}">
@@ -7658,7 +7823,7 @@
           <a:p>
             <a:r>
               <a:rPr lang="en-US" dirty="0"/>
-              <a:t>Learn a deterministic policy while following an exploring behavior policy.</a:t>
+              <a:t>Learn a deterministic target policy while following an exploring behavior policy.</a:t>
             </a:r>
           </a:p>
         </p:txBody>
@@ -7721,8 +7886,8 @@
           </a:p>
         </p:txBody>
       </p:sp>
-      <mc:AlternateContent xmlns:mc="http://schemas.openxmlformats.org/markup-compatibility/2006" xmlns:a14="http://schemas.microsoft.com/office/drawing/2010/main">
-        <mc:Choice Requires="a14">
+      <mc:AlternateContent xmlns:mc="http://schemas.openxmlformats.org/markup-compatibility/2006">
+        <mc:Choice xmlns:a14="http://schemas.microsoft.com/office/drawing/2010/main" Requires="a14">
           <p:sp>
             <p:nvSpPr>
               <p:cNvPr id="3" name="Content Placeholder 2">
@@ -7754,7 +7919,7 @@
               <a:p>
                 <a:r>
                   <a:rPr lang="en-US" dirty="0"/>
-                  <a:t>Update rule only uses Sars observed by following the behavior policy:</a:t>
+                  <a:t>Update rule only uses observed Sars following the behavior policy:</a:t>
                 </a:r>
               </a:p>
               <a:p>
@@ -8245,31 +8410,25 @@
                 </a14:m>
                 <a:r>
                   <a:rPr lang="en-US" dirty="0"/>
-                  <a:t> independent of the behavior policy being followed because it ignores the next behavior action and updates with the next action for the greedy target policy instead. Note: There is no need for importance sampling, it relies on </a:t>
-                </a:r>
-                <a14:m>
-                  <m:oMath xmlns:m="http://schemas.openxmlformats.org/officeDocument/2006/math">
-                    <m:r>
-                      <a:rPr lang="en-US" b="0" i="1" smtClean="0">
-                        <a:latin typeface="Cambria Math" panose="02040503050406030204" pitchFamily="18" charset="0"/>
-                      </a:rPr>
-                      <m:t>𝑄</m:t>
-                    </m:r>
-                  </m:oMath>
-                </a14:m>
-                <a:r>
-                  <a:rPr lang="en-US" dirty="0"/>
-                  <a:t> estimates instead.</a:t>
+                  <a:t> independent of the behavior policy being followed because it ignores the next behavior action and updates with the next action for the greedy target policy instead. Note: There is no need for importance sampling!</a:t>
                 </a:r>
               </a:p>
               <a:p>
                 <a:r>
                   <a:rPr lang="en-US" b="1" dirty="0"/>
-                  <a:t>Converges</a:t>
+                  <a:t>Convergence</a:t>
                 </a:r>
                 <a:r>
                   <a:rPr lang="en-US" dirty="0"/>
-                  <a:t> to the optimal value function if:</a:t>
+                  <a:t> </a:t>
+                </a:r>
+                <a:r>
+                  <a:rPr lang="en-US" b="1" dirty="0"/>
+                  <a:t>conditions</a:t>
+                </a:r>
+                <a:r>
+                  <a:rPr lang="en-US" dirty="0"/>
+                  <a:t>: </a:t>
                 </a:r>
               </a:p>
               <a:p>
@@ -8289,13 +8448,13 @@
                 </a:pPr>
                 <a:r>
                   <a:rPr lang="en-US" dirty="0"/>
-                  <a:t>All action are repeatedly sampled in all states (behavior policy keeps exploring).</a:t>
+                  <a:t>All actions are repeatedly sampled in all states (behavior policy keeps exploring).</a:t>
                 </a:r>
               </a:p>
             </p:txBody>
           </p:sp>
         </mc:Choice>
-        <mc:Fallback xmlns="">
+        <mc:Fallback>
           <p:sp>
             <p:nvSpPr>
               <p:cNvPr id="3" name="Content Placeholder 2">
@@ -8349,7 +8508,7 @@
         </p:nvSpPr>
         <p:spPr>
           <a:xfrm>
-            <a:off x="6337579" y="3354377"/>
+            <a:off x="6096000" y="3169820"/>
             <a:ext cx="4541170" cy="432769"/>
           </a:xfrm>
           <a:prstGeom prst="wedgeRoundRectCallout">
@@ -8498,15 +8657,33 @@
                                   </p:childTnLst>
                                 </p:cTn>
                               </p:par>
+                            </p:childTnLst>
+                          </p:cTn>
+                        </p:par>
+                      </p:childTnLst>
+                    </p:cTn>
+                  </p:par>
+                  <p:par>
+                    <p:cTn id="11" fill="hold">
+                      <p:stCondLst>
+                        <p:cond delay="indefinite"/>
+                      </p:stCondLst>
+                      <p:childTnLst>
+                        <p:par>
+                          <p:cTn id="12" fill="hold">
+                            <p:stCondLst>
+                              <p:cond delay="0"/>
+                            </p:stCondLst>
+                            <p:childTnLst>
                               <p:par>
-                                <p:cTn id="11" presetID="1" presetClass="entr" presetSubtype="0" fill="hold" nodeType="withEffect">
+                                <p:cTn id="13" presetID="1" presetClass="entr" presetSubtype="0" fill="hold" nodeType="clickEffect">
                                   <p:stCondLst>
                                     <p:cond delay="0"/>
                                   </p:stCondLst>
                                   <p:childTnLst>
                                     <p:set>
                                       <p:cBhvr>
-                                        <p:cTn id="12" dur="1" fill="hold">
+                                        <p:cTn id="14" dur="1" fill="hold">
                                           <p:stCondLst>
                                             <p:cond delay="0"/>
                                           </p:stCondLst>
@@ -8530,14 +8707,14 @@
                                 </p:cTn>
                               </p:par>
                               <p:par>
-                                <p:cTn id="13" presetID="1" presetClass="entr" presetSubtype="0" fill="hold" nodeType="withEffect">
+                                <p:cTn id="15" presetID="1" presetClass="entr" presetSubtype="0" fill="hold" nodeType="withEffect">
                                   <p:stCondLst>
                                     <p:cond delay="0"/>
                                   </p:stCondLst>
                                   <p:childTnLst>
                                     <p:set>
                                       <p:cBhvr>
-                                        <p:cTn id="14" dur="1" fill="hold">
+                                        <p:cTn id="16" dur="1" fill="hold">
                                           <p:stCondLst>
                                             <p:cond delay="0"/>
                                           </p:stCondLst>
@@ -8692,7 +8869,7 @@
         </p:blipFill>
         <p:spPr>
           <a:xfrm>
-            <a:off x="3233926" y="2661557"/>
+            <a:off x="3239223" y="2604879"/>
             <a:ext cx="8445114" cy="3509203"/>
           </a:xfrm>
           <a:prstGeom prst="rect">
@@ -8877,8 +9054,8 @@
           </a:fontRef>
         </p:style>
       </p:cxnSp>
-      <mc:AlternateContent xmlns:mc="http://schemas.openxmlformats.org/markup-compatibility/2006" xmlns:a14="http://schemas.microsoft.com/office/drawing/2010/main">
-        <mc:Choice Requires="a14">
+      <mc:AlternateContent xmlns:mc="http://schemas.openxmlformats.org/markup-compatibility/2006">
+        <mc:Choice xmlns:a14="http://schemas.microsoft.com/office/drawing/2010/main" Requires="a14">
           <p:sp>
             <p:nvSpPr>
               <p:cNvPr id="14" name="Speech Bubble: Rectangle with Corners Rounded 13">
@@ -8994,7 +9171,7 @@
                 </a14:m>
                 <a:r>
                   <a:rPr lang="en-US" sz="1400" dirty="0"/>
-                  <a:t> and a deterministic target </a:t>
+                  <a:t> and a deterministic target policy </a:t>
                 </a:r>
                 <a14:m>
                   <m:oMath xmlns:m="http://schemas.openxmlformats.org/officeDocument/2006/math">
@@ -9033,7 +9210,7 @@
             </p:txBody>
           </p:sp>
         </mc:Choice>
-        <mc:Fallback xmlns="">
+        <mc:Fallback>
           <p:sp>
             <p:nvSpPr>
               <p:cNvPr id="14" name="Speech Bubble: Rectangle with Corners Rounded 13">
@@ -9230,6 +9407,129 @@
           </a:p>
         </p:txBody>
       </p:sp>
+      <mc:AlternateContent xmlns:mc="http://schemas.openxmlformats.org/markup-compatibility/2006">
+        <mc:Choice xmlns:a14="http://schemas.microsoft.com/office/drawing/2010/main" Requires="a14">
+          <p:sp>
+            <p:nvSpPr>
+              <p:cNvPr id="10" name="TextBox 9">
+                <a:extLst>
+                  <a:ext uri="{FF2B5EF4-FFF2-40B4-BE49-F238E27FC236}">
+                    <a16:creationId xmlns:a16="http://schemas.microsoft.com/office/drawing/2014/main" id="{DE3D2834-B3E4-7166-3E08-4203F3346418}"/>
+                  </a:ext>
+                </a:extLst>
+              </p:cNvPr>
+              <p:cNvSpPr txBox="1"/>
+              <p:nvPr/>
+            </p:nvSpPr>
+            <p:spPr>
+              <a:xfrm>
+                <a:off x="3745069" y="6123542"/>
+                <a:ext cx="2009163" cy="369332"/>
+              </a:xfrm>
+              <a:prstGeom prst="rect">
+                <a:avLst/>
+              </a:prstGeom>
+            </p:spPr>
+            <p:style>
+              <a:lnRef idx="2">
+                <a:schemeClr val="accent1">
+                  <a:shade val="15000"/>
+                </a:schemeClr>
+              </a:lnRef>
+              <a:fillRef idx="1">
+                <a:schemeClr val="accent1"/>
+              </a:fillRef>
+              <a:effectRef idx="0">
+                <a:schemeClr val="accent1"/>
+              </a:effectRef>
+              <a:fontRef idx="minor">
+                <a:schemeClr val="lt1"/>
+              </a:fontRef>
+            </p:style>
+            <p:txBody>
+              <a:bodyPr wrap="square" rtlCol="0">
+                <a:spAutoFit/>
+              </a:bodyPr>
+              <a:lstStyle/>
+              <a:p>
+                <a:r>
+                  <a:rPr lang="en-US" dirty="0"/>
+                  <a:t>+ extract </a:t>
+                </a:r>
+                <a14:m>
+                  <m:oMath xmlns:m="http://schemas.openxmlformats.org/officeDocument/2006/math">
+                    <m:r>
+                      <a:rPr lang="en-US" b="0" i="1" smtClean="0">
+                        <a:latin typeface="Cambria Math" panose="02040503050406030204" pitchFamily="18" charset="0"/>
+                      </a:rPr>
+                      <m:t>𝜋</m:t>
+                    </m:r>
+                  </m:oMath>
+                </a14:m>
+                <a:r>
+                  <a:rPr lang="en-US" dirty="0"/>
+                  <a:t> from </a:t>
+                </a:r>
+                <a14:m>
+                  <m:oMath xmlns:m="http://schemas.openxmlformats.org/officeDocument/2006/math">
+                    <m:r>
+                      <a:rPr lang="en-US" b="0" i="1" smtClean="0">
+                        <a:latin typeface="Cambria Math" panose="02040503050406030204" pitchFamily="18" charset="0"/>
+                      </a:rPr>
+                      <m:t>𝑄</m:t>
+                    </m:r>
+                  </m:oMath>
+                </a14:m>
+                <a:endParaRPr lang="en-US" dirty="0"/>
+              </a:p>
+            </p:txBody>
+          </p:sp>
+        </mc:Choice>
+        <mc:Fallback>
+          <p:sp>
+            <p:nvSpPr>
+              <p:cNvPr id="10" name="TextBox 9">
+                <a:extLst>
+                  <a:ext uri="{FF2B5EF4-FFF2-40B4-BE49-F238E27FC236}">
+                    <a16:creationId xmlns:a16="http://schemas.microsoft.com/office/drawing/2014/main" id="{DE3D2834-B3E4-7166-3E08-4203F3346418}"/>
+                  </a:ext>
+                </a:extLst>
+              </p:cNvPr>
+              <p:cNvSpPr txBox="1">
+                <a:spLocks noRot="1" noChangeAspect="1" noMove="1" noResize="1" noEditPoints="1" noAdjustHandles="1" noChangeArrowheads="1" noChangeShapeType="1" noTextEdit="1"/>
+              </p:cNvSpPr>
+              <p:nvPr/>
+            </p:nvSpPr>
+            <p:spPr>
+              <a:xfrm>
+                <a:off x="3745069" y="6123542"/>
+                <a:ext cx="2009163" cy="369332"/>
+              </a:xfrm>
+              <a:prstGeom prst="rect">
+                <a:avLst/>
+              </a:prstGeom>
+              <a:blipFill>
+                <a:blip r:embed="rId5"/>
+                <a:stretch>
+                  <a:fillRect l="-2102" t="-6349" b="-23810"/>
+                </a:stretch>
+              </a:blipFill>
+            </p:spPr>
+            <p:txBody>
+              <a:bodyPr/>
+              <a:lstStyle/>
+              <a:p>
+                <a:r>
+                  <a:rPr lang="en-US">
+                    <a:noFill/>
+                  </a:rPr>
+                  <a:t> </a:t>
+                </a:r>
+              </a:p>
+            </p:txBody>
+          </p:sp>
+        </mc:Fallback>
+      </mc:AlternateContent>
     </p:spTree>
     <p:extLst>
       <p:ext uri="{BB962C8B-B14F-4D97-AF65-F5344CB8AC3E}">
@@ -9288,8 +9588,8 @@
           </a:p>
         </p:txBody>
       </p:sp>
-      <mc:AlternateContent xmlns:mc="http://schemas.openxmlformats.org/markup-compatibility/2006" xmlns:a14="http://schemas.microsoft.com/office/drawing/2010/main">
-        <mc:Choice Requires="a14">
+      <mc:AlternateContent xmlns:mc="http://schemas.openxmlformats.org/markup-compatibility/2006">
+        <mc:Choice xmlns:a14="http://schemas.microsoft.com/office/drawing/2010/main" Requires="a14">
           <p:sp>
             <p:nvSpPr>
               <p:cNvPr id="3" name="Content Placeholder 2">
@@ -9308,7 +9608,7 @@
             </p:nvSpPr>
             <p:spPr>
               <a:xfrm>
-                <a:off x="838200" y="1173965"/>
+                <a:off x="838200" y="1422856"/>
                 <a:ext cx="10515600" cy="4012288"/>
               </a:xfrm>
             </p:spPr>
@@ -9842,7 +10142,7 @@
             </p:txBody>
           </p:sp>
         </mc:Choice>
-        <mc:Fallback xmlns="">
+        <mc:Fallback>
           <p:sp>
             <p:nvSpPr>
               <p:cNvPr id="3" name="Content Placeholder 2">
@@ -9861,13 +10161,13 @@
             </p:nvSpPr>
             <p:spPr>
               <a:xfrm>
-                <a:off x="838200" y="1173965"/>
+                <a:off x="838200" y="1422856"/>
                 <a:ext cx="10515600" cy="4012288"/>
               </a:xfrm>
               <a:blipFill>
                 <a:blip r:embed="rId2"/>
                 <a:stretch>
-                  <a:fillRect l="-696" t="-3040"/>
+                  <a:fillRect l="-696" t="-2883"/>
                 </a:stretch>
               </a:blipFill>
             </p:spPr>
@@ -10252,7 +10552,7 @@
         </p:style>
         <p:txBody>
           <a:bodyPr vert="horz" lIns="91440" tIns="45720" rIns="91440" bIns="45720" rtlCol="0">
-            <a:normAutofit/>
+            <a:normAutofit fontScale="92500"/>
           </a:bodyPr>
           <a:lstStyle>
             <a:lvl1pPr marL="228600" indent="-228600" algn="l" defTabSz="914400" rtl="0" eaLnBrk="1" latinLnBrk="0" hangingPunct="1">
@@ -10436,7 +10736,7 @@
                   <a:schemeClr val="bg1"/>
                 </a:solidFill>
               </a:rPr>
-              <a:t>: All TD methods have a similar bias, and double learning extensions for these algorithms also exist.</a:t>
+              <a:t>: Many TD methods have a similar bias, and double learning extensions for these algorithms also exist.</a:t>
             </a:r>
           </a:p>
         </p:txBody>
@@ -10988,8 +11288,8 @@
           </a:p>
         </p:txBody>
       </p:sp>
-      <mc:AlternateContent xmlns:mc="http://schemas.openxmlformats.org/markup-compatibility/2006" xmlns:a14="http://schemas.microsoft.com/office/drawing/2010/main">
-        <mc:Choice Requires="a14">
+      <mc:AlternateContent xmlns:mc="http://schemas.openxmlformats.org/markup-compatibility/2006">
+        <mc:Choice xmlns:a14="http://schemas.microsoft.com/office/drawing/2010/main" Requires="a14">
           <p:sp>
             <p:nvSpPr>
               <p:cNvPr id="3" name="Content Placeholder 2">
@@ -11009,7 +11309,7 @@
             <p:spPr/>
             <p:txBody>
               <a:bodyPr>
-                <a:normAutofit fontScale="92500" lnSpcReduction="20000"/>
+                <a:normAutofit fontScale="85000" lnSpcReduction="10000"/>
               </a:bodyPr>
               <a:lstStyle/>
               <a:p>
@@ -12009,10 +12309,21 @@
                   <a:t> since it already uses the expectation!</a:t>
                 </a:r>
               </a:p>
+              <a:p>
+                <a:pPr lvl="1">
+                  <a:lnSpc>
+                    <a:spcPct val="100000"/>
+                  </a:lnSpc>
+                </a:pPr>
+                <a:r>
+                  <a:rPr lang="en-US" dirty="0"/>
+                  <a:t>Requires that actions for not affect the next immediate reward.</a:t>
+                </a:r>
+              </a:p>
             </p:txBody>
           </p:sp>
         </mc:Choice>
-        <mc:Fallback xmlns="">
+        <mc:Fallback>
           <p:sp>
             <p:nvSpPr>
               <p:cNvPr id="3" name="Content Placeholder 2">
@@ -12033,7 +12344,7 @@
               <a:blipFill>
                 <a:blip r:embed="rId2"/>
                 <a:stretch>
-                  <a:fillRect l="-928" t="-3189"/>
+                  <a:fillRect l="-812" t="-2296"/>
                 </a:stretch>
               </a:blipFill>
             </p:spPr>
@@ -21368,8 +21679,8 @@
           </a:p>
         </p:txBody>
       </p:sp>
-      <mc:AlternateContent xmlns:mc="http://schemas.openxmlformats.org/markup-compatibility/2006" xmlns:a14="http://schemas.microsoft.com/office/drawing/2010/main">
-        <mc:Choice Requires="a14">
+      <mc:AlternateContent xmlns:mc="http://schemas.openxmlformats.org/markup-compatibility/2006">
+        <mc:Choice xmlns:a14="http://schemas.microsoft.com/office/drawing/2010/main" Requires="a14">
           <p:sp>
             <p:nvSpPr>
               <p:cNvPr id="3" name="Content Placeholder 2">
@@ -21388,45 +21699,20 @@
             </p:nvSpPr>
             <p:spPr>
               <a:xfrm>
-                <a:off x="863121" y="1397329"/>
-                <a:ext cx="7956792" cy="4998782"/>
+                <a:off x="858634" y="1212209"/>
+                <a:ext cx="7956792" cy="5246331"/>
               </a:xfrm>
             </p:spPr>
             <p:txBody>
               <a:bodyPr>
-                <a:normAutofit fontScale="47500" lnSpcReduction="20000"/>
+                <a:normAutofit fontScale="62500" lnSpcReduction="20000"/>
               </a:bodyPr>
               <a:lstStyle/>
               <a:p>
                 <a:r>
                   <a:rPr lang="en-US" dirty="0"/>
-                  <a:t>We will first focus on:</a:t>
+                  <a:t>We will first focus on: On-step, tabular, model-free TD</a:t>
                 </a:r>
-              </a:p>
-              <a:p>
-                <a:pPr lvl="1"/>
-                <a:r>
-                  <a:rPr lang="en-US" dirty="0"/>
-                  <a:t>On-step</a:t>
-                </a:r>
-              </a:p>
-              <a:p>
-                <a:pPr lvl="1"/>
-                <a:r>
-                  <a:rPr lang="en-US" dirty="0"/>
-                  <a:t>Tabular</a:t>
-                </a:r>
-              </a:p>
-              <a:p>
-                <a:pPr lvl="1"/>
-                <a:r>
-                  <a:rPr lang="en-US" dirty="0"/>
-                  <a:t>Model-free TD</a:t>
-                </a:r>
-              </a:p>
-              <a:p>
-                <a:pPr lvl="1"/>
-                <a:endParaRPr lang="en-US" dirty="0"/>
               </a:p>
               <a:p>
                 <a:r>
@@ -21759,8 +22045,12 @@
               </a:p>
               <a:p>
                 <a:r>
+                  <a:rPr lang="en-US" b="1" dirty="0"/>
+                  <a:t>TD error: </a:t>
+                </a:r>
+                <a:r>
                   <a:rPr lang="en-US" dirty="0"/>
-                  <a:t>The error for our current tabular estimates </a:t>
+                  <a:t>The error for our current tabular estimate </a:t>
                 </a:r>
                 <a14:m>
                   <m:oMath xmlns:m="http://schemas.openxmlformats.org/officeDocument/2006/math">
@@ -21774,7 +22064,38 @@
                       <a:rPr lang="en-US" b="0" i="1" smtClean="0">
                         <a:latin typeface="Cambria Math" panose="02040503050406030204" pitchFamily="18" charset="0"/>
                       </a:rPr>
-                      <m:t>(⋅)</m:t>
+                      <m:t>(</m:t>
+                    </m:r>
+                    <m:sSub>
+                      <m:sSubPr>
+                        <m:ctrlPr>
+                          <a:rPr lang="en-US" b="0" i="1" smtClean="0">
+                            <a:latin typeface="Cambria Math" panose="02040503050406030204" pitchFamily="18" charset="0"/>
+                          </a:rPr>
+                        </m:ctrlPr>
+                      </m:sSubPr>
+                      <m:e>
+                        <m:r>
+                          <a:rPr lang="en-US" b="0" i="1" smtClean="0">
+                            <a:latin typeface="Cambria Math" panose="02040503050406030204" pitchFamily="18" charset="0"/>
+                          </a:rPr>
+                          <m:t>𝑆</m:t>
+                        </m:r>
+                      </m:e>
+                      <m:sub>
+                        <m:r>
+                          <a:rPr lang="en-US" b="0" i="1" smtClean="0">
+                            <a:latin typeface="Cambria Math" panose="02040503050406030204" pitchFamily="18" charset="0"/>
+                          </a:rPr>
+                          <m:t>𝑡</m:t>
+                        </m:r>
+                      </m:sub>
+                    </m:sSub>
+                    <m:r>
+                      <a:rPr lang="en-US" b="0" i="1" smtClean="0">
+                        <a:latin typeface="Cambria Math" panose="02040503050406030204" pitchFamily="18" charset="0"/>
+                      </a:rPr>
+                      <m:t>)</m:t>
                     </m:r>
                   </m:oMath>
                 </a14:m>
@@ -21788,49 +22109,7 @@
                 </a:r>
                 <a:r>
                   <a:rPr lang="en-US" dirty="0"/>
-                  <a:t> using the value of the state at time </a:t>
-                </a:r>
-                <a14:m>
-                  <m:oMath xmlns:m="http://schemas.openxmlformats.org/officeDocument/2006/math">
-                    <m:r>
-                      <a:rPr lang="en-US" b="0" i="1" smtClean="0">
-                        <a:latin typeface="Cambria Math" panose="02040503050406030204" pitchFamily="18" charset="0"/>
-                      </a:rPr>
-                      <m:t>𝑡</m:t>
-                    </m:r>
-                  </m:oMath>
-                </a14:m>
-                <a:r>
-                  <a:rPr lang="en-US" dirty="0"/>
-                  <a:t>, the observed immediate reward and next state at time </a:t>
-                </a:r>
-                <a14:m>
-                  <m:oMath xmlns:m="http://schemas.openxmlformats.org/officeDocument/2006/math">
-                    <m:r>
-                      <a:rPr lang="en-US" b="0" i="1" smtClean="0">
-                        <a:latin typeface="Cambria Math" panose="02040503050406030204" pitchFamily="18" charset="0"/>
-                      </a:rPr>
-                      <m:t>𝑡</m:t>
-                    </m:r>
-                    <m:r>
-                      <a:rPr lang="en-US" b="0" i="1" smtClean="0">
-                        <a:latin typeface="Cambria Math" panose="02040503050406030204" pitchFamily="18" charset="0"/>
-                      </a:rPr>
-                      <m:t>+1</m:t>
-                    </m:r>
-                  </m:oMath>
-                </a14:m>
-                <a:r>
-                  <a:rPr lang="en-US" dirty="0"/>
-                  <a:t>. The </a:t>
-                </a:r>
-                <a:r>
-                  <a:rPr lang="en-US" b="1" dirty="0"/>
-                  <a:t>TD error </a:t>
-                </a:r>
-                <a:r>
-                  <a:rPr lang="en-US" dirty="0"/>
-                  <a:t>is defined between two time steps as:   </a:t>
+                  <a:t> using the reward and value of the next:   </a:t>
                 </a:r>
                 <a:br>
                   <a:rPr lang="en-US" i="1" dirty="0">
@@ -22015,9 +22294,9 @@
                 <a:endParaRPr lang="en-US" dirty="0"/>
               </a:p>
               <a:p>
-                <a:endParaRPr lang="en-US" dirty="0"/>
-              </a:p>
-              <a:p>
+                <a:pPr marL="0" indent="0">
+                  <a:buNone/>
+                </a:pPr>
                 <a:endParaRPr lang="en-US" b="1" dirty="0"/>
               </a:p>
               <a:p>
@@ -22435,36 +22714,20 @@
                 </a14:m>
                 <a:r>
                   <a:rPr lang="en-US" dirty="0"/>
-                  <a:t> tuples), but only uses one step instead of a whole episode. This </a:t>
-                </a:r>
-                <a:r>
-                  <a:rPr lang="en-US" b="1" dirty="0"/>
-                  <a:t>reduces variance</a:t>
-                </a:r>
-                <a:r>
-                  <a:rPr lang="en-US" dirty="0"/>
-                  <a:t> caused by model stochasticity.</a:t>
+                  <a:t> tuples), but only uses one step instead of a whole episode. </a:t>
                 </a:r>
               </a:p>
               <a:p>
                 <a:pPr lvl="1"/>
                 <a:r>
                   <a:rPr lang="en-US" dirty="0"/>
-                  <a:t>From DP: calculates the error between two value estimates without waiting for the end of the episode. The result is </a:t>
-                </a:r>
-                <a:r>
-                  <a:rPr lang="en-US" b="1" dirty="0"/>
-                  <a:t>biased</a:t>
-                </a:r>
-                <a:r>
-                  <a:rPr lang="en-US" dirty="0"/>
-                  <a:t> towards the estimate.</a:t>
+                  <a:t>From DP: calculates the error between two value estimates without waiting for the end of the episode. </a:t>
                 </a:r>
               </a:p>
             </p:txBody>
           </p:sp>
         </mc:Choice>
-        <mc:Fallback xmlns="">
+        <mc:Fallback>
           <p:sp>
             <p:nvSpPr>
               <p:cNvPr id="3" name="Content Placeholder 2">
@@ -22483,13 +22746,13 @@
             </p:nvSpPr>
             <p:spPr>
               <a:xfrm>
-                <a:off x="863121" y="1397329"/>
-                <a:ext cx="7956792" cy="4998782"/>
+                <a:off x="858634" y="1212209"/>
+                <a:ext cx="7956792" cy="5246331"/>
               </a:xfrm>
               <a:blipFill>
                 <a:blip r:embed="rId3"/>
                 <a:stretch>
-                  <a:fillRect l="-77" t="-976"/>
+                  <a:fillRect l="-536" t="-1860" r="-613"/>
                 </a:stretch>
               </a:blipFill>
             </p:spPr>
@@ -23290,7 +23553,7 @@
         </p:nvGrpSpPr>
         <p:grpSpPr>
           <a:xfrm>
-            <a:off x="8939261" y="5635841"/>
+            <a:off x="9114171" y="5280870"/>
             <a:ext cx="2337445" cy="588315"/>
             <a:chOff x="8819913" y="5280870"/>
             <a:chExt cx="2337445" cy="588315"/>
@@ -23390,13 +23653,13 @@
         </p:nvSpPr>
         <p:spPr>
           <a:xfrm>
-            <a:off x="9127986" y="3892277"/>
-            <a:ext cx="2345128" cy="771993"/>
+            <a:off x="9114171" y="3747023"/>
+            <a:ext cx="2658546" cy="771993"/>
           </a:xfrm>
           <a:prstGeom prst="wedgeRoundRectCallout">
             <a:avLst>
-              <a:gd name="adj1" fmla="val -187123"/>
-              <a:gd name="adj2" fmla="val -27792"/>
+              <a:gd name="adj1" fmla="val -155885"/>
+              <a:gd name="adj2" fmla="val -81581"/>
               <a:gd name="adj3" fmla="val 16667"/>
             </a:avLst>
           </a:prstGeom>
@@ -23436,7 +23699,7 @@
             </a:r>
             <a:r>
               <a:rPr lang="en-US" sz="1200" dirty="0"/>
-              <a:t> from the error distribution because we ignore the expectation!</a:t>
+              <a:t> from the error distribution because we use an observed step and  ignore the expectation!</a:t>
             </a:r>
           </a:p>
         </p:txBody>
@@ -23455,10 +23718,10 @@
         </p:nvGrpSpPr>
         <p:grpSpPr>
           <a:xfrm>
-            <a:off x="3746613" y="4118177"/>
-            <a:ext cx="1829849" cy="341088"/>
-            <a:chOff x="3727857" y="3944679"/>
-            <a:chExt cx="1829849" cy="341088"/>
+            <a:off x="3665988" y="3556145"/>
+            <a:ext cx="2661288" cy="354689"/>
+            <a:chOff x="3973001" y="3944679"/>
+            <a:chExt cx="1829849" cy="354689"/>
           </a:xfrm>
         </p:grpSpPr>
         <p:sp>
@@ -23505,8 +23768,8 @@
             </a:p>
           </p:txBody>
         </p:sp>
-        <mc:AlternateContent xmlns:mc="http://schemas.openxmlformats.org/markup-compatibility/2006" xmlns:a14="http://schemas.microsoft.com/office/drawing/2010/main">
-          <mc:Choice Requires="a14">
+        <mc:AlternateContent xmlns:mc="http://schemas.openxmlformats.org/markup-compatibility/2006">
+          <mc:Choice xmlns:a14="http://schemas.microsoft.com/office/drawing/2010/main" Requires="a14">
             <p:sp>
               <p:nvSpPr>
                 <p:cNvPr id="20" name="TextBox 19">
@@ -23521,7 +23784,7 @@
               </p:nvSpPr>
               <p:spPr>
                 <a:xfrm>
-                  <a:off x="3727857" y="4008768"/>
+                  <a:off x="3973001" y="4022369"/>
                   <a:ext cx="1829849" cy="276999"/>
                 </a:xfrm>
                 <a:prstGeom prst="rect">
@@ -23578,7 +23841,7 @@
               </p:txBody>
             </p:sp>
           </mc:Choice>
-          <mc:Fallback xmlns="">
+          <mc:Fallback>
             <p:sp>
               <p:nvSpPr>
                 <p:cNvPr id="20" name="TextBox 19">
@@ -23595,7 +23858,7 @@
               </p:nvSpPr>
               <p:spPr>
                 <a:xfrm>
-                  <a:off x="3727857" y="4008768"/>
+                  <a:off x="3973001" y="4022369"/>
                   <a:ext cx="1829849" cy="276999"/>
                 </a:xfrm>
                 <a:prstGeom prst="rect">
@@ -23604,7 +23867,7 @@
                 <a:blipFill>
                   <a:blip r:embed="rId9"/>
                   <a:stretch>
-                    <a:fillRect l="-333" t="-2222" b="-17778"/>
+                    <a:fillRect b="-15217"/>
                   </a:stretch>
                 </a:blipFill>
               </p:spPr>
@@ -23685,15 +23948,33 @@
                                   </p:childTnLst>
                                 </p:cTn>
                               </p:par>
+                            </p:childTnLst>
+                          </p:cTn>
+                        </p:par>
+                      </p:childTnLst>
+                    </p:cTn>
+                  </p:par>
+                  <p:par>
+                    <p:cTn id="7" fill="hold">
+                      <p:stCondLst>
+                        <p:cond delay="indefinite"/>
+                      </p:stCondLst>
+                      <p:childTnLst>
+                        <p:par>
+                          <p:cTn id="8" fill="hold">
+                            <p:stCondLst>
+                              <p:cond delay="0"/>
+                            </p:stCondLst>
+                            <p:childTnLst>
                               <p:par>
-                                <p:cTn id="7" presetID="1" presetClass="entr" presetSubtype="0" fill="hold" grpId="0" nodeType="withEffect">
+                                <p:cTn id="9" presetID="1" presetClass="entr" presetSubtype="0" fill="hold" grpId="0" nodeType="clickEffect">
                                   <p:stCondLst>
                                     <p:cond delay="0"/>
                                   </p:stCondLst>
                                   <p:childTnLst>
                                     <p:set>
                                       <p:cBhvr>
-                                        <p:cTn id="8" dur="1" fill="hold">
+                                        <p:cTn id="10" dur="1" fill="hold">
                                           <p:stCondLst>
                                             <p:cond delay="0"/>
                                           </p:stCondLst>
@@ -23716,46 +23997,33 @@
                                   </p:childTnLst>
                                 </p:cTn>
                               </p:par>
+                            </p:childTnLst>
+                          </p:cTn>
+                        </p:par>
+                      </p:childTnLst>
+                    </p:cTn>
+                  </p:par>
+                  <p:par>
+                    <p:cTn id="11" fill="hold">
+                      <p:stCondLst>
+                        <p:cond delay="indefinite"/>
+                      </p:stCondLst>
+                      <p:childTnLst>
+                        <p:par>
+                          <p:cTn id="12" fill="hold">
+                            <p:stCondLst>
+                              <p:cond delay="0"/>
+                            </p:stCondLst>
+                            <p:childTnLst>
                               <p:par>
-                                <p:cTn id="9" presetID="1" presetClass="entr" presetSubtype="0" fill="hold" grpId="0" nodeType="withEffect">
+                                <p:cTn id="13" presetID="1" presetClass="entr" presetSubtype="0" fill="hold" grpId="0" nodeType="clickEffect">
                                   <p:stCondLst>
                                     <p:cond delay="0"/>
                                   </p:stCondLst>
                                   <p:childTnLst>
                                     <p:set>
                                       <p:cBhvr>
-                                        <p:cTn id="10" dur="1" fill="hold">
-                                          <p:stCondLst>
-                                            <p:cond delay="0"/>
-                                          </p:stCondLst>
-                                        </p:cTn>
-                                        <p:tgtEl>
-                                          <p:spTgt spid="3">
-                                            <p:txEl>
-                                              <p:pRg st="2" end="2"/>
-                                            </p:txEl>
-                                          </p:spTgt>
-                                        </p:tgtEl>
-                                        <p:attrNameLst>
-                                          <p:attrName>style.visibility</p:attrName>
-                                        </p:attrNameLst>
-                                      </p:cBhvr>
-                                      <p:to>
-                                        <p:strVal val="visible"/>
-                                      </p:to>
-                                    </p:set>
-                                  </p:childTnLst>
-                                </p:cTn>
-                              </p:par>
-                              <p:par>
-                                <p:cTn id="11" presetID="1" presetClass="entr" presetSubtype="0" fill="hold" grpId="0" nodeType="withEffect">
-                                  <p:stCondLst>
-                                    <p:cond delay="0"/>
-                                  </p:stCondLst>
-                                  <p:childTnLst>
-                                    <p:set>
-                                      <p:cBhvr>
-                                        <p:cTn id="12" dur="1" fill="hold">
+                                        <p:cTn id="14" dur="1" fill="hold">
                                           <p:stCondLst>
                                             <p:cond delay="0"/>
                                           </p:stCondLst>
@@ -23785,26 +24053,26 @@
                     </p:cTn>
                   </p:par>
                   <p:par>
-                    <p:cTn id="13" fill="hold">
+                    <p:cTn id="15" fill="hold">
                       <p:stCondLst>
                         <p:cond delay="indefinite"/>
                       </p:stCondLst>
                       <p:childTnLst>
                         <p:par>
-                          <p:cTn id="14" fill="hold">
+                          <p:cTn id="16" fill="hold">
                             <p:stCondLst>
                               <p:cond delay="0"/>
                             </p:stCondLst>
                             <p:childTnLst>
                               <p:par>
-                                <p:cTn id="15" presetID="1" presetClass="entr" presetSubtype="0" fill="hold" grpId="0" nodeType="clickEffect">
+                                <p:cTn id="17" presetID="1" presetClass="entr" presetSubtype="0" fill="hold" grpId="0" nodeType="clickEffect">
                                   <p:stCondLst>
                                     <p:cond delay="0"/>
                                   </p:stCondLst>
                                   <p:childTnLst>
                                     <p:set>
                                       <p:cBhvr>
-                                        <p:cTn id="16" dur="1" fill="hold">
+                                        <p:cTn id="18" dur="1" fill="hold">
                                           <p:stCondLst>
                                             <p:cond delay="0"/>
                                           </p:stCondLst>
@@ -23834,50 +24102,19 @@
                     </p:cTn>
                   </p:par>
                   <p:par>
-                    <p:cTn id="17" fill="hold">
+                    <p:cTn id="19" fill="hold">
                       <p:stCondLst>
                         <p:cond delay="indefinite"/>
                       </p:stCondLst>
                       <p:childTnLst>
                         <p:par>
-                          <p:cTn id="18" fill="hold">
+                          <p:cTn id="20" fill="hold">
                             <p:stCondLst>
                               <p:cond delay="0"/>
                             </p:stCondLst>
                             <p:childTnLst>
                               <p:par>
-                                <p:cTn id="19" presetID="1" presetClass="entr" presetSubtype="0" fill="hold" grpId="0" nodeType="clickEffect">
-                                  <p:stCondLst>
-                                    <p:cond delay="0"/>
-                                  </p:stCondLst>
-                                  <p:childTnLst>
-                                    <p:set>
-                                      <p:cBhvr>
-                                        <p:cTn id="20" dur="1" fill="hold">
-                                          <p:stCondLst>
-                                            <p:cond delay="0"/>
-                                          </p:stCondLst>
-                                        </p:cTn>
-                                        <p:tgtEl>
-                                          <p:spTgt spid="3">
-                                            <p:txEl>
-                                              <p:pRg st="7" end="7"/>
-                                            </p:txEl>
-                                          </p:spTgt>
-                                        </p:tgtEl>
-                                        <p:attrNameLst>
-                                          <p:attrName>style.visibility</p:attrName>
-                                        </p:attrNameLst>
-                                      </p:cBhvr>
-                                      <p:to>
-                                        <p:strVal val="visible"/>
-                                      </p:to>
-                                    </p:set>
-                                  </p:childTnLst>
-                                </p:cTn>
-                              </p:par>
-                              <p:par>
-                                <p:cTn id="21" presetID="1" presetClass="entr" presetSubtype="0" fill="hold" nodeType="withEffect">
+                                <p:cTn id="21" presetID="1" presetClass="entr" presetSubtype="0" fill="hold" grpId="0" nodeType="clickEffect">
                                   <p:stCondLst>
                                     <p:cond delay="0"/>
                                   </p:stCondLst>
@@ -23890,7 +24127,11 @@
                                           </p:stCondLst>
                                         </p:cTn>
                                         <p:tgtEl>
-                                          <p:spTgt spid="21"/>
+                                          <p:spTgt spid="3">
+                                            <p:txEl>
+                                              <p:pRg st="6" end="6"/>
+                                            </p:txEl>
+                                          </p:spTgt>
                                         </p:tgtEl>
                                         <p:attrNameLst>
                                           <p:attrName>style.visibility</p:attrName>
@@ -23935,7 +24176,11 @@
                                           </p:stCondLst>
                                         </p:cTn>
                                         <p:tgtEl>
-                                          <p:spTgt spid="13"/>
+                                          <p:spTgt spid="3">
+                                            <p:txEl>
+                                              <p:pRg st="8" end="8"/>
+                                            </p:txEl>
+                                          </p:spTgt>
                                         </p:tgtEl>
                                         <p:attrNameLst>
                                           <p:attrName>style.visibility</p:attrName>
@@ -23948,26 +24193,39 @@
                                   </p:childTnLst>
                                 </p:cTn>
                               </p:par>
-                            </p:childTnLst>
-                          </p:cTn>
-                        </p:par>
-                      </p:childTnLst>
-                    </p:cTn>
-                  </p:par>
-                  <p:par>
-                    <p:cTn id="27" fill="hold">
-                      <p:stCondLst>
-                        <p:cond delay="indefinite"/>
-                      </p:stCondLst>
-                      <p:childTnLst>
-                        <p:par>
-                          <p:cTn id="28" fill="hold">
-                            <p:stCondLst>
-                              <p:cond delay="0"/>
-                            </p:stCondLst>
-                            <p:childTnLst>
                               <p:par>
-                                <p:cTn id="29" presetID="1" presetClass="entr" presetSubtype="0" fill="hold" grpId="0" nodeType="clickEffect">
+                                <p:cTn id="27" presetID="1" presetClass="entr" presetSubtype="0" fill="hold" grpId="0" nodeType="withEffect">
+                                  <p:stCondLst>
+                                    <p:cond delay="0"/>
+                                  </p:stCondLst>
+                                  <p:childTnLst>
+                                    <p:set>
+                                      <p:cBhvr>
+                                        <p:cTn id="28" dur="1" fill="hold">
+                                          <p:stCondLst>
+                                            <p:cond delay="0"/>
+                                          </p:stCondLst>
+                                        </p:cTn>
+                                        <p:tgtEl>
+                                          <p:spTgt spid="3">
+                                            <p:txEl>
+                                              <p:pRg st="9" end="9"/>
+                                            </p:txEl>
+                                          </p:spTgt>
+                                        </p:tgtEl>
+                                        <p:attrNameLst>
+                                          <p:attrName>style.visibility</p:attrName>
+                                        </p:attrNameLst>
+                                      </p:cBhvr>
+                                      <p:to>
+                                        <p:strVal val="visible"/>
+                                      </p:to>
+                                    </p:set>
+                                  </p:childTnLst>
+                                </p:cTn>
+                              </p:par>
+                              <p:par>
+                                <p:cTn id="29" presetID="1" presetClass="entr" presetSubtype="0" fill="hold" grpId="0" nodeType="withEffect">
                                   <p:stCondLst>
                                     <p:cond delay="0"/>
                                   </p:stCondLst>
@@ -23998,7 +24256,7 @@
                                 </p:cTn>
                               </p:par>
                               <p:par>
-                                <p:cTn id="31" presetID="1" presetClass="entr" presetSubtype="0" fill="hold" grpId="0" nodeType="withEffect">
+                                <p:cTn id="31" presetID="1" presetClass="entr" presetSubtype="0" fill="hold" nodeType="withEffect">
                                   <p:stCondLst>
                                     <p:cond delay="0"/>
                                   </p:stCondLst>
@@ -24011,11 +24269,7 @@
                                           </p:stCondLst>
                                         </p:cTn>
                                         <p:tgtEl>
-                                          <p:spTgt spid="3">
-                                            <p:txEl>
-                                              <p:pRg st="11" end="11"/>
-                                            </p:txEl>
-                                          </p:spTgt>
+                                          <p:spTgt spid="21"/>
                                         </p:tgtEl>
                                         <p:attrNameLst>
                                           <p:attrName>style.visibility</p:attrName>
@@ -24060,11 +24314,7 @@
                                           </p:stCondLst>
                                         </p:cTn>
                                         <p:tgtEl>
-                                          <p:spTgt spid="3">
-                                            <p:txEl>
-                                              <p:pRg st="13" end="13"/>
-                                            </p:txEl>
-                                          </p:spTgt>
+                                          <p:spTgt spid="13"/>
                                         </p:tgtEl>
                                         <p:attrNameLst>
                                           <p:attrName>style.visibility</p:attrName>
@@ -24078,7 +24328,7 @@
                                 </p:cTn>
                               </p:par>
                               <p:par>
-                                <p:cTn id="37" presetID="1" presetClass="entr" presetSubtype="0" fill="hold" grpId="0" nodeType="withEffect">
+                                <p:cTn id="37" presetID="1" presetClass="entr" presetSubtype="0" fill="hold" nodeType="withEffect">
                                   <p:stCondLst>
                                     <p:cond delay="0"/>
                                   </p:stCondLst>
@@ -24086,68 +24336,6 @@
                                     <p:set>
                                       <p:cBhvr>
                                         <p:cTn id="38" dur="1" fill="hold">
-                                          <p:stCondLst>
-                                            <p:cond delay="0"/>
-                                          </p:stCondLst>
-                                        </p:cTn>
-                                        <p:tgtEl>
-                                          <p:spTgt spid="3">
-                                            <p:txEl>
-                                              <p:pRg st="14" end="14"/>
-                                            </p:txEl>
-                                          </p:spTgt>
-                                        </p:tgtEl>
-                                        <p:attrNameLst>
-                                          <p:attrName>style.visibility</p:attrName>
-                                        </p:attrNameLst>
-                                      </p:cBhvr>
-                                      <p:to>
-                                        <p:strVal val="visible"/>
-                                      </p:to>
-                                    </p:set>
-                                  </p:childTnLst>
-                                </p:cTn>
-                              </p:par>
-                              <p:par>
-                                <p:cTn id="39" presetID="1" presetClass="entr" presetSubtype="0" fill="hold" grpId="0" nodeType="withEffect">
-                                  <p:stCondLst>
-                                    <p:cond delay="0"/>
-                                  </p:stCondLst>
-                                  <p:childTnLst>
-                                    <p:set>
-                                      <p:cBhvr>
-                                        <p:cTn id="40" dur="1" fill="hold">
-                                          <p:stCondLst>
-                                            <p:cond delay="0"/>
-                                          </p:stCondLst>
-                                        </p:cTn>
-                                        <p:tgtEl>
-                                          <p:spTgt spid="3">
-                                            <p:txEl>
-                                              <p:pRg st="15" end="15"/>
-                                            </p:txEl>
-                                          </p:spTgt>
-                                        </p:tgtEl>
-                                        <p:attrNameLst>
-                                          <p:attrName>style.visibility</p:attrName>
-                                        </p:attrNameLst>
-                                      </p:cBhvr>
-                                      <p:to>
-                                        <p:strVal val="visible"/>
-                                      </p:to>
-                                    </p:set>
-                                  </p:childTnLst>
-                                </p:cTn>
-                              </p:par>
-                              <p:par>
-                                <p:cTn id="41" presetID="1" presetClass="entr" presetSubtype="0" fill="hold" nodeType="withEffect">
-                                  <p:stCondLst>
-                                    <p:cond delay="0"/>
-                                  </p:stCondLst>
-                                  <p:childTnLst>
-                                    <p:set>
-                                      <p:cBhvr>
-                                        <p:cTn id="42" dur="1" fill="hold">
                                           <p:stCondLst>
                                             <p:cond delay="0"/>
                                           </p:stCondLst>
@@ -24332,8 +24520,8 @@
           </a:p>
         </p:txBody>
       </p:sp>
-      <mc:AlternateContent xmlns:mc="http://schemas.openxmlformats.org/markup-compatibility/2006" xmlns:a14="http://schemas.microsoft.com/office/drawing/2010/main">
-        <mc:Choice Requires="a14">
+      <mc:AlternateContent xmlns:mc="http://schemas.openxmlformats.org/markup-compatibility/2006">
+        <mc:Choice xmlns:a14="http://schemas.microsoft.com/office/drawing/2010/main" Requires="a14">
           <p:sp>
             <p:nvSpPr>
               <p:cNvPr id="3" name="Content Placeholder 2">
@@ -24378,7 +24566,7 @@
                 </a14:m>
                 <a:r>
                   <a:rPr lang="en-US" dirty="0"/>
-                  <a:t> and update tabular estimate </a:t>
+                  <a:t> and update the tabular estimate </a:t>
                 </a:r>
                 <a14:m>
                   <m:oMath xmlns:m="http://schemas.openxmlformats.org/officeDocument/2006/math">
@@ -24707,24 +24895,77 @@
               </a:p>
               <a:p>
                 <a:r>
+                  <a:rPr lang="en-US" b="1" dirty="0"/>
+                  <a:t>Bootstrapping</a:t>
+                </a:r>
+                <a:r>
                   <a:rPr lang="en-US" dirty="0"/>
-                  <a:t>Updating an estimate using another estimate is called </a:t>
+                  <a:t>: Updating an estimate using another estimate. Introduces an </a:t>
                 </a:r>
                 <a:r>
                   <a:rPr lang="en-US" b="1" dirty="0"/>
-                  <a:t>“bootstrapping” </a:t>
+                  <a:t>estimation bias</a:t>
                 </a:r>
                 <a:r>
                   <a:rPr lang="en-US" dirty="0"/>
-                  <a:t>and introduces an </a:t>
+                  <a:t> towards the biased estimate of </a:t>
                 </a:r>
-                <a:r>
-                  <a:rPr lang="en-US" b="1" dirty="0"/>
-                  <a:t>estimation bias </a:t>
-                </a:r>
+                <a14:m>
+                  <m:oMath xmlns:m="http://schemas.openxmlformats.org/officeDocument/2006/math">
+                    <m:r>
+                      <a:rPr lang="en-US" b="0" i="1" smtClean="0">
+                        <a:latin typeface="Cambria Math" panose="02040503050406030204" pitchFamily="18" charset="0"/>
+                      </a:rPr>
+                      <m:t>𝑉</m:t>
+                    </m:r>
+                    <m:r>
+                      <a:rPr lang="en-US" b="0" i="1" smtClean="0">
+                        <a:latin typeface="Cambria Math" panose="02040503050406030204" pitchFamily="18" charset="0"/>
+                      </a:rPr>
+                      <m:t>(</m:t>
+                    </m:r>
+                    <m:sSub>
+                      <m:sSubPr>
+                        <m:ctrlPr>
+                          <a:rPr lang="en-US" b="0" i="1" smtClean="0">
+                            <a:latin typeface="Cambria Math" panose="02040503050406030204" pitchFamily="18" charset="0"/>
+                          </a:rPr>
+                        </m:ctrlPr>
+                      </m:sSubPr>
+                      <m:e>
+                        <m:r>
+                          <a:rPr lang="en-US" b="0" i="1" smtClean="0">
+                            <a:latin typeface="Cambria Math" panose="02040503050406030204" pitchFamily="18" charset="0"/>
+                          </a:rPr>
+                          <m:t>𝑠</m:t>
+                        </m:r>
+                      </m:e>
+                      <m:sub>
+                        <m:r>
+                          <a:rPr lang="en-US" b="0" i="1" smtClean="0">
+                            <a:latin typeface="Cambria Math" panose="02040503050406030204" pitchFamily="18" charset="0"/>
+                          </a:rPr>
+                          <m:t>𝑡</m:t>
+                        </m:r>
+                        <m:r>
+                          <a:rPr lang="en-US" b="0" i="1" smtClean="0">
+                            <a:latin typeface="Cambria Math" panose="02040503050406030204" pitchFamily="18" charset="0"/>
+                          </a:rPr>
+                          <m:t>+1</m:t>
+                        </m:r>
+                      </m:sub>
+                    </m:sSub>
+                    <m:r>
+                      <a:rPr lang="en-US" b="0" i="1" smtClean="0">
+                        <a:latin typeface="Cambria Math" panose="02040503050406030204" pitchFamily="18" charset="0"/>
+                      </a:rPr>
+                      <m:t>)</m:t>
+                    </m:r>
+                  </m:oMath>
+                </a14:m>
                 <a:r>
                   <a:rPr lang="en-US" dirty="0"/>
-                  <a:t>due to error propagation.</a:t>
+                  <a:t>.</a:t>
                 </a:r>
               </a:p>
               <a:p>
@@ -24942,7 +25183,7 @@
             </p:txBody>
           </p:sp>
         </mc:Choice>
-        <mc:Fallback xmlns="">
+        <mc:Fallback>
           <p:sp>
             <p:nvSpPr>
               <p:cNvPr id="3" name="Content Placeholder 2">
@@ -24967,7 +25208,7 @@
               <a:blipFill>
                 <a:blip r:embed="rId2"/>
                 <a:stretch>
-                  <a:fillRect l="-1194" t="-2469" r="-597"/>
+                  <a:fillRect l="-1194" t="-2469"/>
                 </a:stretch>
               </a:blipFill>
             </p:spPr>
@@ -25692,6 +25933,9 @@
                     <p:cTn id="3" fill="hold">
                       <p:stCondLst>
                         <p:cond delay="indefinite"/>
+                        <p:cond evt="onBegin" delay="0">
+                          <p:tn val="2"/>
+                        </p:cond>
                       </p:stCondLst>
                       <p:childTnLst>
                         <p:par>
@@ -25701,7 +25945,7 @@
                             </p:stCondLst>
                             <p:childTnLst>
                               <p:par>
-                                <p:cTn id="5" presetID="1" presetClass="entr" presetSubtype="0" fill="hold" nodeType="clickEffect">
+                                <p:cTn id="5" presetID="1" presetClass="entr" presetSubtype="0" fill="hold" nodeType="withEffect">
                                   <p:stCondLst>
                                     <p:cond delay="0"/>
                                   </p:stCondLst>
@@ -25709,86 +25953,6 @@
                                     <p:set>
                                       <p:cBhvr>
                                         <p:cTn id="6" dur="1" fill="hold">
-                                          <p:stCondLst>
-                                            <p:cond delay="0"/>
-                                          </p:stCondLst>
-                                        </p:cTn>
-                                        <p:tgtEl>
-                                          <p:spTgt spid="3">
-                                            <p:txEl>
-                                              <p:pRg st="5" end="5"/>
-                                            </p:txEl>
-                                          </p:spTgt>
-                                        </p:tgtEl>
-                                        <p:attrNameLst>
-                                          <p:attrName>style.visibility</p:attrName>
-                                        </p:attrNameLst>
-                                      </p:cBhvr>
-                                      <p:to>
-                                        <p:strVal val="visible"/>
-                                      </p:to>
-                                    </p:set>
-                                  </p:childTnLst>
-                                </p:cTn>
-                              </p:par>
-                            </p:childTnLst>
-                          </p:cTn>
-                        </p:par>
-                      </p:childTnLst>
-                    </p:cTn>
-                  </p:par>
-                  <p:par>
-                    <p:cTn id="7" fill="hold">
-                      <p:stCondLst>
-                        <p:cond delay="indefinite"/>
-                      </p:stCondLst>
-                      <p:childTnLst>
-                        <p:par>
-                          <p:cTn id="8" fill="hold">
-                            <p:stCondLst>
-                              <p:cond delay="0"/>
-                            </p:stCondLst>
-                            <p:childTnLst>
-                              <p:par>
-                                <p:cTn id="9" presetID="1" presetClass="entr" presetSubtype="0" fill="hold" nodeType="clickEffect">
-                                  <p:stCondLst>
-                                    <p:cond delay="0"/>
-                                  </p:stCondLst>
-                                  <p:childTnLst>
-                                    <p:set>
-                                      <p:cBhvr>
-                                        <p:cTn id="10" dur="1" fill="hold">
-                                          <p:stCondLst>
-                                            <p:cond delay="0"/>
-                                          </p:stCondLst>
-                                        </p:cTn>
-                                        <p:tgtEl>
-                                          <p:spTgt spid="3">
-                                            <p:txEl>
-                                              <p:pRg st="8" end="8"/>
-                                            </p:txEl>
-                                          </p:spTgt>
-                                        </p:tgtEl>
-                                        <p:attrNameLst>
-                                          <p:attrName>style.visibility</p:attrName>
-                                        </p:attrNameLst>
-                                      </p:cBhvr>
-                                      <p:to>
-                                        <p:strVal val="visible"/>
-                                      </p:to>
-                                    </p:set>
-                                  </p:childTnLst>
-                                </p:cTn>
-                              </p:par>
-                              <p:par>
-                                <p:cTn id="11" presetID="1" presetClass="entr" presetSubtype="0" fill="hold" nodeType="withEffect">
-                                  <p:stCondLst>
-                                    <p:cond delay="0"/>
-                                  </p:stCondLst>
-                                  <p:childTnLst>
-                                    <p:set>
-                                      <p:cBhvr>
-                                        <p:cTn id="12" dur="1" fill="hold">
                                           <p:stCondLst>
                                             <p:cond delay="0"/>
                                           </p:stCondLst>
@@ -25808,14 +25972,14 @@
                                 </p:cTn>
                               </p:par>
                               <p:par>
-                                <p:cTn id="13" presetID="1" presetClass="entr" presetSubtype="0" fill="hold" grpId="0" nodeType="withEffect">
+                                <p:cTn id="7" presetID="1" presetClass="entr" presetSubtype="0" fill="hold" grpId="0" nodeType="withEffect">
                                   <p:stCondLst>
                                     <p:cond delay="0"/>
                                   </p:stCondLst>
                                   <p:childTnLst>
                                     <p:set>
                                       <p:cBhvr>
-                                        <p:cTn id="14" dur="1" fill="hold">
+                                        <p:cTn id="8" dur="1" fill="hold">
                                           <p:stCondLst>
                                             <p:cond delay="0"/>
                                           </p:stCondLst>
@@ -26473,8 +26637,8 @@
           </a:p>
         </p:txBody>
       </p:sp>
-      <mc:AlternateContent xmlns:mc="http://schemas.openxmlformats.org/markup-compatibility/2006" xmlns:a14="http://schemas.microsoft.com/office/drawing/2010/main">
-        <mc:Choice Requires="a14">
+      <mc:AlternateContent xmlns:mc="http://schemas.openxmlformats.org/markup-compatibility/2006">
+        <mc:Choice xmlns:a14="http://schemas.microsoft.com/office/drawing/2010/main" Requires="a14">
           <p:sp>
             <p:nvSpPr>
               <p:cNvPr id="3" name="Content Placeholder 2">
@@ -26491,27 +26655,32 @@
                 <p:ph idx="1"/>
               </p:nvPr>
             </p:nvSpPr>
-            <p:spPr/>
+            <p:spPr>
+              <a:xfrm>
+                <a:off x="838200" y="1288280"/>
+                <a:ext cx="10515600" cy="4779633"/>
+              </a:xfrm>
+            </p:spPr>
             <p:txBody>
               <a:bodyPr>
-                <a:normAutofit fontScale="55000" lnSpcReduction="20000"/>
+                <a:noAutofit/>
               </a:bodyPr>
               <a:lstStyle/>
               <a:p>
                 <a:r>
-                  <a:rPr lang="en-US" dirty="0"/>
+                  <a:rPr lang="en-US" sz="1800" dirty="0"/>
                   <a:t>Regular conditions on the MDP apply (finite, </a:t>
                 </a:r>
                 <a14:m>
                   <m:oMath xmlns:m="http://schemas.openxmlformats.org/officeDocument/2006/math">
                     <m:r>
-                      <a:rPr lang="en-US" b="0" i="1" smtClean="0">
+                      <a:rPr lang="en-US" sz="1800" b="0" i="1" smtClean="0">
                         <a:latin typeface="Cambria Math" panose="02040503050406030204" pitchFamily="18" charset="0"/>
                       </a:rPr>
                       <m:t>𝛾</m:t>
                     </m:r>
                     <m:r>
-                      <a:rPr lang="en-US" b="0" i="1" smtClean="0">
+                      <a:rPr lang="en-US" sz="1800" b="0" i="1" smtClean="0">
                         <a:latin typeface="Cambria Math" panose="02040503050406030204" pitchFamily="18" charset="0"/>
                       </a:rPr>
                       <m:t>&lt;1</m:t>
@@ -26519,13 +26688,13 @@
                   </m:oMath>
                 </a14:m>
                 <a:r>
-                  <a:rPr lang="en-US" dirty="0"/>
+                  <a:rPr lang="en-US" sz="1800" dirty="0"/>
                   <a:t>, etc.)</a:t>
                 </a:r>
               </a:p>
               <a:p>
                 <a:r>
-                  <a:rPr lang="en-US" dirty="0"/>
+                  <a:rPr lang="en-US" sz="1800" dirty="0"/>
                   <a:t>The observed TD error </a:t>
                 </a:r>
                 <a14:m>
@@ -26533,14 +26702,14 @@
                     <m:sSub>
                       <m:sSubPr>
                         <m:ctrlPr>
-                          <a:rPr lang="en-US" i="1">
+                          <a:rPr lang="en-US" sz="1800" i="1">
                             <a:latin typeface="Cambria Math" panose="02040503050406030204" pitchFamily="18" charset="0"/>
                           </a:rPr>
                         </m:ctrlPr>
                       </m:sSubPr>
                       <m:e>
                         <m:r>
-                          <a:rPr lang="en-US" i="1">
+                          <a:rPr lang="en-US" sz="1800" i="1">
                             <a:latin typeface="Cambria Math" panose="02040503050406030204" pitchFamily="18" charset="0"/>
                           </a:rPr>
                           <m:t>𝛿</m:t>
@@ -26548,7 +26717,7 @@
                       </m:e>
                       <m:sub>
                         <m:r>
-                          <a:rPr lang="en-US" i="1">
+                          <a:rPr lang="en-US" sz="1800" i="1">
                             <a:latin typeface="Cambria Math" panose="02040503050406030204" pitchFamily="18" charset="0"/>
                           </a:rPr>
                           <m:t>𝑡</m:t>
@@ -26556,7 +26725,7 @@
                       </m:sub>
                     </m:sSub>
                     <m:r>
-                      <a:rPr lang="en-US" i="1">
+                      <a:rPr lang="en-US" sz="1800" i="1">
                         <a:latin typeface="Cambria Math" panose="02040503050406030204" pitchFamily="18" charset="0"/>
                       </a:rPr>
                       <m:t>=</m:t>
@@ -26564,14 +26733,14 @@
                     <m:sSub>
                       <m:sSubPr>
                         <m:ctrlPr>
-                          <a:rPr lang="en-US" i="1">
+                          <a:rPr lang="en-US" sz="1800" i="1">
                             <a:latin typeface="Cambria Math" panose="02040503050406030204" pitchFamily="18" charset="0"/>
                           </a:rPr>
                         </m:ctrlPr>
                       </m:sSubPr>
                       <m:e>
                         <m:r>
-                          <a:rPr lang="en-US" i="1">
+                          <a:rPr lang="en-US" sz="1800" i="1">
                             <a:latin typeface="Cambria Math" panose="02040503050406030204" pitchFamily="18" charset="0"/>
                           </a:rPr>
                           <m:t>𝑅</m:t>
@@ -26579,13 +26748,13 @@
                       </m:e>
                       <m:sub>
                         <m:r>
-                          <a:rPr lang="en-US" i="1">
+                          <a:rPr lang="en-US" sz="1800" i="1">
                             <a:latin typeface="Cambria Math" panose="02040503050406030204" pitchFamily="18" charset="0"/>
                           </a:rPr>
                           <m:t>𝑡</m:t>
                         </m:r>
                         <m:r>
-                          <a:rPr lang="en-US" i="1">
+                          <a:rPr lang="en-US" sz="1800" i="1">
                             <a:latin typeface="Cambria Math" panose="02040503050406030204" pitchFamily="18" charset="0"/>
                           </a:rPr>
                           <m:t>+1</m:t>
@@ -26593,19 +26762,19 @@
                       </m:sub>
                     </m:sSub>
                     <m:r>
-                      <a:rPr lang="en-US" i="1">
+                      <a:rPr lang="en-US" sz="1800" i="1">
                         <a:latin typeface="Cambria Math" panose="02040503050406030204" pitchFamily="18" charset="0"/>
                       </a:rPr>
                       <m:t>+</m:t>
                     </m:r>
                     <m:r>
-                      <a:rPr lang="en-US" i="1">
+                      <a:rPr lang="en-US" sz="1800" i="1">
                         <a:latin typeface="Cambria Math" panose="02040503050406030204" pitchFamily="18" charset="0"/>
                       </a:rPr>
                       <m:t>𝛾</m:t>
                     </m:r>
                     <m:r>
-                      <a:rPr lang="en-US" i="1">
+                      <a:rPr lang="en-US" sz="1800" i="1">
                         <a:latin typeface="Cambria Math" panose="02040503050406030204" pitchFamily="18" charset="0"/>
                       </a:rPr>
                       <m:t>𝑉</m:t>
@@ -26613,7 +26782,7 @@
                     <m:d>
                       <m:dPr>
                         <m:ctrlPr>
-                          <a:rPr lang="en-US" i="1">
+                          <a:rPr lang="en-US" sz="1800" i="1">
                             <a:latin typeface="Cambria Math" panose="02040503050406030204" pitchFamily="18" charset="0"/>
                           </a:rPr>
                         </m:ctrlPr>
@@ -26622,14 +26791,14 @@
                         <m:sSub>
                           <m:sSubPr>
                             <m:ctrlPr>
-                              <a:rPr lang="en-US" i="1">
+                              <a:rPr lang="en-US" sz="1800" i="1">
                                 <a:latin typeface="Cambria Math" panose="02040503050406030204" pitchFamily="18" charset="0"/>
                               </a:rPr>
                             </m:ctrlPr>
                           </m:sSubPr>
                           <m:e>
                             <m:r>
-                              <a:rPr lang="en-US" i="1">
+                              <a:rPr lang="en-US" sz="1800" i="1">
                                 <a:latin typeface="Cambria Math" panose="02040503050406030204" pitchFamily="18" charset="0"/>
                               </a:rPr>
                               <m:t>𝑆</m:t>
@@ -26637,13 +26806,13 @@
                           </m:e>
                           <m:sub>
                             <m:r>
-                              <a:rPr lang="en-US" i="1">
+                              <a:rPr lang="en-US" sz="1800" i="1">
                                 <a:latin typeface="Cambria Math" panose="02040503050406030204" pitchFamily="18" charset="0"/>
                               </a:rPr>
                               <m:t>𝑡</m:t>
                             </m:r>
                             <m:r>
-                              <a:rPr lang="en-US" i="1">
+                              <a:rPr lang="en-US" sz="1800" i="1">
                                 <a:latin typeface="Cambria Math" panose="02040503050406030204" pitchFamily="18" charset="0"/>
                               </a:rPr>
                               <m:t>+1</m:t>
@@ -26653,13 +26822,13 @@
                       </m:e>
                     </m:d>
                     <m:r>
-                      <a:rPr lang="en-US" i="1">
+                      <a:rPr lang="en-US" sz="1800" i="1">
                         <a:latin typeface="Cambria Math" panose="02040503050406030204" pitchFamily="18" charset="0"/>
                       </a:rPr>
                       <m:t>−</m:t>
                     </m:r>
                     <m:r>
-                      <a:rPr lang="en-US" i="1">
+                      <a:rPr lang="en-US" sz="1800" i="1">
                         <a:latin typeface="Cambria Math" panose="02040503050406030204" pitchFamily="18" charset="0"/>
                       </a:rPr>
                       <m:t>𝑉</m:t>
@@ -26667,7 +26836,7 @@
                     <m:d>
                       <m:dPr>
                         <m:ctrlPr>
-                          <a:rPr lang="en-US" i="1">
+                          <a:rPr lang="en-US" sz="1800" i="1">
                             <a:latin typeface="Cambria Math" panose="02040503050406030204" pitchFamily="18" charset="0"/>
                           </a:rPr>
                         </m:ctrlPr>
@@ -26676,14 +26845,14 @@
                         <m:sSub>
                           <m:sSubPr>
                             <m:ctrlPr>
-                              <a:rPr lang="en-US" i="1">
+                              <a:rPr lang="en-US" sz="1800" i="1">
                                 <a:latin typeface="Cambria Math" panose="02040503050406030204" pitchFamily="18" charset="0"/>
                               </a:rPr>
                             </m:ctrlPr>
                           </m:sSubPr>
                           <m:e>
                             <m:r>
-                              <a:rPr lang="en-US" i="1">
+                              <a:rPr lang="en-US" sz="1800" i="1">
                                 <a:latin typeface="Cambria Math" panose="02040503050406030204" pitchFamily="18" charset="0"/>
                               </a:rPr>
                               <m:t>𝑆</m:t>
@@ -26691,7 +26860,7 @@
                           </m:e>
                           <m:sub>
                             <m:r>
-                              <a:rPr lang="en-US" i="1">
+                              <a:rPr lang="en-US" sz="1800" i="1">
                                 <a:latin typeface="Cambria Math" panose="02040503050406030204" pitchFamily="18" charset="0"/>
                               </a:rPr>
                               <m:t>𝑡</m:t>
@@ -26703,34 +26872,31 @@
                   </m:oMath>
                 </a14:m>
                 <a:r>
-                  <a:rPr lang="en-US" dirty="0"/>
+                  <a:rPr lang="en-US" sz="1800" dirty="0"/>
                   <a:t> is a noisy sample of the true difference.</a:t>
                 </a:r>
                 <a:br>
-                  <a:rPr lang="en-US" dirty="0"/>
+                  <a:rPr lang="en-US" sz="1800" dirty="0"/>
                 </a:br>
-                <a:br>
-                  <a:rPr lang="en-US" dirty="0"/>
-                </a:br>
-                <a:endParaRPr lang="en-US" dirty="0"/>
+                <a:endParaRPr lang="en-US" sz="1800" dirty="0"/>
               </a:p>
               <a:p>
                 <a:r>
-                  <a:rPr lang="en-US" b="1" dirty="0"/>
+                  <a:rPr lang="en-US" sz="1800" b="1" dirty="0"/>
                   <a:t>Convergence</a:t>
                 </a:r>
                 <a:r>
-                  <a:rPr lang="en-US" dirty="0"/>
+                  <a:rPr lang="en-US" sz="1800" dirty="0"/>
                   <a:t>: Stochastic approximation theory guarantees convergence if the </a:t>
                 </a:r>
                 <a:r>
-                  <a:rPr lang="en-US" b="1" dirty="0"/>
+                  <a:rPr lang="en-US" sz="1800" b="1" dirty="0"/>
                   <a:t>learning rate </a:t>
                 </a:r>
                 <a14:m>
                   <m:oMath xmlns:m="http://schemas.openxmlformats.org/officeDocument/2006/math">
                     <m:r>
-                      <a:rPr lang="en-US" b="1" i="1" smtClean="0">
+                      <a:rPr lang="en-US" sz="1800" b="1" i="1" smtClean="0">
                         <a:latin typeface="Cambria Math" panose="02040503050406030204" pitchFamily="18" charset="0"/>
                       </a:rPr>
                       <m:t>𝜶</m:t>
@@ -26738,23 +26904,23 @@
                   </m:oMath>
                 </a14:m>
                 <a:r>
-                  <a:rPr lang="en-US" b="1" dirty="0"/>
+                  <a:rPr lang="en-US" sz="1800" b="1" dirty="0"/>
                   <a:t> decreases slowly enough. </a:t>
                 </a:r>
                 <a:r>
-                  <a:rPr lang="en-US" dirty="0"/>
+                  <a:rPr lang="en-US" sz="1800" dirty="0"/>
                   <a:t>Then the updates</a:t>
                 </a:r>
                 <a:br>
-                  <a:rPr lang="en-US" dirty="0"/>
+                  <a:rPr lang="en-US" sz="1800" dirty="0"/>
                 </a:br>
                 <a:br>
-                  <a:rPr lang="en-US" dirty="0"/>
+                  <a:rPr lang="en-US" sz="1800" dirty="0"/>
                 </a:br>
                 <a14:m>
                   <m:oMath xmlns:m="http://schemas.openxmlformats.org/officeDocument/2006/math">
                     <m:r>
-                      <a:rPr lang="en-US" i="1">
+                      <a:rPr lang="en-US" sz="1800" i="1">
                         <a:latin typeface="Cambria Math" panose="02040503050406030204" pitchFamily="18" charset="0"/>
                       </a:rPr>
                       <m:t>𝑉</m:t>
@@ -26762,7 +26928,7 @@
                     <m:d>
                       <m:dPr>
                         <m:ctrlPr>
-                          <a:rPr lang="en-US" i="1">
+                          <a:rPr lang="en-US" sz="1800" i="1">
                             <a:latin typeface="Cambria Math" panose="02040503050406030204" pitchFamily="18" charset="0"/>
                           </a:rPr>
                         </m:ctrlPr>
@@ -26771,14 +26937,14 @@
                         <m:sSub>
                           <m:sSubPr>
                             <m:ctrlPr>
-                              <a:rPr lang="en-US" i="1">
+                              <a:rPr lang="en-US" sz="1800" i="1">
                                 <a:latin typeface="Cambria Math" panose="02040503050406030204" pitchFamily="18" charset="0"/>
                               </a:rPr>
                             </m:ctrlPr>
                           </m:sSubPr>
                           <m:e>
                             <m:r>
-                              <a:rPr lang="en-US" i="1">
+                              <a:rPr lang="en-US" sz="1800" i="1">
                                 <a:latin typeface="Cambria Math" panose="02040503050406030204" pitchFamily="18" charset="0"/>
                               </a:rPr>
                               <m:t>𝑆</m:t>
@@ -26786,7 +26952,7 @@
                           </m:e>
                           <m:sub>
                             <m:r>
-                              <a:rPr lang="en-US" i="1">
+                              <a:rPr lang="en-US" sz="1800" i="1">
                                 <a:latin typeface="Cambria Math" panose="02040503050406030204" pitchFamily="18" charset="0"/>
                               </a:rPr>
                               <m:t>𝑡</m:t>
@@ -26801,7 +26967,7 @@
                         <m:pos m:val="top"/>
                         <m:vertJc m:val="top"/>
                         <m:ctrlPr>
-                          <a:rPr lang="en-US" i="1">
+                          <a:rPr lang="en-US" sz="1800" i="1">
                             <a:latin typeface="Cambria Math" panose="02040503050406030204" pitchFamily="18" charset="0"/>
                           </a:rPr>
                         </m:ctrlPr>
@@ -26809,7 +26975,7 @@
                       <m:e/>
                     </m:groupChr>
                     <m:r>
-                      <a:rPr lang="en-US" i="1">
+                      <a:rPr lang="en-US" sz="1800" i="1">
                         <a:latin typeface="Cambria Math" panose="02040503050406030204" pitchFamily="18" charset="0"/>
                       </a:rPr>
                       <m:t>𝑉</m:t>
@@ -26817,7 +26983,7 @@
                     <m:d>
                       <m:dPr>
                         <m:ctrlPr>
-                          <a:rPr lang="en-US" i="1">
+                          <a:rPr lang="en-US" sz="1800" i="1">
                             <a:latin typeface="Cambria Math" panose="02040503050406030204" pitchFamily="18" charset="0"/>
                           </a:rPr>
                         </m:ctrlPr>
@@ -26826,14 +26992,14 @@
                         <m:sSub>
                           <m:sSubPr>
                             <m:ctrlPr>
-                              <a:rPr lang="en-US" i="1">
+                              <a:rPr lang="en-US" sz="1800" i="1">
                                 <a:latin typeface="Cambria Math" panose="02040503050406030204" pitchFamily="18" charset="0"/>
                               </a:rPr>
                             </m:ctrlPr>
                           </m:sSubPr>
                           <m:e>
                             <m:r>
-                              <a:rPr lang="en-US" i="1">
+                              <a:rPr lang="en-US" sz="1800" i="1">
                                 <a:latin typeface="Cambria Math" panose="02040503050406030204" pitchFamily="18" charset="0"/>
                               </a:rPr>
                               <m:t>𝑆</m:t>
@@ -26841,7 +27007,7 @@
                           </m:e>
                           <m:sub>
                             <m:r>
-                              <a:rPr lang="en-US" i="1">
+                              <a:rPr lang="en-US" sz="1800" i="1">
                                 <a:latin typeface="Cambria Math" panose="02040503050406030204" pitchFamily="18" charset="0"/>
                               </a:rPr>
                               <m:t>𝑡</m:t>
@@ -26851,13 +27017,13 @@
                       </m:e>
                     </m:d>
                     <m:r>
-                      <a:rPr lang="en-US">
+                      <a:rPr lang="en-US" sz="1800">
                         <a:latin typeface="Cambria Math" panose="02040503050406030204" pitchFamily="18" charset="0"/>
                       </a:rPr>
                       <m:t>+</m:t>
                     </m:r>
                     <m:r>
-                      <a:rPr lang="en-US" i="1">
+                      <a:rPr lang="en-US" sz="1800" i="1">
                         <a:latin typeface="Cambria Math" panose="02040503050406030204" pitchFamily="18" charset="0"/>
                       </a:rPr>
                       <m:t>𝛼</m:t>
@@ -26867,7 +27033,7 @@
                         <m:begChr m:val="["/>
                         <m:endChr m:val="]"/>
                         <m:ctrlPr>
-                          <a:rPr lang="en-US" i="1">
+                          <a:rPr lang="en-US" sz="1800" i="1">
                             <a:latin typeface="Cambria Math" panose="02040503050406030204" pitchFamily="18" charset="0"/>
                           </a:rPr>
                         </m:ctrlPr>
@@ -26876,14 +27042,14 @@
                         <m:sSub>
                           <m:sSubPr>
                             <m:ctrlPr>
-                              <a:rPr lang="en-US" i="1">
+                              <a:rPr lang="en-US" sz="1800" i="1">
                                 <a:latin typeface="Cambria Math" panose="02040503050406030204" pitchFamily="18" charset="0"/>
                               </a:rPr>
                             </m:ctrlPr>
                           </m:sSubPr>
                           <m:e>
                             <m:r>
-                              <a:rPr lang="en-US" i="1">
+                              <a:rPr lang="en-US" sz="1800" i="1">
                                 <a:latin typeface="Cambria Math" panose="02040503050406030204" pitchFamily="18" charset="0"/>
                               </a:rPr>
                               <m:t>𝑅</m:t>
@@ -26891,13 +27057,13 @@
                           </m:e>
                           <m:sub>
                             <m:r>
-                              <a:rPr lang="en-US" i="1">
+                              <a:rPr lang="en-US" sz="1800" i="1">
                                 <a:latin typeface="Cambria Math" panose="02040503050406030204" pitchFamily="18" charset="0"/>
                               </a:rPr>
                               <m:t>𝑡</m:t>
                             </m:r>
                             <m:r>
-                              <a:rPr lang="en-US" i="1">
+                              <a:rPr lang="en-US" sz="1800" i="1">
                                 <a:latin typeface="Cambria Math" panose="02040503050406030204" pitchFamily="18" charset="0"/>
                               </a:rPr>
                               <m:t>+1</m:t>
@@ -26905,19 +27071,19 @@
                           </m:sub>
                         </m:sSub>
                         <m:r>
-                          <a:rPr lang="en-US" i="1">
+                          <a:rPr lang="en-US" sz="1800" i="1">
                             <a:latin typeface="Cambria Math" panose="02040503050406030204" pitchFamily="18" charset="0"/>
                           </a:rPr>
                           <m:t>+</m:t>
                         </m:r>
                         <m:r>
-                          <a:rPr lang="en-US" i="1">
+                          <a:rPr lang="en-US" sz="1800" i="1">
                             <a:latin typeface="Cambria Math" panose="02040503050406030204" pitchFamily="18" charset="0"/>
                           </a:rPr>
                           <m:t>𝛾</m:t>
                         </m:r>
                         <m:r>
-                          <a:rPr lang="en-US" i="1">
+                          <a:rPr lang="en-US" sz="1800" i="1">
                             <a:latin typeface="Cambria Math" panose="02040503050406030204" pitchFamily="18" charset="0"/>
                           </a:rPr>
                           <m:t>𝑉</m:t>
@@ -26925,7 +27091,7 @@
                         <m:d>
                           <m:dPr>
                             <m:ctrlPr>
-                              <a:rPr lang="en-US" i="1">
+                              <a:rPr lang="en-US" sz="1800" i="1">
                                 <a:latin typeface="Cambria Math" panose="02040503050406030204" pitchFamily="18" charset="0"/>
                               </a:rPr>
                             </m:ctrlPr>
@@ -26934,14 +27100,14 @@
                             <m:sSub>
                               <m:sSubPr>
                                 <m:ctrlPr>
-                                  <a:rPr lang="en-US" i="1">
+                                  <a:rPr lang="en-US" sz="1800" i="1">
                                     <a:latin typeface="Cambria Math" panose="02040503050406030204" pitchFamily="18" charset="0"/>
                                   </a:rPr>
                                 </m:ctrlPr>
                               </m:sSubPr>
                               <m:e>
                                 <m:r>
-                                  <a:rPr lang="en-US" i="1">
+                                  <a:rPr lang="en-US" sz="1800" i="1">
                                     <a:latin typeface="Cambria Math" panose="02040503050406030204" pitchFamily="18" charset="0"/>
                                   </a:rPr>
                                   <m:t>𝑆</m:t>
@@ -26949,13 +27115,13 @@
                               </m:e>
                               <m:sub>
                                 <m:r>
-                                  <a:rPr lang="en-US" i="1">
+                                  <a:rPr lang="en-US" sz="1800" i="1">
                                     <a:latin typeface="Cambria Math" panose="02040503050406030204" pitchFamily="18" charset="0"/>
                                   </a:rPr>
                                   <m:t>𝑡</m:t>
                                 </m:r>
                                 <m:r>
-                                  <a:rPr lang="en-US" i="1">
+                                  <a:rPr lang="en-US" sz="1800" i="1">
                                     <a:latin typeface="Cambria Math" panose="02040503050406030204" pitchFamily="18" charset="0"/>
                                   </a:rPr>
                                   <m:t>+1</m:t>
@@ -26965,13 +27131,13 @@
                           </m:e>
                         </m:d>
                         <m:r>
-                          <a:rPr lang="en-US" i="1">
+                          <a:rPr lang="en-US" sz="1800" i="1">
                             <a:latin typeface="Cambria Math" panose="02040503050406030204" pitchFamily="18" charset="0"/>
                           </a:rPr>
                           <m:t>−</m:t>
                         </m:r>
                         <m:r>
-                          <a:rPr lang="en-US" i="1">
+                          <a:rPr lang="en-US" sz="1800" i="1">
                             <a:latin typeface="Cambria Math" panose="02040503050406030204" pitchFamily="18" charset="0"/>
                           </a:rPr>
                           <m:t>𝑉</m:t>
@@ -26979,7 +27145,7 @@
                         <m:d>
                           <m:dPr>
                             <m:ctrlPr>
-                              <a:rPr lang="en-US" i="1">
+                              <a:rPr lang="en-US" sz="1800" i="1">
                                 <a:latin typeface="Cambria Math" panose="02040503050406030204" pitchFamily="18" charset="0"/>
                               </a:rPr>
                             </m:ctrlPr>
@@ -26988,14 +27154,14 @@
                             <m:sSub>
                               <m:sSubPr>
                                 <m:ctrlPr>
-                                  <a:rPr lang="en-US" i="1">
+                                  <a:rPr lang="en-US" sz="1800" i="1">
                                     <a:latin typeface="Cambria Math" panose="02040503050406030204" pitchFamily="18" charset="0"/>
                                   </a:rPr>
                                 </m:ctrlPr>
                               </m:sSubPr>
                               <m:e>
                                 <m:r>
-                                  <a:rPr lang="en-US" i="1">
+                                  <a:rPr lang="en-US" sz="1800" i="1">
                                     <a:latin typeface="Cambria Math" panose="02040503050406030204" pitchFamily="18" charset="0"/>
                                   </a:rPr>
                                   <m:t>𝑆</m:t>
@@ -27003,7 +27169,7 @@
                               </m:e>
                               <m:sub>
                                 <m:r>
-                                  <a:rPr lang="en-US" i="1">
+                                  <a:rPr lang="en-US" sz="1800" i="1">
                                     <a:latin typeface="Cambria Math" panose="02040503050406030204" pitchFamily="18" charset="0"/>
                                   </a:rPr>
                                   <m:t>𝑡</m:t>
@@ -27017,49 +27183,40 @@
                   </m:oMath>
                 </a14:m>
                 <a:br>
-                  <a:rPr lang="en-US" dirty="0"/>
+                  <a:rPr lang="en-US" sz="1800" dirty="0"/>
                 </a:br>
                 <a:br>
-                  <a:rPr lang="en-US" dirty="0"/>
+                  <a:rPr lang="en-US" sz="1800" dirty="0"/>
                 </a:br>
                 <a:r>
-                  <a:rPr lang="en-US" dirty="0"/>
+                  <a:rPr lang="en-US" sz="1800" dirty="0"/>
                   <a:t>lead to an expected TD error of 0, i.e., the Bellman consistency conditions are met which means convergence.</a:t>
                 </a:r>
               </a:p>
               <a:p>
-                <a:endParaRPr lang="en-US" dirty="0"/>
+                <a:endParaRPr lang="en-US" sz="1800" dirty="0"/>
               </a:p>
               <a:p>
                 <a:r>
-                  <a:rPr lang="en-US" dirty="0"/>
+                  <a:rPr lang="en-US" sz="1800" dirty="0"/>
                   <a:t>What is slow enough?</a:t>
                 </a:r>
               </a:p>
               <a:p>
-                <a:endParaRPr lang="en-US" b="1" dirty="0"/>
+                <a:endParaRPr lang="en-US" sz="1800" b="1" dirty="0"/>
               </a:p>
               <a:p>
-                <a:endParaRPr lang="en-US" dirty="0"/>
+                <a:endParaRPr lang="en-US" sz="1800" dirty="0"/>
               </a:p>
               <a:p>
                 <a:pPr marL="0" indent="0">
                   <a:buNone/>
                 </a:pPr>
-                <a:endParaRPr lang="en-US" dirty="0"/>
-              </a:p>
-              <a:p>
-                <a:endParaRPr lang="en-US" dirty="0"/>
-              </a:p>
-              <a:p>
-                <a:endParaRPr lang="en-US" dirty="0"/>
-              </a:p>
-              <a:p>
-                <a:endParaRPr lang="en-US" dirty="0"/>
+                <a:endParaRPr lang="en-US" sz="1800" dirty="0"/>
               </a:p>
               <a:p>
                 <a:r>
-                  <a:rPr lang="en-US" dirty="0"/>
+                  <a:rPr lang="en-US" sz="1800" dirty="0"/>
                   <a:t>Example: </a:t>
                 </a:r>
                 <a14:m>
@@ -27067,14 +27224,14 @@
                     <m:sSub>
                       <m:sSubPr>
                         <m:ctrlPr>
-                          <a:rPr lang="en-US" b="0" i="1" smtClean="0">
+                          <a:rPr lang="en-US" sz="1800" b="0" i="1" smtClean="0">
                             <a:latin typeface="Cambria Math" panose="02040503050406030204" pitchFamily="18" charset="0"/>
                           </a:rPr>
                         </m:ctrlPr>
                       </m:sSubPr>
                       <m:e>
                         <m:r>
-                          <a:rPr lang="en-US" b="0" i="1" smtClean="0">
+                          <a:rPr lang="en-US" sz="1800" b="0" i="1" smtClean="0">
                             <a:latin typeface="Cambria Math" panose="02040503050406030204" pitchFamily="18" charset="0"/>
                           </a:rPr>
                           <m:t>𝛼</m:t>
@@ -27082,7 +27239,7 @@
                       </m:e>
                       <m:sub>
                         <m:r>
-                          <a:rPr lang="en-US" b="0" i="1" smtClean="0">
+                          <a:rPr lang="en-US" sz="1800" b="0" i="1" smtClean="0">
                             <a:latin typeface="Cambria Math" panose="02040503050406030204" pitchFamily="18" charset="0"/>
                           </a:rPr>
                           <m:t>𝑡</m:t>
@@ -27090,7 +27247,7 @@
                       </m:sub>
                     </m:sSub>
                     <m:r>
-                      <a:rPr lang="en-US" b="0" i="1" smtClean="0">
+                      <a:rPr lang="en-US" sz="1800" b="0" i="1" smtClean="0">
                         <a:latin typeface="Cambria Math" panose="02040503050406030204" pitchFamily="18" charset="0"/>
                       </a:rPr>
                       <m:t>=</m:t>
@@ -27098,14 +27255,14 @@
                     <m:f>
                       <m:fPr>
                         <m:ctrlPr>
-                          <a:rPr lang="en-US" b="0" i="1" smtClean="0">
+                          <a:rPr lang="en-US" sz="1800" b="0" i="1" smtClean="0">
                             <a:latin typeface="Cambria Math" panose="02040503050406030204" pitchFamily="18" charset="0"/>
                           </a:rPr>
                         </m:ctrlPr>
                       </m:fPr>
                       <m:num>
                         <m:r>
-                          <a:rPr lang="en-US" b="0" i="1" smtClean="0">
+                          <a:rPr lang="en-US" sz="1800" b="0" i="1" smtClean="0">
                             <a:latin typeface="Cambria Math" panose="02040503050406030204" pitchFamily="18" charset="0"/>
                           </a:rPr>
                           <m:t>1</m:t>
@@ -27113,7 +27270,7 @@
                       </m:num>
                       <m:den>
                         <m:r>
-                          <a:rPr lang="en-US" b="0" i="1" smtClean="0">
+                          <a:rPr lang="en-US" sz="1800" b="0" i="1" smtClean="0">
                             <a:latin typeface="Cambria Math" panose="02040503050406030204" pitchFamily="18" charset="0"/>
                           </a:rPr>
                           <m:t>𝑡</m:t>
@@ -27123,20 +27280,14 @@
                   </m:oMath>
                 </a14:m>
                 <a:r>
-                  <a:rPr lang="en-US" dirty="0"/>
+                  <a:rPr lang="en-US" sz="1800" dirty="0"/>
                   <a:t>     (equivalent to incremental averaging)</a:t>
                 </a:r>
-              </a:p>
-              <a:p>
-                <a:endParaRPr lang="en-US" dirty="0"/>
-              </a:p>
-              <a:p>
-                <a:endParaRPr lang="en-US" dirty="0"/>
               </a:p>
             </p:txBody>
           </p:sp>
         </mc:Choice>
-        <mc:Fallback xmlns="">
+        <mc:Fallback>
           <p:sp>
             <p:nvSpPr>
               <p:cNvPr id="3" name="Content Placeholder 2">
@@ -27154,10 +27305,14 @@
               </p:nvPr>
             </p:nvSpPr>
             <p:spPr>
+              <a:xfrm>
+                <a:off x="838200" y="1288280"/>
+                <a:ext cx="10515600" cy="4779633"/>
+              </a:xfrm>
               <a:blipFill>
                 <a:blip r:embed="rId2"/>
                 <a:stretch>
-                  <a:fillRect l="-174" t="-1276"/>
+                  <a:fillRect l="-406" t="-1148" b="-10587"/>
                 </a:stretch>
               </a:blipFill>
             </p:spPr>
@@ -27176,8 +27331,8 @@
           </p:sp>
         </mc:Fallback>
       </mc:AlternateContent>
-      <mc:AlternateContent xmlns:mc="http://schemas.openxmlformats.org/markup-compatibility/2006" xmlns:a14="http://schemas.microsoft.com/office/drawing/2010/main">
-        <mc:Choice Requires="a14">
+      <mc:AlternateContent xmlns:mc="http://schemas.openxmlformats.org/markup-compatibility/2006">
+        <mc:Choice xmlns:a14="http://schemas.microsoft.com/office/drawing/2010/main" Requires="a14">
           <p:sp>
             <p:nvSpPr>
               <p:cNvPr id="6" name="TextBox 5">
@@ -27192,7 +27347,7 @@
             </p:nvSpPr>
             <p:spPr>
               <a:xfrm>
-                <a:off x="4234316" y="3989253"/>
+                <a:off x="4230122" y="4681336"/>
                 <a:ext cx="3983011" cy="1124603"/>
               </a:xfrm>
               <a:prstGeom prst="rect">
@@ -27408,7 +27563,7 @@
             </p:txBody>
           </p:sp>
         </mc:Choice>
-        <mc:Fallback xmlns="">
+        <mc:Fallback>
           <p:sp>
             <p:nvSpPr>
               <p:cNvPr id="6" name="TextBox 5">
@@ -27425,7 +27580,7 @@
             </p:nvSpPr>
             <p:spPr>
               <a:xfrm>
-                <a:off x="4234316" y="3989253"/>
+                <a:off x="4230122" y="4681336"/>
                 <a:ext cx="3983011" cy="1124603"/>
               </a:xfrm>
               <a:prstGeom prst="rect">
@@ -27434,7 +27589,7 @@
               <a:blipFill>
                 <a:blip r:embed="rId3"/>
                 <a:stretch>
-                  <a:fillRect l="-1220" t="-1596"/>
+                  <a:fillRect l="-1220" t="-2139"/>
                 </a:stretch>
               </a:blipFill>
             </p:spPr>
@@ -27453,8 +27608,8 @@
           </p:sp>
         </mc:Fallback>
       </mc:AlternateContent>
-      <mc:AlternateContent xmlns:mc="http://schemas.openxmlformats.org/markup-compatibility/2006" xmlns:a14="http://schemas.microsoft.com/office/drawing/2010/main">
-        <mc:Choice Requires="a14">
+      <mc:AlternateContent xmlns:mc="http://schemas.openxmlformats.org/markup-compatibility/2006">
+        <mc:Choice xmlns:a14="http://schemas.microsoft.com/office/drawing/2010/main" Requires="a14">
           <p:sp>
             <p:nvSpPr>
               <p:cNvPr id="7" name="Speech Bubble: Rectangle with Corners Rounded 6">
@@ -27469,7 +27624,7 @@
             </p:nvSpPr>
             <p:spPr>
               <a:xfrm>
-                <a:off x="1711522" y="4572015"/>
+                <a:off x="1707328" y="5264098"/>
                 <a:ext cx="2048969" cy="625337"/>
               </a:xfrm>
               <a:prstGeom prst="wedgeRoundRectCallout">
@@ -27525,7 +27680,7 @@
             </p:txBody>
           </p:sp>
         </mc:Choice>
-        <mc:Fallback xmlns="">
+        <mc:Fallback>
           <p:sp>
             <p:nvSpPr>
               <p:cNvPr id="7" name="Speech Bubble: Rectangle with Corners Rounded 6">
@@ -27542,7 +27697,7 @@
             </p:nvSpPr>
             <p:spPr>
               <a:xfrm>
-                <a:off x="1711522" y="4572015"/>
+                <a:off x="1707328" y="5264098"/>
                 <a:ext cx="2048969" cy="625337"/>
               </a:xfrm>
               <a:prstGeom prst="wedgeRoundRectCallout">
@@ -27588,7 +27743,7 @@
         </p:nvSpPr>
         <p:spPr>
           <a:xfrm>
-            <a:off x="8645847" y="4097106"/>
+            <a:off x="8641653" y="4789189"/>
             <a:ext cx="2599545" cy="978192"/>
           </a:xfrm>
           <a:prstGeom prst="wedgeRoundRectCallout">
@@ -28004,7 +28159,7 @@
                                         <p:tgtEl>
                                           <p:spTgt spid="3">
                                             <p:txEl>
-                                              <p:pRg st="11" end="11"/>
+                                              <p:pRg st="8" end="8"/>
                                             </p:txEl>
                                           </p:spTgt>
                                         </p:tgtEl>

</xml_diff>

<commit_message>
Added GLIE to the slides.
</commit_message>
<xml_diff>
--- a/slides/Lecture_Chapter06.pptx
+++ b/slides/Lecture_Chapter06.pptx
@@ -5,7 +5,7 @@
     <p:sldMasterId id="2147483648" r:id="rId1"/>
   </p:sldMasterIdLst>
   <p:notesMasterIdLst>
-    <p:notesMasterId r:id="rId28"/>
+    <p:notesMasterId r:id="rId29"/>
   </p:notesMasterIdLst>
   <p:sldIdLst>
     <p:sldId id="256" r:id="rId2"/>
@@ -33,7 +33,8 @@
     <p:sldId id="396" r:id="rId24"/>
     <p:sldId id="479" r:id="rId25"/>
     <p:sldId id="401" r:id="rId26"/>
-    <p:sldId id="400" r:id="rId27"/>
+    <p:sldId id="482" r:id="rId27"/>
+    <p:sldId id="400" r:id="rId28"/>
   </p:sldIdLst>
   <p:sldSz cx="12192000" cy="6858000"/>
   <p:notesSz cx="6858000" cy="9144000"/>
@@ -186,6 +187,7 @@
             <p14:sldId id="396"/>
             <p14:sldId id="479"/>
             <p14:sldId id="401"/>
+            <p14:sldId id="482"/>
             <p14:sldId id="400"/>
           </p14:sldIdLst>
         </p14:section>
@@ -280,7 +282,7 @@
           <a:p>
             <a:fld id="{2A92B22A-BE2A-43CB-B312-FF3A0A14567B}" type="datetimeFigureOut">
               <a:rPr lang="en-US" smtClean="0"/>
-              <a:t>9/25/2026</a:t>
+              <a:t>9/30/2026</a:t>
             </a:fld>
             <a:endParaRPr lang="en-US"/>
           </a:p>
@@ -778,7 +780,7 @@
           <a:p>
             <a:fld id="{3E22BF2E-04DA-469E-97C5-BB68A0368813}" type="datetimeFigureOut">
               <a:rPr lang="en-US" smtClean="0"/>
-              <a:t>9/25/2026</a:t>
+              <a:t>9/30/2026</a:t>
             </a:fld>
             <a:endParaRPr lang="en-US"/>
           </a:p>
@@ -976,7 +978,7 @@
           <a:p>
             <a:fld id="{3E22BF2E-04DA-469E-97C5-BB68A0368813}" type="datetimeFigureOut">
               <a:rPr lang="en-US" smtClean="0"/>
-              <a:t>9/25/2026</a:t>
+              <a:t>9/30/2026</a:t>
             </a:fld>
             <a:endParaRPr lang="en-US"/>
           </a:p>
@@ -1184,7 +1186,7 @@
           <a:p>
             <a:fld id="{3E22BF2E-04DA-469E-97C5-BB68A0368813}" type="datetimeFigureOut">
               <a:rPr lang="en-US" smtClean="0"/>
-              <a:t>9/25/2026</a:t>
+              <a:t>9/30/2026</a:t>
             </a:fld>
             <a:endParaRPr lang="en-US"/>
           </a:p>
@@ -1392,7 +1394,7 @@
           <a:p>
             <a:fld id="{3E22BF2E-04DA-469E-97C5-BB68A0368813}" type="datetimeFigureOut">
               <a:rPr lang="en-US" smtClean="0"/>
-              <a:t>9/25/2026</a:t>
+              <a:t>9/30/2026</a:t>
             </a:fld>
             <a:endParaRPr lang="en-US"/>
           </a:p>
@@ -1667,7 +1669,7 @@
           <a:p>
             <a:fld id="{3E22BF2E-04DA-469E-97C5-BB68A0368813}" type="datetimeFigureOut">
               <a:rPr lang="en-US" smtClean="0"/>
-              <a:t>9/25/2026</a:t>
+              <a:t>9/30/2026</a:t>
             </a:fld>
             <a:endParaRPr lang="en-US"/>
           </a:p>
@@ -1932,7 +1934,7 @@
           <a:p>
             <a:fld id="{3E22BF2E-04DA-469E-97C5-BB68A0368813}" type="datetimeFigureOut">
               <a:rPr lang="en-US" smtClean="0"/>
-              <a:t>9/25/2026</a:t>
+              <a:t>9/30/2026</a:t>
             </a:fld>
             <a:endParaRPr lang="en-US"/>
           </a:p>
@@ -2344,7 +2346,7 @@
           <a:p>
             <a:fld id="{3E22BF2E-04DA-469E-97C5-BB68A0368813}" type="datetimeFigureOut">
               <a:rPr lang="en-US" smtClean="0"/>
-              <a:t>9/25/2026</a:t>
+              <a:t>9/30/2026</a:t>
             </a:fld>
             <a:endParaRPr lang="en-US"/>
           </a:p>
@@ -2485,7 +2487,7 @@
           <a:p>
             <a:fld id="{3E22BF2E-04DA-469E-97C5-BB68A0368813}" type="datetimeFigureOut">
               <a:rPr lang="en-US" smtClean="0"/>
-              <a:t>9/25/2026</a:t>
+              <a:t>9/30/2026</a:t>
             </a:fld>
             <a:endParaRPr lang="en-US"/>
           </a:p>
@@ -2598,7 +2600,7 @@
           <a:p>
             <a:fld id="{3E22BF2E-04DA-469E-97C5-BB68A0368813}" type="datetimeFigureOut">
               <a:rPr lang="en-US" smtClean="0"/>
-              <a:t>9/25/2026</a:t>
+              <a:t>9/30/2026</a:t>
             </a:fld>
             <a:endParaRPr lang="en-US"/>
           </a:p>
@@ -2909,7 +2911,7 @@
           <a:p>
             <a:fld id="{3E22BF2E-04DA-469E-97C5-BB68A0368813}" type="datetimeFigureOut">
               <a:rPr lang="en-US" smtClean="0"/>
-              <a:t>9/25/2026</a:t>
+              <a:t>9/30/2026</a:t>
             </a:fld>
             <a:endParaRPr lang="en-US"/>
           </a:p>
@@ -3197,7 +3199,7 @@
           <a:p>
             <a:fld id="{3E22BF2E-04DA-469E-97C5-BB68A0368813}" type="datetimeFigureOut">
               <a:rPr lang="en-US" smtClean="0"/>
-              <a:t>9/25/2026</a:t>
+              <a:t>9/30/2026</a:t>
             </a:fld>
             <a:endParaRPr lang="en-US"/>
           </a:p>
@@ -3438,7 +3440,7 @@
           <a:p>
             <a:fld id="{3E22BF2E-04DA-469E-97C5-BB68A0368813}" type="datetimeFigureOut">
               <a:rPr lang="en-US" smtClean="0"/>
-              <a:t>9/25/2026</a:t>
+              <a:t>9/30/2026</a:t>
             </a:fld>
             <a:endParaRPr lang="en-US"/>
           </a:p>
@@ -4601,8 +4603,8 @@
           </a:p>
         </p:txBody>
       </p:sp>
-      <mc:AlternateContent xmlns:mc="http://schemas.openxmlformats.org/markup-compatibility/2006">
-        <mc:Choice xmlns:a14="http://schemas.microsoft.com/office/drawing/2010/main" Requires="a14">
+      <mc:AlternateContent xmlns:mc="http://schemas.openxmlformats.org/markup-compatibility/2006" xmlns:a14="http://schemas.microsoft.com/office/drawing/2010/main">
+        <mc:Choice Requires="a14">
           <p:sp>
             <p:nvSpPr>
               <p:cNvPr id="3" name="Content Placeholder 2">
@@ -4777,7 +4779,7 @@
             </p:txBody>
           </p:sp>
         </mc:Choice>
-        <mc:Fallback>
+        <mc:Fallback xmlns="">
           <p:sp>
             <p:nvSpPr>
               <p:cNvPr id="3" name="Content Placeholder 2">
@@ -7612,8 +7614,8 @@
           </p:sp>
         </mc:Fallback>
       </mc:AlternateContent>
-      <mc:AlternateContent xmlns:mc="http://schemas.openxmlformats.org/markup-compatibility/2006">
-        <mc:Choice xmlns:a14="http://schemas.microsoft.com/office/drawing/2010/main" Requires="a14">
+      <mc:AlternateContent xmlns:mc="http://schemas.openxmlformats.org/markup-compatibility/2006" xmlns:a14="http://schemas.microsoft.com/office/drawing/2010/main">
+        <mc:Choice Requires="a14">
           <p:sp>
             <p:nvSpPr>
               <p:cNvPr id="10" name="TextBox 9">
@@ -7690,7 +7692,7 @@
             </p:txBody>
           </p:sp>
         </mc:Choice>
-        <mc:Fallback>
+        <mc:Fallback xmlns="">
           <p:sp>
             <p:nvSpPr>
               <p:cNvPr id="10" name="TextBox 9">
@@ -7886,8 +7888,8 @@
           </a:p>
         </p:txBody>
       </p:sp>
-      <mc:AlternateContent xmlns:mc="http://schemas.openxmlformats.org/markup-compatibility/2006">
-        <mc:Choice xmlns:a14="http://schemas.microsoft.com/office/drawing/2010/main" Requires="a14">
+      <mc:AlternateContent xmlns:mc="http://schemas.openxmlformats.org/markup-compatibility/2006" xmlns:a14="http://schemas.microsoft.com/office/drawing/2010/main">
+        <mc:Choice Requires="a14">
           <p:sp>
             <p:nvSpPr>
               <p:cNvPr id="3" name="Content Placeholder 2">
@@ -8454,7 +8456,7 @@
             </p:txBody>
           </p:sp>
         </mc:Choice>
-        <mc:Fallback>
+        <mc:Fallback xmlns="">
           <p:sp>
             <p:nvSpPr>
               <p:cNvPr id="3" name="Content Placeholder 2">
@@ -9054,8 +9056,8 @@
           </a:fontRef>
         </p:style>
       </p:cxnSp>
-      <mc:AlternateContent xmlns:mc="http://schemas.openxmlformats.org/markup-compatibility/2006">
-        <mc:Choice xmlns:a14="http://schemas.microsoft.com/office/drawing/2010/main" Requires="a14">
+      <mc:AlternateContent xmlns:mc="http://schemas.openxmlformats.org/markup-compatibility/2006" xmlns:a14="http://schemas.microsoft.com/office/drawing/2010/main">
+        <mc:Choice Requires="a14">
           <p:sp>
             <p:nvSpPr>
               <p:cNvPr id="14" name="Speech Bubble: Rectangle with Corners Rounded 13">
@@ -9210,7 +9212,7 @@
             </p:txBody>
           </p:sp>
         </mc:Choice>
-        <mc:Fallback>
+        <mc:Fallback xmlns="">
           <p:sp>
             <p:nvSpPr>
               <p:cNvPr id="14" name="Speech Bubble: Rectangle with Corners Rounded 13">
@@ -9407,8 +9409,8 @@
           </a:p>
         </p:txBody>
       </p:sp>
-      <mc:AlternateContent xmlns:mc="http://schemas.openxmlformats.org/markup-compatibility/2006">
-        <mc:Choice xmlns:a14="http://schemas.microsoft.com/office/drawing/2010/main" Requires="a14">
+      <mc:AlternateContent xmlns:mc="http://schemas.openxmlformats.org/markup-compatibility/2006" xmlns:a14="http://schemas.microsoft.com/office/drawing/2010/main">
+        <mc:Choice Requires="a14">
           <p:sp>
             <p:nvSpPr>
               <p:cNvPr id="10" name="TextBox 9">
@@ -9485,7 +9487,7 @@
             </p:txBody>
           </p:sp>
         </mc:Choice>
-        <mc:Fallback>
+        <mc:Fallback xmlns="">
           <p:sp>
             <p:nvSpPr>
               <p:cNvPr id="10" name="TextBox 9">
@@ -9588,8 +9590,8 @@
           </a:p>
         </p:txBody>
       </p:sp>
-      <mc:AlternateContent xmlns:mc="http://schemas.openxmlformats.org/markup-compatibility/2006">
-        <mc:Choice xmlns:a14="http://schemas.microsoft.com/office/drawing/2010/main" Requires="a14">
+      <mc:AlternateContent xmlns:mc="http://schemas.openxmlformats.org/markup-compatibility/2006" xmlns:a14="http://schemas.microsoft.com/office/drawing/2010/main">
+        <mc:Choice Requires="a14">
           <p:sp>
             <p:nvSpPr>
               <p:cNvPr id="3" name="Content Placeholder 2">
@@ -10142,7 +10144,7 @@
             </p:txBody>
           </p:sp>
         </mc:Choice>
-        <mc:Fallback>
+        <mc:Fallback xmlns="">
           <p:sp>
             <p:nvSpPr>
               <p:cNvPr id="3" name="Content Placeholder 2">
@@ -11288,8 +11290,8 @@
           </a:p>
         </p:txBody>
       </p:sp>
-      <mc:AlternateContent xmlns:mc="http://schemas.openxmlformats.org/markup-compatibility/2006">
-        <mc:Choice xmlns:a14="http://schemas.microsoft.com/office/drawing/2010/main" Requires="a14">
+      <mc:AlternateContent xmlns:mc="http://schemas.openxmlformats.org/markup-compatibility/2006" xmlns:a14="http://schemas.microsoft.com/office/drawing/2010/main">
+        <mc:Choice Requires="a14">
           <p:sp>
             <p:nvSpPr>
               <p:cNvPr id="3" name="Content Placeholder 2">
@@ -12323,7 +12325,7 @@
             </p:txBody>
           </p:sp>
         </mc:Choice>
-        <mc:Fallback>
+        <mc:Fallback xmlns="">
           <p:sp>
             <p:nvSpPr>
               <p:cNvPr id="3" name="Content Placeholder 2">
@@ -15505,7 +15507,7 @@
           <a:p>
             <a:r>
               <a:rPr lang="en-US" sz="1800" dirty="0"/>
-              <a:t>Actions causing movement up, down, right, and left. </a:t>
+              <a:t>Actions cause movement up, down, right, and left. </a:t>
             </a:r>
           </a:p>
           <a:p>
@@ -16113,7 +16115,7 @@
           <a:p>
             <a:r>
               <a:rPr lang="en-US" sz="1800" dirty="0"/>
-              <a:t>Actions causing movement up, down, right, and left. </a:t>
+              <a:t>Actions cause movement up, down, right, and left. </a:t>
             </a:r>
           </a:p>
           <a:p>
@@ -16410,6 +16412,88 @@
             <a:r>
               <a:rPr lang="en-US" sz="1100" dirty="0"/>
               <a:t>Sarsa is on-policy and learns a soft policy. Walking along the cliff would be dangerous! Q-Learning learns the optimal deterministic policy.</a:t>
+            </a:r>
+          </a:p>
+        </p:txBody>
+      </p:sp>
+      <p:sp>
+        <p:nvSpPr>
+          <p:cNvPr id="8" name="Speech Bubble: Rectangle with Corners Rounded 7">
+            <a:extLst>
+              <a:ext uri="{FF2B5EF4-FFF2-40B4-BE49-F238E27FC236}">
+                <a16:creationId xmlns:a16="http://schemas.microsoft.com/office/drawing/2014/main" id="{CB38205F-1ACF-C7D0-7E54-69C6E3891790}"/>
+              </a:ext>
+            </a:extLst>
+          </p:cNvPr>
+          <p:cNvSpPr/>
+          <p:nvPr/>
+        </p:nvSpPr>
+        <p:spPr>
+          <a:xfrm>
+            <a:off x="3665989" y="4983060"/>
+            <a:ext cx="2844947" cy="1496761"/>
+          </a:xfrm>
+          <a:prstGeom prst="wedgeRoundRectCallout">
+            <a:avLst>
+              <a:gd name="adj1" fmla="val 91461"/>
+              <a:gd name="adj2" fmla="val 7925"/>
+              <a:gd name="adj3" fmla="val 16667"/>
+            </a:avLst>
+          </a:prstGeom>
+        </p:spPr>
+        <p:style>
+          <a:lnRef idx="2">
+            <a:schemeClr val="accent3">
+              <a:shade val="15000"/>
+            </a:schemeClr>
+          </a:lnRef>
+          <a:fillRef idx="1">
+            <a:schemeClr val="accent3"/>
+          </a:fillRef>
+          <a:effectRef idx="0">
+            <a:schemeClr val="accent3"/>
+          </a:effectRef>
+          <a:fontRef idx="minor">
+            <a:schemeClr val="lt1"/>
+          </a:fontRef>
+        </p:style>
+        <p:txBody>
+          <a:bodyPr rtlCol="0" anchor="ctr"/>
+          <a:lstStyle/>
+          <a:p>
+            <a:r>
+              <a:rPr lang="en-US" sz="1600" b="1" dirty="0"/>
+              <a:t>Initial behavior</a:t>
+            </a:r>
+          </a:p>
+          <a:p>
+            <a:pPr marL="285750" indent="-285750">
+              <a:buFont typeface="Arial" panose="020B0604020202020204" pitchFamily="34" charset="0"/>
+              <a:buChar char="•"/>
+            </a:pPr>
+            <a:r>
+              <a:rPr lang="en-US" sz="1600" dirty="0"/>
+              <a:t>All Q-values are 0</a:t>
+            </a:r>
+          </a:p>
+          <a:p>
+            <a:pPr marL="285750" indent="-285750">
+              <a:buFont typeface="Arial" panose="020B0604020202020204" pitchFamily="34" charset="0"/>
+              <a:buChar char="•"/>
+            </a:pPr>
+            <a:r>
+              <a:rPr lang="en-US" sz="1600" dirty="0"/>
+              <a:t>Produces long episodes following a random walk.</a:t>
+            </a:r>
+          </a:p>
+          <a:p>
+            <a:pPr marL="285750" indent="-285750">
+              <a:buFont typeface="Arial" panose="020B0604020202020204" pitchFamily="34" charset="0"/>
+              <a:buChar char="•"/>
+            </a:pPr>
+            <a:r>
+              <a:rPr lang="en-US" sz="1600" dirty="0"/>
+              <a:t>This is pure exploration.</a:t>
             </a:r>
           </a:p>
         </p:txBody>
@@ -16706,6 +16790,1296 @@
 </file>
 
 <file path=ppt/slides/slide26.xml><?xml version="1.0" encoding="utf-8"?>
+<p:sld xmlns:a="http://schemas.openxmlformats.org/drawingml/2006/main" xmlns:r="http://schemas.openxmlformats.org/officeDocument/2006/relationships" xmlns:p="http://schemas.openxmlformats.org/presentationml/2006/main">
+  <p:cSld>
+    <p:spTree>
+      <p:nvGrpSpPr>
+        <p:cNvPr id="1" name=""/>
+        <p:cNvGrpSpPr/>
+        <p:nvPr/>
+      </p:nvGrpSpPr>
+      <p:grpSpPr>
+        <a:xfrm>
+          <a:off x="0" y="0"/>
+          <a:ext cx="0" cy="0"/>
+          <a:chOff x="0" y="0"/>
+          <a:chExt cx="0" cy="0"/>
+        </a:xfrm>
+      </p:grpSpPr>
+      <p:sp>
+        <p:nvSpPr>
+          <p:cNvPr id="2" name="Title 1">
+            <a:extLst>
+              <a:ext uri="{FF2B5EF4-FFF2-40B4-BE49-F238E27FC236}">
+                <a16:creationId xmlns:a16="http://schemas.microsoft.com/office/drawing/2014/main" id="{7AFDDC0C-7B50-2CF0-564C-587B670953AF}"/>
+              </a:ext>
+            </a:extLst>
+          </p:cNvPr>
+          <p:cNvSpPr>
+            <a:spLocks noGrp="1"/>
+          </p:cNvSpPr>
+          <p:nvPr>
+            <p:ph type="title"/>
+          </p:nvPr>
+        </p:nvSpPr>
+        <p:spPr/>
+        <p:txBody>
+          <a:bodyPr>
+            <a:normAutofit/>
+          </a:bodyPr>
+          <a:lstStyle/>
+          <a:p>
+            <a:r>
+              <a:rPr lang="en-US" dirty="0"/>
+              <a:t>Convergence: GLIE for Sarsa and Q-Learning</a:t>
+            </a:r>
+          </a:p>
+        </p:txBody>
+      </p:sp>
+      <mc:AlternateContent xmlns:mc="http://schemas.openxmlformats.org/markup-compatibility/2006">
+        <mc:Choice xmlns:a14="http://schemas.microsoft.com/office/drawing/2010/main" Requires="a14">
+          <p:sp>
+            <p:nvSpPr>
+              <p:cNvPr id="3" name="Content Placeholder 2">
+                <a:extLst>
+                  <a:ext uri="{FF2B5EF4-FFF2-40B4-BE49-F238E27FC236}">
+                    <a16:creationId xmlns:a16="http://schemas.microsoft.com/office/drawing/2014/main" id="{43DECDB7-7AA0-1233-4B62-A4FC8D424FF0}"/>
+                  </a:ext>
+                </a:extLst>
+              </p:cNvPr>
+              <p:cNvSpPr>
+                <a:spLocks noGrp="1"/>
+              </p:cNvSpPr>
+              <p:nvPr>
+                <p:ph idx="1"/>
+              </p:nvPr>
+            </p:nvSpPr>
+            <p:spPr>
+              <a:xfrm>
+                <a:off x="838200" y="4353886"/>
+                <a:ext cx="10515600" cy="2063692"/>
+              </a:xfrm>
+            </p:spPr>
+            <p:txBody>
+              <a:bodyPr>
+                <a:normAutofit fontScale="70000" lnSpcReduction="20000"/>
+              </a:bodyPr>
+              <a:lstStyle/>
+              <a:p>
+                <a:pPr marL="0" indent="0">
+                  <a:buNone/>
+                </a:pPr>
+                <a:r>
+                  <a:rPr lang="en-US" b="1" dirty="0"/>
+                  <a:t>Sarsa</a:t>
+                </a:r>
+                <a:r>
+                  <a:rPr lang="en-US" dirty="0"/>
+                  <a:t> is on-policy. </a:t>
+                </a:r>
+              </a:p>
+              <a:p>
+                <a:pPr lvl="1"/>
+                <a:r>
+                  <a:rPr lang="en-US" dirty="0"/>
+                  <a:t>Requires GLIE to converge to the optimal deterministic policy.</a:t>
+                </a:r>
+              </a:p>
+              <a:p>
+                <a:endParaRPr lang="en-US" b="1" dirty="0"/>
+              </a:p>
+              <a:p>
+                <a:pPr marL="0" indent="0">
+                  <a:buNone/>
+                </a:pPr>
+                <a:r>
+                  <a:rPr lang="en-US" b="1" dirty="0"/>
+                  <a:t>Q-Learning</a:t>
+                </a:r>
+                <a:r>
+                  <a:rPr lang="en-US" dirty="0"/>
+                  <a:t> is off-policy. </a:t>
+                </a:r>
+              </a:p>
+              <a:p>
+                <a:pPr lvl="1"/>
+                <a:r>
+                  <a:rPr lang="en-US" dirty="0"/>
+                  <a:t>The target policy converges to the optimal policy. Tabular Q-learning only requires infinite exploration.</a:t>
+                </a:r>
+              </a:p>
+              <a:p>
+                <a:pPr lvl="1"/>
+                <a:r>
+                  <a:rPr lang="en-US" dirty="0"/>
+                  <a:t>However: If the agent needs to behave optimally (i.e., follow the target policy), then </a:t>
+                </a:r>
+                <a14:m>
+                  <m:oMath xmlns:m="http://schemas.openxmlformats.org/officeDocument/2006/math">
+                    <m:r>
+                      <a:rPr lang="en-US" b="0" i="1" smtClean="0">
+                        <a:latin typeface="Cambria Math" panose="02040503050406030204" pitchFamily="18" charset="0"/>
+                      </a:rPr>
+                      <m:t>𝜖</m:t>
+                    </m:r>
+                  </m:oMath>
+                </a14:m>
+                <a:r>
+                  <a:rPr lang="en-US" dirty="0"/>
+                  <a:t> needs to be set to 0.</a:t>
+                </a:r>
+              </a:p>
+            </p:txBody>
+          </p:sp>
+        </mc:Choice>
+        <mc:Fallback>
+          <p:sp>
+            <p:nvSpPr>
+              <p:cNvPr id="3" name="Content Placeholder 2">
+                <a:extLst>
+                  <a:ext uri="{FF2B5EF4-FFF2-40B4-BE49-F238E27FC236}">
+                    <a16:creationId xmlns:a16="http://schemas.microsoft.com/office/drawing/2014/main" id="{43DECDB7-7AA0-1233-4B62-A4FC8D424FF0}"/>
+                  </a:ext>
+                </a:extLst>
+              </p:cNvPr>
+              <p:cNvSpPr>
+                <a:spLocks noGrp="1" noRot="1" noChangeAspect="1" noMove="1" noResize="1" noEditPoints="1" noAdjustHandles="1" noChangeArrowheads="1" noChangeShapeType="1" noTextEdit="1"/>
+              </p:cNvSpPr>
+              <p:nvPr>
+                <p:ph idx="1"/>
+              </p:nvPr>
+            </p:nvSpPr>
+            <p:spPr>
+              <a:xfrm>
+                <a:off x="838200" y="4353886"/>
+                <a:ext cx="10515600" cy="2063692"/>
+              </a:xfrm>
+              <a:blipFill>
+                <a:blip r:embed="rId2"/>
+                <a:stretch>
+                  <a:fillRect l="-638" t="-5015"/>
+                </a:stretch>
+              </a:blipFill>
+            </p:spPr>
+            <p:txBody>
+              <a:bodyPr/>
+              <a:lstStyle/>
+              <a:p>
+                <a:r>
+                  <a:rPr lang="en-US">
+                    <a:noFill/>
+                  </a:rPr>
+                  <a:t> </a:t>
+                </a:r>
+              </a:p>
+            </p:txBody>
+          </p:sp>
+        </mc:Fallback>
+      </mc:AlternateContent>
+      <mc:AlternateContent xmlns:mc="http://schemas.openxmlformats.org/markup-compatibility/2006">
+        <mc:Choice xmlns:a14="http://schemas.microsoft.com/office/drawing/2010/main" Requires="a14">
+          <p:sp>
+            <p:nvSpPr>
+              <p:cNvPr id="5" name="TextBox 4">
+                <a:extLst>
+                  <a:ext uri="{FF2B5EF4-FFF2-40B4-BE49-F238E27FC236}">
+                    <a16:creationId xmlns:a16="http://schemas.microsoft.com/office/drawing/2014/main" id="{57BE216A-DD30-7358-2C8B-8809C21F0C7B}"/>
+                  </a:ext>
+                </a:extLst>
+              </p:cNvPr>
+              <p:cNvSpPr txBox="1"/>
+              <p:nvPr/>
+            </p:nvSpPr>
+            <p:spPr>
+              <a:xfrm>
+                <a:off x="965801" y="1266799"/>
+                <a:ext cx="9291234" cy="2803075"/>
+              </a:xfrm>
+              <a:prstGeom prst="rect">
+                <a:avLst/>
+              </a:prstGeom>
+            </p:spPr>
+            <p:style>
+              <a:lnRef idx="2">
+                <a:schemeClr val="accent3">
+                  <a:shade val="15000"/>
+                </a:schemeClr>
+              </a:lnRef>
+              <a:fillRef idx="1">
+                <a:schemeClr val="accent3"/>
+              </a:fillRef>
+              <a:effectRef idx="0">
+                <a:schemeClr val="accent3"/>
+              </a:effectRef>
+              <a:fontRef idx="minor">
+                <a:schemeClr val="lt1"/>
+              </a:fontRef>
+            </p:style>
+            <p:txBody>
+              <a:bodyPr wrap="square">
+                <a:spAutoFit/>
+              </a:bodyPr>
+              <a:lstStyle/>
+              <a:p>
+                <a:pPr algn="ctr"/>
+                <a:r>
+                  <a:rPr lang="en-US" sz="2000" b="1" dirty="0"/>
+                  <a:t>GLIE Condition</a:t>
+                </a:r>
+                <a:endParaRPr lang="en-US" sz="2000" dirty="0"/>
+              </a:p>
+              <a:p>
+                <a:endParaRPr lang="en-US" dirty="0"/>
+              </a:p>
+              <a:p>
+                <a:r>
+                  <a:rPr lang="en-US" dirty="0"/>
+                  <a:t>Many on-policy control methods converge to the optimal deterministic policy if:</a:t>
+                </a:r>
+              </a:p>
+              <a:p>
+                <a:endParaRPr lang="en-US" dirty="0"/>
+              </a:p>
+              <a:p>
+                <a:pPr marL="342900" indent="-342900">
+                  <a:buFont typeface="+mj-lt"/>
+                  <a:buAutoNum type="arabicPeriod"/>
+                </a:pPr>
+                <a:r>
+                  <a:rPr lang="en-US" b="1" dirty="0"/>
+                  <a:t>Infinite explorations</a:t>
+                </a:r>
+                <a:r>
+                  <a:rPr lang="en-US" dirty="0"/>
+                  <a:t>: Every state-action pair is visited infinitely often.</a:t>
+                </a:r>
+                <a:br>
+                  <a:rPr lang="en-US" dirty="0"/>
+                </a:br>
+                <a14:m>
+                  <m:oMath xmlns:m="http://schemas.openxmlformats.org/officeDocument/2006/math">
+                    <m:func>
+                      <m:funcPr>
+                        <m:ctrlPr>
+                          <a:rPr lang="en-US" i="1" smtClean="0">
+                            <a:latin typeface="Cambria Math" panose="02040503050406030204" pitchFamily="18" charset="0"/>
+                          </a:rPr>
+                        </m:ctrlPr>
+                      </m:funcPr>
+                      <m:fName>
+                        <m:limLow>
+                          <m:limLowPr>
+                            <m:ctrlPr>
+                              <a:rPr lang="en-US" i="0" smtClean="0">
+                                <a:latin typeface="Cambria Math" panose="02040503050406030204" pitchFamily="18" charset="0"/>
+                              </a:rPr>
+                            </m:ctrlPr>
+                          </m:limLowPr>
+                          <m:e>
+                            <m:r>
+                              <m:rPr>
+                                <m:sty m:val="p"/>
+                              </m:rPr>
+                              <a:rPr lang="en-US" i="0" smtClean="0">
+                                <a:latin typeface="Cambria Math" panose="02040503050406030204" pitchFamily="18" charset="0"/>
+                              </a:rPr>
+                              <m:t>lim</m:t>
+                            </m:r>
+                          </m:e>
+                          <m:lim>
+                            <m:r>
+                              <a:rPr lang="en-US" b="0" i="1" smtClean="0">
+                                <a:latin typeface="Cambria Math" panose="02040503050406030204" pitchFamily="18" charset="0"/>
+                              </a:rPr>
+                              <m:t>𝑡</m:t>
+                            </m:r>
+                            <m:r>
+                              <a:rPr lang="en-US" b="0" i="1" smtClean="0">
+                                <a:latin typeface="Cambria Math" panose="02040503050406030204" pitchFamily="18" charset="0"/>
+                              </a:rPr>
+                              <m:t>→∞</m:t>
+                            </m:r>
+                          </m:lim>
+                        </m:limLow>
+                      </m:fName>
+                      <m:e>
+                        <m:sSub>
+                          <m:sSubPr>
+                            <m:ctrlPr>
+                              <a:rPr lang="en-US" b="0" i="1" smtClean="0">
+                                <a:latin typeface="Cambria Math" panose="02040503050406030204" pitchFamily="18" charset="0"/>
+                              </a:rPr>
+                            </m:ctrlPr>
+                          </m:sSubPr>
+                          <m:e>
+                            <m:r>
+                              <a:rPr lang="en-US" b="0" i="1" smtClean="0">
+                                <a:latin typeface="Cambria Math" panose="02040503050406030204" pitchFamily="18" charset="0"/>
+                              </a:rPr>
+                              <m:t>𝑁</m:t>
+                            </m:r>
+                          </m:e>
+                          <m:sub>
+                            <m:r>
+                              <a:rPr lang="en-US" b="0" i="1" smtClean="0">
+                                <a:latin typeface="Cambria Math" panose="02040503050406030204" pitchFamily="18" charset="0"/>
+                              </a:rPr>
+                              <m:t>𝑡</m:t>
+                            </m:r>
+                          </m:sub>
+                        </m:sSub>
+                        <m:d>
+                          <m:dPr>
+                            <m:ctrlPr>
+                              <a:rPr lang="en-US" b="0" i="1" smtClean="0">
+                                <a:latin typeface="Cambria Math" panose="02040503050406030204" pitchFamily="18" charset="0"/>
+                              </a:rPr>
+                            </m:ctrlPr>
+                          </m:dPr>
+                          <m:e>
+                            <m:r>
+                              <a:rPr lang="en-US" b="0" i="1" smtClean="0">
+                                <a:latin typeface="Cambria Math" panose="02040503050406030204" pitchFamily="18" charset="0"/>
+                              </a:rPr>
+                              <m:t>𝑠</m:t>
+                            </m:r>
+                            <m:r>
+                              <a:rPr lang="en-US" b="0" i="1" smtClean="0">
+                                <a:latin typeface="Cambria Math" panose="02040503050406030204" pitchFamily="18" charset="0"/>
+                              </a:rPr>
+                              <m:t>,</m:t>
+                            </m:r>
+                            <m:r>
+                              <a:rPr lang="en-US" b="0" i="1" smtClean="0">
+                                <a:latin typeface="Cambria Math" panose="02040503050406030204" pitchFamily="18" charset="0"/>
+                              </a:rPr>
+                              <m:t>𝑎</m:t>
+                            </m:r>
+                          </m:e>
+                        </m:d>
+                        <m:r>
+                          <a:rPr lang="en-US" b="0" i="1" smtClean="0">
+                            <a:latin typeface="Cambria Math" panose="02040503050406030204" pitchFamily="18" charset="0"/>
+                          </a:rPr>
+                          <m:t>=∞</m:t>
+                        </m:r>
+                      </m:e>
+                    </m:func>
+                    <m:r>
+                      <a:rPr lang="en-US" b="0" i="1" smtClean="0">
+                        <a:latin typeface="Cambria Math" panose="02040503050406030204" pitchFamily="18" charset="0"/>
+                      </a:rPr>
+                      <m:t>             </m:t>
+                    </m:r>
+                    <m:r>
+                      <m:rPr>
+                        <m:nor/>
+                      </m:rPr>
+                      <a:rPr lang="en-US" b="0" i="0" smtClean="0"/>
+                      <m:t>where</m:t>
+                    </m:r>
+                    <m:r>
+                      <m:rPr>
+                        <m:nor/>
+                      </m:rPr>
+                      <a:rPr lang="en-US" b="0" i="0" smtClean="0">
+                        <a:latin typeface="Cambria Math" panose="02040503050406030204" pitchFamily="18" charset="0"/>
+                      </a:rPr>
+                      <m:t> </m:t>
+                    </m:r>
+                    <m:r>
+                      <a:rPr lang="en-US" b="0" i="1" smtClean="0">
+                        <a:latin typeface="Cambria Math" panose="02040503050406030204" pitchFamily="18" charset="0"/>
+                      </a:rPr>
+                      <m:t>𝑁</m:t>
+                    </m:r>
+                    <m:d>
+                      <m:dPr>
+                        <m:ctrlPr>
+                          <a:rPr lang="en-US" b="0" i="1" smtClean="0">
+                            <a:latin typeface="Cambria Math" panose="02040503050406030204" pitchFamily="18" charset="0"/>
+                          </a:rPr>
+                        </m:ctrlPr>
+                      </m:dPr>
+                      <m:e>
+                        <m:r>
+                          <a:rPr lang="en-US" b="0" i="1" smtClean="0">
+                            <a:latin typeface="Cambria Math" panose="02040503050406030204" pitchFamily="18" charset="0"/>
+                          </a:rPr>
+                          <m:t>⋅,⋅</m:t>
+                        </m:r>
+                      </m:e>
+                    </m:d>
+                    <m:r>
+                      <a:rPr lang="en-US" b="0" i="1" smtClean="0">
+                        <a:latin typeface="Cambria Math" panose="02040503050406030204" pitchFamily="18" charset="0"/>
+                      </a:rPr>
+                      <m:t> </m:t>
+                    </m:r>
+                    <m:r>
+                      <m:rPr>
+                        <m:nor/>
+                      </m:rPr>
+                      <a:rPr lang="en-US" b="0" i="0" smtClean="0"/>
+                      <m:t>is the visit count</m:t>
+                    </m:r>
+                  </m:oMath>
+                </a14:m>
+                <a:br>
+                  <a:rPr lang="en-US" dirty="0"/>
+                </a:br>
+                <a:endParaRPr lang="en-US" dirty="0"/>
+              </a:p>
+              <a:p>
+                <a:pPr marL="342900" indent="-342900">
+                  <a:buFont typeface="+mj-lt"/>
+                  <a:buAutoNum type="arabicPeriod"/>
+                </a:pPr>
+                <a:endParaRPr lang="en-US" dirty="0"/>
+              </a:p>
+              <a:p>
+                <a:pPr marL="342900" indent="-342900">
+                  <a:buFont typeface="+mj-lt"/>
+                  <a:buAutoNum type="arabicPeriod"/>
+                </a:pPr>
+                <a:r>
+                  <a:rPr lang="en-US" b="1" dirty="0"/>
+                  <a:t>Greedy in the limit</a:t>
+                </a:r>
+                <a:r>
+                  <a:rPr lang="en-US" dirty="0"/>
+                  <a:t>: The policy becomes greedy with respect to </a:t>
+                </a:r>
+                <a14:m>
+                  <m:oMath xmlns:m="http://schemas.openxmlformats.org/officeDocument/2006/math">
+                    <m:r>
+                      <a:rPr lang="en-US" i="1" dirty="0" smtClean="0">
+                        <a:latin typeface="Cambria Math" panose="02040503050406030204" pitchFamily="18" charset="0"/>
+                      </a:rPr>
+                      <m:t>𝑄</m:t>
+                    </m:r>
+                  </m:oMath>
+                </a14:m>
+                <a:r>
+                  <a:rPr lang="en-US" dirty="0"/>
+                  <a:t> over time.</a:t>
+                </a:r>
+                <a:br>
+                  <a:rPr lang="en-US" dirty="0"/>
+                </a:br>
+                <a14:m>
+                  <m:oMath xmlns:m="http://schemas.openxmlformats.org/officeDocument/2006/math">
+                    <m:limLow>
+                      <m:limLowPr>
+                        <m:ctrlPr>
+                          <a:rPr lang="en-US">
+                            <a:latin typeface="Cambria Math" panose="02040503050406030204" pitchFamily="18" charset="0"/>
+                          </a:rPr>
+                        </m:ctrlPr>
+                      </m:limLowPr>
+                      <m:e>
+                        <m:r>
+                          <m:rPr>
+                            <m:sty m:val="p"/>
+                          </m:rPr>
+                          <a:rPr lang="en-US">
+                            <a:latin typeface="Cambria Math" panose="02040503050406030204" pitchFamily="18" charset="0"/>
+                          </a:rPr>
+                          <m:t>lim</m:t>
+                        </m:r>
+                      </m:e>
+                      <m:lim>
+                        <m:r>
+                          <a:rPr lang="en-US" i="1">
+                            <a:latin typeface="Cambria Math" panose="02040503050406030204" pitchFamily="18" charset="0"/>
+                          </a:rPr>
+                          <m:t>𝑡</m:t>
+                        </m:r>
+                        <m:r>
+                          <a:rPr lang="en-US" i="1">
+                            <a:latin typeface="Cambria Math" panose="02040503050406030204" pitchFamily="18" charset="0"/>
+                          </a:rPr>
+                          <m:t>→∞</m:t>
+                        </m:r>
+                      </m:lim>
+                    </m:limLow>
+                    <m:r>
+                      <a:rPr lang="en-US" b="0" i="1" smtClean="0">
+                        <a:latin typeface="Cambria Math" panose="02040503050406030204" pitchFamily="18" charset="0"/>
+                      </a:rPr>
+                      <m:t> </m:t>
+                    </m:r>
+                    <m:r>
+                      <a:rPr lang="en-US" b="0" i="1" smtClean="0">
+                        <a:latin typeface="Cambria Math" panose="02040503050406030204" pitchFamily="18" charset="0"/>
+                      </a:rPr>
+                      <m:t>𝜋</m:t>
+                    </m:r>
+                    <m:d>
+                      <m:dPr>
+                        <m:ctrlPr>
+                          <a:rPr lang="en-US" b="0" i="0" smtClean="0">
+                            <a:latin typeface="Cambria Math" panose="02040503050406030204" pitchFamily="18" charset="0"/>
+                          </a:rPr>
+                        </m:ctrlPr>
+                      </m:dPr>
+                      <m:e>
+                        <m:r>
+                          <m:rPr>
+                            <m:nor/>
+                          </m:rPr>
+                          <a:rPr lang="en-US" b="0" i="0" smtClean="0">
+                            <a:latin typeface="Cambria Math" panose="02040503050406030204" pitchFamily="18" charset="0"/>
+                          </a:rPr>
+                          <m:t>argma</m:t>
+                        </m:r>
+                        <m:sSub>
+                          <m:sSubPr>
+                            <m:ctrlPr>
+                              <a:rPr lang="en-US" b="0" i="0" smtClean="0">
+                                <a:latin typeface="Cambria Math" panose="02040503050406030204" pitchFamily="18" charset="0"/>
+                              </a:rPr>
+                            </m:ctrlPr>
+                          </m:sSubPr>
+                          <m:e>
+                            <m:r>
+                              <m:rPr>
+                                <m:nor/>
+                              </m:rPr>
+                              <a:rPr lang="en-US" b="0" i="0" smtClean="0">
+                                <a:latin typeface="Cambria Math" panose="02040503050406030204" pitchFamily="18" charset="0"/>
+                              </a:rPr>
+                              <m:t>x</m:t>
+                            </m:r>
+                          </m:e>
+                          <m:sub>
+                            <m:r>
+                              <a:rPr lang="en-US" b="0" i="1" smtClean="0">
+                                <a:latin typeface="Cambria Math" panose="02040503050406030204" pitchFamily="18" charset="0"/>
+                              </a:rPr>
+                              <m:t>𝑎</m:t>
+                            </m:r>
+                          </m:sub>
+                        </m:sSub>
+                        <m:d>
+                          <m:dPr>
+                            <m:ctrlPr>
+                              <a:rPr lang="en-US" i="1">
+                                <a:latin typeface="Cambria Math" panose="02040503050406030204" pitchFamily="18" charset="0"/>
+                              </a:rPr>
+                            </m:ctrlPr>
+                          </m:dPr>
+                          <m:e>
+                            <m:sSub>
+                              <m:sSubPr>
+                                <m:ctrlPr>
+                                  <a:rPr lang="en-US" i="1">
+                                    <a:latin typeface="Cambria Math" panose="02040503050406030204" pitchFamily="18" charset="0"/>
+                                  </a:rPr>
+                                </m:ctrlPr>
+                              </m:sSubPr>
+                              <m:e>
+                                <m:r>
+                                  <a:rPr lang="en-US" i="1">
+                                    <a:latin typeface="Cambria Math" panose="02040503050406030204" pitchFamily="18" charset="0"/>
+                                  </a:rPr>
+                                  <m:t>𝑄</m:t>
+                                </m:r>
+                              </m:e>
+                              <m:sub>
+                                <m:r>
+                                  <a:rPr lang="en-US" i="1">
+                                    <a:latin typeface="Cambria Math" panose="02040503050406030204" pitchFamily="18" charset="0"/>
+                                  </a:rPr>
+                                  <m:t>𝑡</m:t>
+                                </m:r>
+                              </m:sub>
+                            </m:sSub>
+                            <m:d>
+                              <m:dPr>
+                                <m:ctrlPr>
+                                  <a:rPr lang="en-US" i="1">
+                                    <a:latin typeface="Cambria Math" panose="02040503050406030204" pitchFamily="18" charset="0"/>
+                                  </a:rPr>
+                                </m:ctrlPr>
+                              </m:dPr>
+                              <m:e>
+                                <m:r>
+                                  <a:rPr lang="en-US" i="1">
+                                    <a:latin typeface="Cambria Math" panose="02040503050406030204" pitchFamily="18" charset="0"/>
+                                  </a:rPr>
+                                  <m:t>𝑠</m:t>
+                                </m:r>
+                                <m:r>
+                                  <a:rPr lang="en-US" i="1">
+                                    <a:latin typeface="Cambria Math" panose="02040503050406030204" pitchFamily="18" charset="0"/>
+                                  </a:rPr>
+                                  <m:t>,</m:t>
+                                </m:r>
+                                <m:r>
+                                  <a:rPr lang="en-US" i="1">
+                                    <a:latin typeface="Cambria Math" panose="02040503050406030204" pitchFamily="18" charset="0"/>
+                                  </a:rPr>
+                                  <m:t>𝑎</m:t>
+                                </m:r>
+                              </m:e>
+                            </m:d>
+                            <m:r>
+                              <a:rPr lang="en-US" i="1">
+                                <a:latin typeface="Cambria Math" panose="02040503050406030204" pitchFamily="18" charset="0"/>
+                              </a:rPr>
+                              <m:t>,</m:t>
+                            </m:r>
+                            <m:r>
+                              <a:rPr lang="en-US" i="1">
+                                <a:latin typeface="Cambria Math" panose="02040503050406030204" pitchFamily="18" charset="0"/>
+                              </a:rPr>
+                              <m:t>𝑠</m:t>
+                            </m:r>
+                          </m:e>
+                        </m:d>
+                      </m:e>
+                    </m:d>
+                    <m:r>
+                      <a:rPr lang="en-US" b="0" i="1" smtClean="0">
+                        <a:latin typeface="Cambria Math" panose="02040503050406030204" pitchFamily="18" charset="0"/>
+                      </a:rPr>
+                      <m:t>=1</m:t>
+                    </m:r>
+                  </m:oMath>
+                </a14:m>
+                <a:endParaRPr lang="en-US" dirty="0"/>
+              </a:p>
+            </p:txBody>
+          </p:sp>
+        </mc:Choice>
+        <mc:Fallback>
+          <p:sp>
+            <p:nvSpPr>
+              <p:cNvPr id="5" name="TextBox 4">
+                <a:extLst>
+                  <a:ext uri="{FF2B5EF4-FFF2-40B4-BE49-F238E27FC236}">
+                    <a16:creationId xmlns:a16="http://schemas.microsoft.com/office/drawing/2014/main" id="{57BE216A-DD30-7358-2C8B-8809C21F0C7B}"/>
+                  </a:ext>
+                </a:extLst>
+              </p:cNvPr>
+              <p:cNvSpPr txBox="1">
+                <a:spLocks noRot="1" noChangeAspect="1" noMove="1" noResize="1" noEditPoints="1" noAdjustHandles="1" noChangeArrowheads="1" noChangeShapeType="1" noTextEdit="1"/>
+              </p:cNvSpPr>
+              <p:nvPr/>
+            </p:nvSpPr>
+            <p:spPr>
+              <a:xfrm>
+                <a:off x="965801" y="1266799"/>
+                <a:ext cx="9291234" cy="2803075"/>
+              </a:xfrm>
+              <a:prstGeom prst="rect">
+                <a:avLst/>
+              </a:prstGeom>
+              <a:blipFill>
+                <a:blip r:embed="rId3"/>
+                <a:stretch>
+                  <a:fillRect l="-524" t="-1080"/>
+                </a:stretch>
+              </a:blipFill>
+            </p:spPr>
+            <p:txBody>
+              <a:bodyPr/>
+              <a:lstStyle/>
+              <a:p>
+                <a:r>
+                  <a:rPr lang="en-US">
+                    <a:noFill/>
+                  </a:rPr>
+                  <a:t> </a:t>
+                </a:r>
+              </a:p>
+            </p:txBody>
+          </p:sp>
+        </mc:Fallback>
+      </mc:AlternateContent>
+      <mc:AlternateContent xmlns:mc="http://schemas.openxmlformats.org/markup-compatibility/2006">
+        <mc:Choice xmlns:a14="http://schemas.microsoft.com/office/drawing/2010/main" Requires="a14">
+          <p:sp>
+            <p:nvSpPr>
+              <p:cNvPr id="4" name="Speech Bubble: Rectangle with Corners Rounded 3">
+                <a:extLst>
+                  <a:ext uri="{FF2B5EF4-FFF2-40B4-BE49-F238E27FC236}">
+                    <a16:creationId xmlns:a16="http://schemas.microsoft.com/office/drawing/2014/main" id="{1A52C5AC-CDE6-5FB1-CFBE-3FBF12DD0611}"/>
+                  </a:ext>
+                </a:extLst>
+              </p:cNvPr>
+              <p:cNvSpPr/>
+              <p:nvPr/>
+            </p:nvSpPr>
+            <p:spPr>
+              <a:xfrm>
+                <a:off x="8984609" y="1963024"/>
+                <a:ext cx="3091343" cy="624968"/>
+              </a:xfrm>
+              <a:prstGeom prst="wedgeRoundRectCallout">
+                <a:avLst>
+                  <a:gd name="adj1" fmla="val -73449"/>
+                  <a:gd name="adj2" fmla="val 61135"/>
+                  <a:gd name="adj3" fmla="val 16667"/>
+                </a:avLst>
+              </a:prstGeom>
+            </p:spPr>
+            <p:style>
+              <a:lnRef idx="2">
+                <a:schemeClr val="accent2">
+                  <a:shade val="15000"/>
+                </a:schemeClr>
+              </a:lnRef>
+              <a:fillRef idx="1">
+                <a:schemeClr val="accent2"/>
+              </a:fillRef>
+              <a:effectRef idx="0">
+                <a:schemeClr val="accent2"/>
+              </a:effectRef>
+              <a:fontRef idx="minor">
+                <a:schemeClr val="lt1"/>
+              </a:fontRef>
+            </p:style>
+            <p:txBody>
+              <a:bodyPr rtlCol="0" anchor="ctr"/>
+              <a:lstStyle/>
+              <a:p>
+                <a:pPr algn="ctr"/>
+                <a:r>
+                  <a:rPr lang="en-US" sz="1600" dirty="0"/>
+                  <a:t>Many episodes.</a:t>
+                </a:r>
+              </a:p>
+              <a:p>
+                <a:pPr algn="ctr"/>
+                <a:r>
+                  <a:rPr lang="en-US" sz="1600" dirty="0"/>
+                  <a:t>Exploring policy (e.g., </a:t>
+                </a:r>
+                <a14:m>
+                  <m:oMath xmlns:m="http://schemas.openxmlformats.org/officeDocument/2006/math">
+                    <m:r>
+                      <a:rPr lang="en-US" sz="1600" i="1">
+                        <a:latin typeface="Cambria Math" panose="02040503050406030204" pitchFamily="18" charset="0"/>
+                      </a:rPr>
+                      <m:t>𝜖</m:t>
+                    </m:r>
+                  </m:oMath>
+                </a14:m>
+                <a:r>
+                  <a:rPr lang="en-US" sz="1600" dirty="0"/>
+                  <a:t>-greedy).</a:t>
+                </a:r>
+              </a:p>
+            </p:txBody>
+          </p:sp>
+        </mc:Choice>
+        <mc:Fallback>
+          <p:sp>
+            <p:nvSpPr>
+              <p:cNvPr id="4" name="Speech Bubble: Rectangle with Corners Rounded 3">
+                <a:extLst>
+                  <a:ext uri="{FF2B5EF4-FFF2-40B4-BE49-F238E27FC236}">
+                    <a16:creationId xmlns:a16="http://schemas.microsoft.com/office/drawing/2014/main" id="{1A52C5AC-CDE6-5FB1-CFBE-3FBF12DD0611}"/>
+                  </a:ext>
+                </a:extLst>
+              </p:cNvPr>
+              <p:cNvSpPr>
+                <a:spLocks noRot="1" noChangeAspect="1" noMove="1" noResize="1" noEditPoints="1" noAdjustHandles="1" noChangeArrowheads="1" noChangeShapeType="1" noTextEdit="1"/>
+              </p:cNvSpPr>
+              <p:nvPr/>
+            </p:nvSpPr>
+            <p:spPr>
+              <a:xfrm>
+                <a:off x="8984609" y="1963024"/>
+                <a:ext cx="3091343" cy="624968"/>
+              </a:xfrm>
+              <a:prstGeom prst="wedgeRoundRectCallout">
+                <a:avLst>
+                  <a:gd name="adj1" fmla="val -73449"/>
+                  <a:gd name="adj2" fmla="val 61135"/>
+                  <a:gd name="adj3" fmla="val 16667"/>
+                </a:avLst>
+              </a:prstGeom>
+              <a:blipFill>
+                <a:blip r:embed="rId4"/>
+                <a:stretch>
+                  <a:fillRect/>
+                </a:stretch>
+              </a:blipFill>
+            </p:spPr>
+            <p:txBody>
+              <a:bodyPr/>
+              <a:lstStyle/>
+              <a:p>
+                <a:r>
+                  <a:rPr lang="en-US">
+                    <a:noFill/>
+                  </a:rPr>
+                  <a:t> </a:t>
+                </a:r>
+              </a:p>
+            </p:txBody>
+          </p:sp>
+        </mc:Fallback>
+      </mc:AlternateContent>
+      <mc:AlternateContent xmlns:mc="http://schemas.openxmlformats.org/markup-compatibility/2006">
+        <mc:Choice xmlns:a14="http://schemas.microsoft.com/office/drawing/2010/main" Requires="a14">
+          <p:sp>
+            <p:nvSpPr>
+              <p:cNvPr id="7" name="Speech Bubble: Rectangle with Corners Rounded 6">
+                <a:extLst>
+                  <a:ext uri="{FF2B5EF4-FFF2-40B4-BE49-F238E27FC236}">
+                    <a16:creationId xmlns:a16="http://schemas.microsoft.com/office/drawing/2014/main" id="{705375C7-2EB6-E9C3-072D-D70D758FBC8C}"/>
+                  </a:ext>
+                </a:extLst>
+              </p:cNvPr>
+              <p:cNvSpPr/>
+              <p:nvPr/>
+            </p:nvSpPr>
+            <p:spPr>
+              <a:xfrm>
+                <a:off x="9161940" y="3594683"/>
+                <a:ext cx="2445391" cy="383747"/>
+              </a:xfrm>
+              <a:prstGeom prst="wedgeRoundRectCallout">
+                <a:avLst>
+                  <a:gd name="adj1" fmla="val -119393"/>
+                  <a:gd name="adj2" fmla="val 10638"/>
+                  <a:gd name="adj3" fmla="val 16667"/>
+                </a:avLst>
+              </a:prstGeom>
+            </p:spPr>
+            <p:style>
+              <a:lnRef idx="2">
+                <a:schemeClr val="accent2">
+                  <a:shade val="15000"/>
+                </a:schemeClr>
+              </a:lnRef>
+              <a:fillRef idx="1">
+                <a:schemeClr val="accent2"/>
+              </a:fillRef>
+              <a:effectRef idx="0">
+                <a:schemeClr val="accent2"/>
+              </a:effectRef>
+              <a:fontRef idx="minor">
+                <a:schemeClr val="lt1"/>
+              </a:fontRef>
+            </p:style>
+            <p:txBody>
+              <a:bodyPr rtlCol="0" anchor="ctr"/>
+              <a:lstStyle/>
+              <a:p>
+                <a:pPr algn="ctr"/>
+                <a:r>
+                  <a:rPr lang="en-US" sz="1600" dirty="0"/>
+                  <a:t>Reduce </a:t>
+                </a:r>
+                <a14:m>
+                  <m:oMath xmlns:m="http://schemas.openxmlformats.org/officeDocument/2006/math">
+                    <m:r>
+                      <a:rPr lang="en-US" sz="1600" b="0" i="1" smtClean="0">
+                        <a:latin typeface="Cambria Math" panose="02040503050406030204" pitchFamily="18" charset="0"/>
+                      </a:rPr>
+                      <m:t>𝜖</m:t>
+                    </m:r>
+                  </m:oMath>
+                </a14:m>
+                <a:r>
+                  <a:rPr lang="en-US" sz="1600" dirty="0"/>
+                  <a:t> slowly.</a:t>
+                </a:r>
+              </a:p>
+            </p:txBody>
+          </p:sp>
+        </mc:Choice>
+        <mc:Fallback>
+          <p:sp>
+            <p:nvSpPr>
+              <p:cNvPr id="7" name="Speech Bubble: Rectangle with Corners Rounded 6">
+                <a:extLst>
+                  <a:ext uri="{FF2B5EF4-FFF2-40B4-BE49-F238E27FC236}">
+                    <a16:creationId xmlns:a16="http://schemas.microsoft.com/office/drawing/2014/main" id="{705375C7-2EB6-E9C3-072D-D70D758FBC8C}"/>
+                  </a:ext>
+                </a:extLst>
+              </p:cNvPr>
+              <p:cNvSpPr>
+                <a:spLocks noRot="1" noChangeAspect="1" noMove="1" noResize="1" noEditPoints="1" noAdjustHandles="1" noChangeArrowheads="1" noChangeShapeType="1" noTextEdit="1"/>
+              </p:cNvSpPr>
+              <p:nvPr/>
+            </p:nvSpPr>
+            <p:spPr>
+              <a:xfrm>
+                <a:off x="9161940" y="3594683"/>
+                <a:ext cx="2445391" cy="383747"/>
+              </a:xfrm>
+              <a:prstGeom prst="wedgeRoundRectCallout">
+                <a:avLst>
+                  <a:gd name="adj1" fmla="val -119393"/>
+                  <a:gd name="adj2" fmla="val 10638"/>
+                  <a:gd name="adj3" fmla="val 16667"/>
+                </a:avLst>
+              </a:prstGeom>
+              <a:blipFill>
+                <a:blip r:embed="rId5"/>
+                <a:stretch>
+                  <a:fillRect b="-10606"/>
+                </a:stretch>
+              </a:blipFill>
+            </p:spPr>
+            <p:txBody>
+              <a:bodyPr/>
+              <a:lstStyle/>
+              <a:p>
+                <a:r>
+                  <a:rPr lang="en-US">
+                    <a:noFill/>
+                  </a:rPr>
+                  <a:t> </a:t>
+                </a:r>
+              </a:p>
+            </p:txBody>
+          </p:sp>
+        </mc:Fallback>
+      </mc:AlternateContent>
+    </p:spTree>
+    <p:extLst>
+      <p:ext uri="{BB962C8B-B14F-4D97-AF65-F5344CB8AC3E}">
+        <p14:creationId xmlns:p14="http://schemas.microsoft.com/office/powerpoint/2010/main" val="604810491"/>
+      </p:ext>
+    </p:extLst>
+  </p:cSld>
+  <p:clrMapOvr>
+    <a:masterClrMapping/>
+  </p:clrMapOvr>
+  <p:timing>
+    <p:tnLst>
+      <p:par>
+        <p:cTn id="1" dur="indefinite" restart="never" nodeType="tmRoot">
+          <p:childTnLst>
+            <p:seq concurrent="1" nextAc="seek">
+              <p:cTn id="2" dur="indefinite" nodeType="mainSeq">
+                <p:childTnLst>
+                  <p:par>
+                    <p:cTn id="3" fill="hold">
+                      <p:stCondLst>
+                        <p:cond delay="indefinite"/>
+                      </p:stCondLst>
+                      <p:childTnLst>
+                        <p:par>
+                          <p:cTn id="4" fill="hold">
+                            <p:stCondLst>
+                              <p:cond delay="0"/>
+                            </p:stCondLst>
+                            <p:childTnLst>
+                              <p:par>
+                                <p:cTn id="5" presetID="1" presetClass="entr" presetSubtype="0" fill="hold" grpId="0" nodeType="clickEffect">
+                                  <p:stCondLst>
+                                    <p:cond delay="0"/>
+                                  </p:stCondLst>
+                                  <p:childTnLst>
+                                    <p:set>
+                                      <p:cBhvr>
+                                        <p:cTn id="6" dur="1" fill="hold">
+                                          <p:stCondLst>
+                                            <p:cond delay="0"/>
+                                          </p:stCondLst>
+                                        </p:cTn>
+                                        <p:tgtEl>
+                                          <p:spTgt spid="5"/>
+                                        </p:tgtEl>
+                                        <p:attrNameLst>
+                                          <p:attrName>style.visibility</p:attrName>
+                                        </p:attrNameLst>
+                                      </p:cBhvr>
+                                      <p:to>
+                                        <p:strVal val="visible"/>
+                                      </p:to>
+                                    </p:set>
+                                  </p:childTnLst>
+                                </p:cTn>
+                              </p:par>
+                            </p:childTnLst>
+                          </p:cTn>
+                        </p:par>
+                      </p:childTnLst>
+                    </p:cTn>
+                  </p:par>
+                  <p:par>
+                    <p:cTn id="7" fill="hold">
+                      <p:stCondLst>
+                        <p:cond delay="indefinite"/>
+                      </p:stCondLst>
+                      <p:childTnLst>
+                        <p:par>
+                          <p:cTn id="8" fill="hold">
+                            <p:stCondLst>
+                              <p:cond delay="0"/>
+                            </p:stCondLst>
+                            <p:childTnLst>
+                              <p:par>
+                                <p:cTn id="9" presetID="1" presetClass="entr" presetSubtype="0" fill="hold" nodeType="clickEffect">
+                                  <p:stCondLst>
+                                    <p:cond delay="0"/>
+                                  </p:stCondLst>
+                                  <p:childTnLst>
+                                    <p:set>
+                                      <p:cBhvr>
+                                        <p:cTn id="10" dur="1" fill="hold">
+                                          <p:stCondLst>
+                                            <p:cond delay="0"/>
+                                          </p:stCondLst>
+                                        </p:cTn>
+                                        <p:tgtEl>
+                                          <p:spTgt spid="3">
+                                            <p:txEl>
+                                              <p:pRg st="0" end="0"/>
+                                            </p:txEl>
+                                          </p:spTgt>
+                                        </p:tgtEl>
+                                        <p:attrNameLst>
+                                          <p:attrName>style.visibility</p:attrName>
+                                        </p:attrNameLst>
+                                      </p:cBhvr>
+                                      <p:to>
+                                        <p:strVal val="visible"/>
+                                      </p:to>
+                                    </p:set>
+                                  </p:childTnLst>
+                                </p:cTn>
+                              </p:par>
+                            </p:childTnLst>
+                          </p:cTn>
+                        </p:par>
+                      </p:childTnLst>
+                    </p:cTn>
+                  </p:par>
+                  <p:par>
+                    <p:cTn id="11" fill="hold">
+                      <p:stCondLst>
+                        <p:cond delay="indefinite"/>
+                      </p:stCondLst>
+                      <p:childTnLst>
+                        <p:par>
+                          <p:cTn id="12" fill="hold">
+                            <p:stCondLst>
+                              <p:cond delay="0"/>
+                            </p:stCondLst>
+                            <p:childTnLst>
+                              <p:par>
+                                <p:cTn id="13" presetID="1" presetClass="entr" presetSubtype="0" fill="hold" nodeType="clickEffect">
+                                  <p:stCondLst>
+                                    <p:cond delay="0"/>
+                                  </p:stCondLst>
+                                  <p:childTnLst>
+                                    <p:set>
+                                      <p:cBhvr>
+                                        <p:cTn id="14" dur="1" fill="hold">
+                                          <p:stCondLst>
+                                            <p:cond delay="0"/>
+                                          </p:stCondLst>
+                                        </p:cTn>
+                                        <p:tgtEl>
+                                          <p:spTgt spid="3">
+                                            <p:txEl>
+                                              <p:pRg st="1" end="1"/>
+                                            </p:txEl>
+                                          </p:spTgt>
+                                        </p:tgtEl>
+                                        <p:attrNameLst>
+                                          <p:attrName>style.visibility</p:attrName>
+                                        </p:attrNameLst>
+                                      </p:cBhvr>
+                                      <p:to>
+                                        <p:strVal val="visible"/>
+                                      </p:to>
+                                    </p:set>
+                                  </p:childTnLst>
+                                </p:cTn>
+                              </p:par>
+                            </p:childTnLst>
+                          </p:cTn>
+                        </p:par>
+                      </p:childTnLst>
+                    </p:cTn>
+                  </p:par>
+                  <p:par>
+                    <p:cTn id="15" fill="hold">
+                      <p:stCondLst>
+                        <p:cond delay="indefinite"/>
+                      </p:stCondLst>
+                      <p:childTnLst>
+                        <p:par>
+                          <p:cTn id="16" fill="hold">
+                            <p:stCondLst>
+                              <p:cond delay="0"/>
+                            </p:stCondLst>
+                            <p:childTnLst>
+                              <p:par>
+                                <p:cTn id="17" presetID="1" presetClass="entr" presetSubtype="0" fill="hold" nodeType="clickEffect">
+                                  <p:stCondLst>
+                                    <p:cond delay="0"/>
+                                  </p:stCondLst>
+                                  <p:childTnLst>
+                                    <p:set>
+                                      <p:cBhvr>
+                                        <p:cTn id="18" dur="1" fill="hold">
+                                          <p:stCondLst>
+                                            <p:cond delay="0"/>
+                                          </p:stCondLst>
+                                        </p:cTn>
+                                        <p:tgtEl>
+                                          <p:spTgt spid="3">
+                                            <p:txEl>
+                                              <p:pRg st="3" end="3"/>
+                                            </p:txEl>
+                                          </p:spTgt>
+                                        </p:tgtEl>
+                                        <p:attrNameLst>
+                                          <p:attrName>style.visibility</p:attrName>
+                                        </p:attrNameLst>
+                                      </p:cBhvr>
+                                      <p:to>
+                                        <p:strVal val="visible"/>
+                                      </p:to>
+                                    </p:set>
+                                  </p:childTnLst>
+                                </p:cTn>
+                              </p:par>
+                            </p:childTnLst>
+                          </p:cTn>
+                        </p:par>
+                      </p:childTnLst>
+                    </p:cTn>
+                  </p:par>
+                  <p:par>
+                    <p:cTn id="19" fill="hold">
+                      <p:stCondLst>
+                        <p:cond delay="indefinite"/>
+                      </p:stCondLst>
+                      <p:childTnLst>
+                        <p:par>
+                          <p:cTn id="20" fill="hold">
+                            <p:stCondLst>
+                              <p:cond delay="0"/>
+                            </p:stCondLst>
+                            <p:childTnLst>
+                              <p:par>
+                                <p:cTn id="21" presetID="1" presetClass="entr" presetSubtype="0" fill="hold" nodeType="clickEffect">
+                                  <p:stCondLst>
+                                    <p:cond delay="0"/>
+                                  </p:stCondLst>
+                                  <p:childTnLst>
+                                    <p:set>
+                                      <p:cBhvr>
+                                        <p:cTn id="22" dur="1" fill="hold">
+                                          <p:stCondLst>
+                                            <p:cond delay="0"/>
+                                          </p:stCondLst>
+                                        </p:cTn>
+                                        <p:tgtEl>
+                                          <p:spTgt spid="3">
+                                            <p:txEl>
+                                              <p:pRg st="4" end="4"/>
+                                            </p:txEl>
+                                          </p:spTgt>
+                                        </p:tgtEl>
+                                        <p:attrNameLst>
+                                          <p:attrName>style.visibility</p:attrName>
+                                        </p:attrNameLst>
+                                      </p:cBhvr>
+                                      <p:to>
+                                        <p:strVal val="visible"/>
+                                      </p:to>
+                                    </p:set>
+                                  </p:childTnLst>
+                                </p:cTn>
+                              </p:par>
+                            </p:childTnLst>
+                          </p:cTn>
+                        </p:par>
+                      </p:childTnLst>
+                    </p:cTn>
+                  </p:par>
+                  <p:par>
+                    <p:cTn id="23" fill="hold">
+                      <p:stCondLst>
+                        <p:cond delay="indefinite"/>
+                      </p:stCondLst>
+                      <p:childTnLst>
+                        <p:par>
+                          <p:cTn id="24" fill="hold">
+                            <p:stCondLst>
+                              <p:cond delay="0"/>
+                            </p:stCondLst>
+                            <p:childTnLst>
+                              <p:par>
+                                <p:cTn id="25" presetID="1" presetClass="entr" presetSubtype="0" fill="hold" nodeType="clickEffect">
+                                  <p:stCondLst>
+                                    <p:cond delay="0"/>
+                                  </p:stCondLst>
+                                  <p:childTnLst>
+                                    <p:set>
+                                      <p:cBhvr>
+                                        <p:cTn id="26" dur="1" fill="hold">
+                                          <p:stCondLst>
+                                            <p:cond delay="0"/>
+                                          </p:stCondLst>
+                                        </p:cTn>
+                                        <p:tgtEl>
+                                          <p:spTgt spid="3">
+                                            <p:txEl>
+                                              <p:pRg st="5" end="5"/>
+                                            </p:txEl>
+                                          </p:spTgt>
+                                        </p:tgtEl>
+                                        <p:attrNameLst>
+                                          <p:attrName>style.visibility</p:attrName>
+                                        </p:attrNameLst>
+                                      </p:cBhvr>
+                                      <p:to>
+                                        <p:strVal val="visible"/>
+                                      </p:to>
+                                    </p:set>
+                                  </p:childTnLst>
+                                </p:cTn>
+                              </p:par>
+                            </p:childTnLst>
+                          </p:cTn>
+                        </p:par>
+                      </p:childTnLst>
+                    </p:cTn>
+                  </p:par>
+                </p:childTnLst>
+              </p:cTn>
+              <p:prevCondLst>
+                <p:cond evt="onPrev" delay="0">
+                  <p:tgtEl>
+                    <p:sldTgt/>
+                  </p:tgtEl>
+                </p:cond>
+              </p:prevCondLst>
+              <p:nextCondLst>
+                <p:cond evt="onNext" delay="0">
+                  <p:tgtEl>
+                    <p:sldTgt/>
+                  </p:tgtEl>
+                </p:cond>
+              </p:nextCondLst>
+            </p:seq>
+          </p:childTnLst>
+        </p:cTn>
+      </p:par>
+    </p:tnLst>
+    <p:bldLst>
+      <p:bldP spid="5" grpId="0" animBg="1"/>
+    </p:bldLst>
+  </p:timing>
+</p:sld>
+</file>
+
+<file path=ppt/slides/slide27.xml><?xml version="1.0" encoding="utf-8"?>
 <p:sld xmlns:a="http://schemas.openxmlformats.org/drawingml/2006/main" xmlns:r="http://schemas.openxmlformats.org/officeDocument/2006/relationships" xmlns:p="http://schemas.openxmlformats.org/presentationml/2006/main">
   <p:cSld>
     <p:bg>
@@ -21679,8 +23053,8 @@
           </a:p>
         </p:txBody>
       </p:sp>
-      <mc:AlternateContent xmlns:mc="http://schemas.openxmlformats.org/markup-compatibility/2006">
-        <mc:Choice xmlns:a14="http://schemas.microsoft.com/office/drawing/2010/main" Requires="a14">
+      <mc:AlternateContent xmlns:mc="http://schemas.openxmlformats.org/markup-compatibility/2006" xmlns:a14="http://schemas.microsoft.com/office/drawing/2010/main">
+        <mc:Choice Requires="a14">
           <p:sp>
             <p:nvSpPr>
               <p:cNvPr id="3" name="Content Placeholder 2">
@@ -22727,7 +24101,7 @@
             </p:txBody>
           </p:sp>
         </mc:Choice>
-        <mc:Fallback>
+        <mc:Fallback xmlns="">
           <p:sp>
             <p:nvSpPr>
               <p:cNvPr id="3" name="Content Placeholder 2">
@@ -23768,8 +25142,8 @@
             </a:p>
           </p:txBody>
         </p:sp>
-        <mc:AlternateContent xmlns:mc="http://schemas.openxmlformats.org/markup-compatibility/2006">
-          <mc:Choice xmlns:a14="http://schemas.microsoft.com/office/drawing/2010/main" Requires="a14">
+        <mc:AlternateContent xmlns:mc="http://schemas.openxmlformats.org/markup-compatibility/2006" xmlns:a14="http://schemas.microsoft.com/office/drawing/2010/main">
+          <mc:Choice Requires="a14">
             <p:sp>
               <p:nvSpPr>
                 <p:cNvPr id="20" name="TextBox 19">
@@ -23841,7 +25215,7 @@
               </p:txBody>
             </p:sp>
           </mc:Choice>
-          <mc:Fallback>
+          <mc:Fallback xmlns="">
             <p:sp>
               <p:nvSpPr>
                 <p:cNvPr id="20" name="TextBox 19">
@@ -24520,8 +25894,8 @@
           </a:p>
         </p:txBody>
       </p:sp>
-      <mc:AlternateContent xmlns:mc="http://schemas.openxmlformats.org/markup-compatibility/2006">
-        <mc:Choice xmlns:a14="http://schemas.microsoft.com/office/drawing/2010/main" Requires="a14">
+      <mc:AlternateContent xmlns:mc="http://schemas.openxmlformats.org/markup-compatibility/2006" xmlns:a14="http://schemas.microsoft.com/office/drawing/2010/main">
+        <mc:Choice Requires="a14">
           <p:sp>
             <p:nvSpPr>
               <p:cNvPr id="3" name="Content Placeholder 2">
@@ -25183,7 +26557,7 @@
             </p:txBody>
           </p:sp>
         </mc:Choice>
-        <mc:Fallback>
+        <mc:Fallback xmlns="">
           <p:sp>
             <p:nvSpPr>
               <p:cNvPr id="3" name="Content Placeholder 2">
@@ -26637,8 +28011,8 @@
           </a:p>
         </p:txBody>
       </p:sp>
-      <mc:AlternateContent xmlns:mc="http://schemas.openxmlformats.org/markup-compatibility/2006">
-        <mc:Choice xmlns:a14="http://schemas.microsoft.com/office/drawing/2010/main" Requires="a14">
+      <mc:AlternateContent xmlns:mc="http://schemas.openxmlformats.org/markup-compatibility/2006" xmlns:a14="http://schemas.microsoft.com/office/drawing/2010/main">
+        <mc:Choice Requires="a14">
           <p:sp>
             <p:nvSpPr>
               <p:cNvPr id="3" name="Content Placeholder 2">
@@ -27287,7 +28661,7 @@
             </p:txBody>
           </p:sp>
         </mc:Choice>
-        <mc:Fallback>
+        <mc:Fallback xmlns="">
           <p:sp>
             <p:nvSpPr>
               <p:cNvPr id="3" name="Content Placeholder 2">
@@ -27331,8 +28705,8 @@
           </p:sp>
         </mc:Fallback>
       </mc:AlternateContent>
-      <mc:AlternateContent xmlns:mc="http://schemas.openxmlformats.org/markup-compatibility/2006">
-        <mc:Choice xmlns:a14="http://schemas.microsoft.com/office/drawing/2010/main" Requires="a14">
+      <mc:AlternateContent xmlns:mc="http://schemas.openxmlformats.org/markup-compatibility/2006" xmlns:a14="http://schemas.microsoft.com/office/drawing/2010/main">
+        <mc:Choice Requires="a14">
           <p:sp>
             <p:nvSpPr>
               <p:cNvPr id="6" name="TextBox 5">
@@ -27563,7 +28937,7 @@
             </p:txBody>
           </p:sp>
         </mc:Choice>
-        <mc:Fallback>
+        <mc:Fallback xmlns="">
           <p:sp>
             <p:nvSpPr>
               <p:cNvPr id="6" name="TextBox 5">
@@ -27608,8 +28982,8 @@
           </p:sp>
         </mc:Fallback>
       </mc:AlternateContent>
-      <mc:AlternateContent xmlns:mc="http://schemas.openxmlformats.org/markup-compatibility/2006">
-        <mc:Choice xmlns:a14="http://schemas.microsoft.com/office/drawing/2010/main" Requires="a14">
+      <mc:AlternateContent xmlns:mc="http://schemas.openxmlformats.org/markup-compatibility/2006" xmlns:a14="http://schemas.microsoft.com/office/drawing/2010/main">
+        <mc:Choice Requires="a14">
           <p:sp>
             <p:nvSpPr>
               <p:cNvPr id="7" name="Speech Bubble: Rectangle with Corners Rounded 6">
@@ -27680,7 +29054,7 @@
             </p:txBody>
           </p:sp>
         </mc:Choice>
-        <mc:Fallback>
+        <mc:Fallback xmlns="">
           <p:sp>
             <p:nvSpPr>
               <p:cNvPr id="7" name="Speech Bubble: Rectangle with Corners Rounded 6">

</xml_diff>

<commit_message>
improved size and readability.
</commit_message>
<xml_diff>
--- a/slides/Lecture_Chapter06.pptx
+++ b/slides/Lecture_Chapter06.pptx
@@ -280,7 +280,7 @@
           <a:p>
             <a:fld id="{2A92B22A-BE2A-43CB-B312-FF3A0A14567B}" type="datetimeFigureOut">
               <a:rPr lang="en-US" smtClean="0"/>
-              <a:t>10/15/26</a:t>
+              <a:t>10/19/2026</a:t>
             </a:fld>
             <a:endParaRPr lang="en-US"/>
           </a:p>
@@ -778,7 +778,7 @@
           <a:p>
             <a:fld id="{3E22BF2E-04DA-469E-97C5-BB68A0368813}" type="datetimeFigureOut">
               <a:rPr lang="en-US" smtClean="0"/>
-              <a:t>10/15/26</a:t>
+              <a:t>10/19/2026</a:t>
             </a:fld>
             <a:endParaRPr lang="en-US"/>
           </a:p>
@@ -976,7 +976,7 @@
           <a:p>
             <a:fld id="{3E22BF2E-04DA-469E-97C5-BB68A0368813}" type="datetimeFigureOut">
               <a:rPr lang="en-US" smtClean="0"/>
-              <a:t>10/15/26</a:t>
+              <a:t>10/19/2026</a:t>
             </a:fld>
             <a:endParaRPr lang="en-US"/>
           </a:p>
@@ -1184,7 +1184,7 @@
           <a:p>
             <a:fld id="{3E22BF2E-04DA-469E-97C5-BB68A0368813}" type="datetimeFigureOut">
               <a:rPr lang="en-US" smtClean="0"/>
-              <a:t>10/15/26</a:t>
+              <a:t>10/19/2026</a:t>
             </a:fld>
             <a:endParaRPr lang="en-US"/>
           </a:p>
@@ -1392,7 +1392,7 @@
           <a:p>
             <a:fld id="{3E22BF2E-04DA-469E-97C5-BB68A0368813}" type="datetimeFigureOut">
               <a:rPr lang="en-US" smtClean="0"/>
-              <a:t>10/15/26</a:t>
+              <a:t>10/19/2026</a:t>
             </a:fld>
             <a:endParaRPr lang="en-US"/>
           </a:p>
@@ -1667,7 +1667,7 @@
           <a:p>
             <a:fld id="{3E22BF2E-04DA-469E-97C5-BB68A0368813}" type="datetimeFigureOut">
               <a:rPr lang="en-US" smtClean="0"/>
-              <a:t>10/15/26</a:t>
+              <a:t>10/19/2026</a:t>
             </a:fld>
             <a:endParaRPr lang="en-US"/>
           </a:p>
@@ -1932,7 +1932,7 @@
           <a:p>
             <a:fld id="{3E22BF2E-04DA-469E-97C5-BB68A0368813}" type="datetimeFigureOut">
               <a:rPr lang="en-US" smtClean="0"/>
-              <a:t>10/15/26</a:t>
+              <a:t>10/19/2026</a:t>
             </a:fld>
             <a:endParaRPr lang="en-US"/>
           </a:p>
@@ -2344,7 +2344,7 @@
           <a:p>
             <a:fld id="{3E22BF2E-04DA-469E-97C5-BB68A0368813}" type="datetimeFigureOut">
               <a:rPr lang="en-US" smtClean="0"/>
-              <a:t>10/15/26</a:t>
+              <a:t>10/19/2026</a:t>
             </a:fld>
             <a:endParaRPr lang="en-US"/>
           </a:p>
@@ -2485,7 +2485,7 @@
           <a:p>
             <a:fld id="{3E22BF2E-04DA-469E-97C5-BB68A0368813}" type="datetimeFigureOut">
               <a:rPr lang="en-US" smtClean="0"/>
-              <a:t>10/15/26</a:t>
+              <a:t>10/19/2026</a:t>
             </a:fld>
             <a:endParaRPr lang="en-US"/>
           </a:p>
@@ -2598,7 +2598,7 @@
           <a:p>
             <a:fld id="{3E22BF2E-04DA-469E-97C5-BB68A0368813}" type="datetimeFigureOut">
               <a:rPr lang="en-US" smtClean="0"/>
-              <a:t>10/15/26</a:t>
+              <a:t>10/19/2026</a:t>
             </a:fld>
             <a:endParaRPr lang="en-US"/>
           </a:p>
@@ -2909,7 +2909,7 @@
           <a:p>
             <a:fld id="{3E22BF2E-04DA-469E-97C5-BB68A0368813}" type="datetimeFigureOut">
               <a:rPr lang="en-US" smtClean="0"/>
-              <a:t>10/15/26</a:t>
+              <a:t>10/19/2026</a:t>
             </a:fld>
             <a:endParaRPr lang="en-US"/>
           </a:p>
@@ -3197,7 +3197,7 @@
           <a:p>
             <a:fld id="{3E22BF2E-04DA-469E-97C5-BB68A0368813}" type="datetimeFigureOut">
               <a:rPr lang="en-US" smtClean="0"/>
-              <a:t>10/15/26</a:t>
+              <a:t>10/19/2026</a:t>
             </a:fld>
             <a:endParaRPr lang="en-US"/>
           </a:p>
@@ -3438,7 +3438,7 @@
           <a:p>
             <a:fld id="{3E22BF2E-04DA-469E-97C5-BB68A0368813}" type="datetimeFigureOut">
               <a:rPr lang="en-US" smtClean="0"/>
-              <a:t>10/15/26</a:t>
+              <a:t>10/19/2026</a:t>
             </a:fld>
             <a:endParaRPr lang="en-US"/>
           </a:p>
@@ -7382,8 +7382,8 @@
           </a:p>
         </p:txBody>
       </p:sp>
-      <mc:AlternateContent xmlns:mc="http://schemas.openxmlformats.org/markup-compatibility/2006">
-        <mc:Choice xmlns:a14="http://schemas.microsoft.com/office/drawing/2010/main" Requires="a14">
+      <mc:AlternateContent xmlns:mc="http://schemas.openxmlformats.org/markup-compatibility/2006" xmlns:a14="http://schemas.microsoft.com/office/drawing/2010/main">
+        <mc:Choice Requires="a14">
           <p:sp>
             <p:nvSpPr>
               <p:cNvPr id="8" name="Speech Bubble: Rectangle with Corners Rounded 7">
@@ -7467,7 +7467,7 @@
             </p:txBody>
           </p:sp>
         </mc:Choice>
-        <mc:Fallback>
+        <mc:Fallback xmlns="">
           <p:sp>
             <p:nvSpPr>
               <p:cNvPr id="8" name="Speech Bubble: Rectangle with Corners Rounded 7">
@@ -7519,8 +7519,8 @@
           </p:sp>
         </mc:Fallback>
       </mc:AlternateContent>
-      <mc:AlternateContent xmlns:mc="http://schemas.openxmlformats.org/markup-compatibility/2006">
-        <mc:Choice xmlns:a14="http://schemas.microsoft.com/office/drawing/2010/main" Requires="a14">
+      <mc:AlternateContent xmlns:mc="http://schemas.openxmlformats.org/markup-compatibility/2006" xmlns:a14="http://schemas.microsoft.com/office/drawing/2010/main">
+        <mc:Choice Requires="a14">
           <p:sp>
             <p:nvSpPr>
               <p:cNvPr id="9" name="Speech Bubble: Rectangle with Corners Rounded 8">
@@ -7608,7 +7608,7 @@
             </p:txBody>
           </p:sp>
         </mc:Choice>
-        <mc:Fallback>
+        <mc:Fallback xmlns="">
           <p:sp>
             <p:nvSpPr>
               <p:cNvPr id="9" name="Speech Bubble: Rectangle with Corners Rounded 8">
@@ -7660,8 +7660,8 @@
           </p:sp>
         </mc:Fallback>
       </mc:AlternateContent>
-      <mc:AlternateContent xmlns:mc="http://schemas.openxmlformats.org/markup-compatibility/2006">
-        <mc:Choice xmlns:a14="http://schemas.microsoft.com/office/drawing/2010/main" Requires="a14">
+      <mc:AlternateContent xmlns:mc="http://schemas.openxmlformats.org/markup-compatibility/2006" xmlns:a14="http://schemas.microsoft.com/office/drawing/2010/main">
+        <mc:Choice Requires="a14">
           <p:sp>
             <p:nvSpPr>
               <p:cNvPr id="10" name="TextBox 9">
@@ -7741,7 +7741,7 @@
             </p:txBody>
           </p:sp>
         </mc:Choice>
-        <mc:Fallback>
+        <mc:Fallback xmlns="">
           <p:sp>
             <p:nvSpPr>
               <p:cNvPr id="10" name="TextBox 9">
@@ -9123,8 +9123,8 @@
           </a:fontRef>
         </p:style>
       </p:cxnSp>
-      <mc:AlternateContent xmlns:mc="http://schemas.openxmlformats.org/markup-compatibility/2006">
-        <mc:Choice xmlns:a14="http://schemas.microsoft.com/office/drawing/2010/main" Requires="a14">
+      <mc:AlternateContent xmlns:mc="http://schemas.openxmlformats.org/markup-compatibility/2006" xmlns:a14="http://schemas.microsoft.com/office/drawing/2010/main">
+        <mc:Choice Requires="a14">
           <p:sp>
             <p:nvSpPr>
               <p:cNvPr id="14" name="Speech Bubble: Rectangle with Corners Rounded 13">
@@ -9282,7 +9282,7 @@
             </p:txBody>
           </p:sp>
         </mc:Choice>
-        <mc:Fallback>
+        <mc:Fallback xmlns="">
           <p:sp>
             <p:nvSpPr>
               <p:cNvPr id="14" name="Speech Bubble: Rectangle with Corners Rounded 13">
@@ -16298,8 +16298,8 @@
           </a:prstGeom>
         </p:spPr>
       </p:pic>
-      <mc:AlternateContent xmlns:mc="http://schemas.openxmlformats.org/markup-compatibility/2006">
-        <mc:Choice xmlns:a14="http://schemas.microsoft.com/office/drawing/2010/main" Requires="a14">
+      <mc:AlternateContent xmlns:mc="http://schemas.openxmlformats.org/markup-compatibility/2006" xmlns:a14="http://schemas.microsoft.com/office/drawing/2010/main">
+        <mc:Choice Requires="a14">
           <p:sp>
             <p:nvSpPr>
               <p:cNvPr id="9" name="TextBox 8">
@@ -16373,7 +16373,7 @@
             </p:txBody>
           </p:sp>
         </mc:Choice>
-        <mc:Fallback>
+        <mc:Fallback xmlns="">
           <p:sp>
             <p:nvSpPr>
               <p:cNvPr id="9" name="TextBox 8">
@@ -25780,8 +25780,8 @@
           </p:txBody>
         </p:sp>
       </p:grpSp>
-      <mc:AlternateContent xmlns:mc="http://schemas.openxmlformats.org/markup-compatibility/2006">
-        <mc:Choice xmlns:a14="http://schemas.microsoft.com/office/drawing/2010/main" Requires="a14">
+      <mc:AlternateContent xmlns:mc="http://schemas.openxmlformats.org/markup-compatibility/2006" xmlns:a14="http://schemas.microsoft.com/office/drawing/2010/main">
+        <mc:Choice Requires="a14">
           <p:sp>
             <p:nvSpPr>
               <p:cNvPr id="5" name="Speech Bubble: Rectangle with Corners Rounded 4">
@@ -25900,7 +25900,7 @@
             </p:txBody>
           </p:sp>
         </mc:Choice>
-        <mc:Fallback>
+        <mc:Fallback xmlns="">
           <p:sp>
             <p:nvSpPr>
               <p:cNvPr id="5" name="Speech Bubble: Rectangle with Corners Rounded 4">
@@ -25952,8 +25952,8 @@
           </p:sp>
         </mc:Fallback>
       </mc:AlternateContent>
-      <mc:AlternateContent xmlns:mc="http://schemas.openxmlformats.org/markup-compatibility/2006">
-        <mc:Choice xmlns:a14="http://schemas.microsoft.com/office/drawing/2010/main" Requires="a14">
+      <mc:AlternateContent xmlns:mc="http://schemas.openxmlformats.org/markup-compatibility/2006" xmlns:a14="http://schemas.microsoft.com/office/drawing/2010/main">
+        <mc:Choice Requires="a14">
           <p:sp>
             <p:nvSpPr>
               <p:cNvPr id="14" name="TextBox 13">
@@ -26022,7 +26022,7 @@
             </p:txBody>
           </p:sp>
         </mc:Choice>
-        <mc:Fallback>
+        <mc:Fallback xmlns="">
           <p:sp>
             <p:nvSpPr>
               <p:cNvPr id="14" name="TextBox 13">
@@ -26799,8 +26799,8 @@
           </a:p>
         </p:txBody>
       </p:sp>
-      <mc:AlternateContent xmlns:mc="http://schemas.openxmlformats.org/markup-compatibility/2006" xmlns:a14="http://schemas.microsoft.com/office/drawing/2010/main">
-        <mc:Choice Requires="a14">
+      <mc:AlternateContent xmlns:mc="http://schemas.openxmlformats.org/markup-compatibility/2006">
+        <mc:Choice xmlns:a14="http://schemas.microsoft.com/office/drawing/2010/main" Requires="a14">
           <p:sp>
             <p:nvSpPr>
               <p:cNvPr id="3" name="Content Placeholder 2" descr="Regular conditions on the MDP apply (finite, gamma is less than 1, etc.). The observed TD error delta sub t equals R sub t plus 1, plus gamma V (S sub t plus 1) minus V (S sub t) is a noisy sample of the true difference. Convergence: Stochastic approximation theory guarantees convergence if the learning rate alpha decreases slowly enough. Then the updates V (S sub t) V (S sub t) plus alpha [R sub t plus 1, plus gamma V (S sub t plus 1) minus V (S sub t)] lead to an expected TD error of 0, i.e., the Bellman consistency conditions are met which means convergence. What is slow enough?. Example: alpha sub t equals 1 over t (equivalent to incremental averaging)">
@@ -26829,9 +26829,17 @@
               </a:bodyPr>
               <a:lstStyle/>
               <a:p>
+                <a:pPr marL="342900" indent="-342900">
+                  <a:buFont typeface="+mj-lt"/>
+                  <a:buAutoNum type="arabicPeriod"/>
+                </a:pPr>
+                <a:r>
+                  <a:rPr lang="en-US" sz="1800" b="1" dirty="0"/>
+                  <a:t>Regular conditions on the MDP: </a:t>
+                </a:r>
                 <a:r>
                   <a:rPr lang="en-US" sz="1800" dirty="0"/>
-                  <a:t>Regular conditions on the MDP apply (finite, </a:t>
+                  <a:t>finite, </a:t>
                 </a:r>
                 <a14:m>
                   <m:oMath xmlns:m="http://schemas.openxmlformats.org/officeDocument/2006/math">
@@ -26851,13 +26859,28 @@
                 </a14:m>
                 <a:r>
                   <a:rPr lang="en-US" sz="1800" dirty="0"/>
-                  <a:t>, etc.)</a:t>
+                  <a:t> or terminating</a:t>
                 </a:r>
               </a:p>
               <a:p>
+                <a:pPr marL="342900" indent="-342900">
+                  <a:buFont typeface="+mj-lt"/>
+                  <a:buAutoNum type="arabicPeriod"/>
+                </a:pPr>
+                <a:endParaRPr lang="en-US" sz="1800" b="1" dirty="0"/>
+              </a:p>
+              <a:p>
+                <a:pPr marL="342900" indent="-342900">
+                  <a:buFont typeface="+mj-lt"/>
+                  <a:buAutoNum type="arabicPeriod"/>
+                </a:pPr>
+                <a:r>
+                  <a:rPr lang="en-US" sz="1800" b="1" dirty="0"/>
+                  <a:t>Stochastic approximation theory</a:t>
+                </a:r>
                 <a:r>
                   <a:rPr lang="en-US" sz="1800" dirty="0"/>
-                  <a:t>The observed TD error </a:t>
+                  <a:t>: The observed TD error </a:t>
                 </a:r>
                 <a14:m>
                   <m:oMath xmlns:m="http://schemas.openxmlformats.org/officeDocument/2006/math">
@@ -27038,46 +27061,10 @@
                   <a:t> is a noisy sample of the true difference.</a:t>
                 </a:r>
                 <a:br>
-                  <a:rPr lang="en-US" sz="1800" dirty="0"/>
-                </a:br>
-                <a:endParaRPr lang="en-US" sz="1800" dirty="0"/>
-              </a:p>
-              <a:p>
-                <a:r>
-                  <a:rPr lang="en-US" sz="1800" b="1" dirty="0"/>
-                  <a:t>Convergence</a:t>
-                </a:r>
-                <a:r>
-                  <a:rPr lang="en-US" sz="1800" dirty="0"/>
-                  <a:t>: Stochastic approximation theory guarantees convergence if the </a:t>
-                </a:r>
-                <a:r>
-                  <a:rPr lang="en-US" sz="1800" b="1" dirty="0"/>
-                  <a:t>learning rate </a:t>
-                </a:r>
-                <a14:m>
-                  <m:oMath xmlns:m="http://schemas.openxmlformats.org/officeDocument/2006/math">
-                    <m:r>
-                      <a:rPr lang="en-US" sz="1800" b="1" i="1" smtClean="0">
-                        <a:latin typeface="Cambria Math" panose="02040503050406030204" pitchFamily="18" charset="0"/>
-                      </a:rPr>
-                      <m:t>𝜶</m:t>
-                    </m:r>
-                  </m:oMath>
-                </a14:m>
-                <a:r>
-                  <a:rPr lang="en-US" sz="1800" b="1" dirty="0"/>
-                  <a:t> decreases slowly enough. </a:t>
-                </a:r>
-                <a:r>
-                  <a:rPr lang="en-US" sz="1800" dirty="0"/>
-                  <a:t>Then the updates</a:t>
-                </a:r>
-                <a:br>
-                  <a:rPr lang="en-US" sz="1800" dirty="0"/>
+                  <a:rPr lang="en-US" sz="1400" dirty="0"/>
                 </a:br>
                 <a:br>
-                  <a:rPr lang="en-US" sz="1800" dirty="0"/>
+                  <a:rPr lang="en-US" sz="1400" dirty="0"/>
                 </a:br>
                 <a14:m>
                   <m:oMath xmlns:m="http://schemas.openxmlformats.org/officeDocument/2006/math">
@@ -27352,13 +27339,32 @@
                 </a:br>
                 <a:r>
                   <a:rPr lang="en-US" sz="1800" dirty="0"/>
-                  <a:t>lead to an expected TD error of 0, i.e., the Bellman consistency conditions are met which means convergence.</a:t>
+                  <a:t>guarantees convergence to an expected TD error of 0, if the </a:t>
                 </a:r>
-              </a:p>
-              <a:p>
-                <a:endParaRPr lang="en-US" sz="1800" dirty="0"/>
-              </a:p>
-              <a:p>
+                <a:r>
+                  <a:rPr lang="en-US" sz="1800" b="1" dirty="0"/>
+                  <a:t>learning rate </a:t>
+                </a:r>
+                <a14:m>
+                  <m:oMath xmlns:m="http://schemas.openxmlformats.org/officeDocument/2006/math">
+                    <m:r>
+                      <a:rPr lang="en-US" sz="1800" b="1" i="1" smtClean="0">
+                        <a:latin typeface="Cambria Math" panose="02040503050406030204" pitchFamily="18" charset="0"/>
+                      </a:rPr>
+                      <m:t>𝜶</m:t>
+                    </m:r>
+                  </m:oMath>
+                </a14:m>
+                <a:r>
+                  <a:rPr lang="en-US" sz="1800" b="1" dirty="0"/>
+                  <a:t> decreases slowly enough.</a:t>
+                </a:r>
+                <a:br>
+                  <a:rPr lang="en-US" sz="1800" b="1" dirty="0"/>
+                </a:br>
+                <a:br>
+                  <a:rPr lang="en-US" sz="1800" b="1" dirty="0"/>
+                </a:br>
                 <a:r>
                   <a:rPr lang="en-US" sz="1800" dirty="0"/>
                   <a:t>What is slow enough?</a:t>
@@ -27446,10 +27452,34 @@
                   <a:t>     (equivalent to incremental averaging)</a:t>
                 </a:r>
               </a:p>
+              <a:p>
+                <a:r>
+                  <a:rPr lang="en-US" sz="1800" b="1" dirty="0"/>
+                  <a:t>In practice</a:t>
+                </a:r>
+                <a:r>
+                  <a:rPr lang="en-US" sz="1800" dirty="0"/>
+                  <a:t>: Choose a fixed small </a:t>
+                </a:r>
+                <a14:m>
+                  <m:oMath xmlns:m="http://schemas.openxmlformats.org/officeDocument/2006/math">
+                    <m:r>
+                      <a:rPr lang="en-US" sz="1800" b="0" i="1" smtClean="0">
+                        <a:latin typeface="Cambria Math" panose="02040503050406030204" pitchFamily="18" charset="0"/>
+                      </a:rPr>
+                      <m:t>𝛼</m:t>
+                    </m:r>
+                  </m:oMath>
+                </a14:m>
+                <a:r>
+                  <a:rPr lang="en-US" sz="1800" dirty="0"/>
+                  <a:t>. Especially for deep RL or non-stationary environments. </a:t>
+                </a:r>
+              </a:p>
             </p:txBody>
           </p:sp>
         </mc:Choice>
-        <mc:Fallback xmlns="">
+        <mc:Fallback>
           <p:sp>
             <p:nvSpPr>
               <p:cNvPr id="3" name="Content Placeholder 2" descr="Regular conditions on the MDP apply (finite, gamma is less than 1, etc.). The observed TD error delta sub t equals R sub t plus 1, plus gamma V (S sub t plus 1) minus V (S sub t) is a noisy sample of the true difference. Convergence: Stochastic approximation theory guarantees convergence if the learning rate alpha decreases slowly enough. Then the updates V (S sub t) V (S sub t) plus alpha [R sub t plus 1, plus gamma V (S sub t plus 1) minus V (S sub t)] lead to an expected TD error of 0, i.e., the Bellman consistency conditions are met which means convergence. What is slow enough?. Example: alpha sub t equals 1 over t (equivalent to incremental averaging)">
@@ -27474,7 +27504,7 @@
               <a:blipFill>
                 <a:blip r:embed="rId2"/>
                 <a:stretch>
-                  <a:fillRect l="-406" t="-1148" b="-10587"/>
+                  <a:fillRect l="-522" t="-1276" b="-7781"/>
                 </a:stretch>
               </a:blipFill>
             </p:spPr>
@@ -27493,8 +27523,8 @@
           </p:sp>
         </mc:Fallback>
       </mc:AlternateContent>
-      <mc:AlternateContent xmlns:mc="http://schemas.openxmlformats.org/markup-compatibility/2006" xmlns:a14="http://schemas.microsoft.com/office/drawing/2010/main">
-        <mc:Choice Requires="a14">
+      <mc:AlternateContent xmlns:mc="http://schemas.openxmlformats.org/markup-compatibility/2006">
+        <mc:Choice xmlns:a14="http://schemas.microsoft.com/office/drawing/2010/main" Requires="a14">
           <p:sp>
             <p:nvSpPr>
               <p:cNvPr id="6" name="TextBox 5" descr="Robbins-Monro condition:. the sum over t equals 1 to infinity, of alpha sub t equals infinity and the sum over t equals 1 to infinity, of alpha sub t, to the power 2, is less than infinity">
@@ -27509,7 +27539,7 @@
             </p:nvSpPr>
             <p:spPr>
               <a:xfrm>
-                <a:off x="4230122" y="4681336"/>
+                <a:off x="4230122" y="4027002"/>
                 <a:ext cx="3983011" cy="1124603"/>
               </a:xfrm>
               <a:prstGeom prst="rect">
@@ -27725,7 +27755,7 @@
             </p:txBody>
           </p:sp>
         </mc:Choice>
-        <mc:Fallback xmlns="">
+        <mc:Fallback>
           <p:sp>
             <p:nvSpPr>
               <p:cNvPr id="6" name="TextBox 5" descr="Robbins-Monro condition:. the sum over t equals 1 to infinity, of alpha sub t equals infinity and the sum over t equals 1 to infinity, of alpha sub t, to the power 2, is less than infinity">
@@ -27742,7 +27772,7 @@
             </p:nvSpPr>
             <p:spPr>
               <a:xfrm>
-                <a:off x="4230122" y="4681336"/>
+                <a:off x="4230122" y="4027002"/>
                 <a:ext cx="3983011" cy="1124603"/>
               </a:xfrm>
               <a:prstGeom prst="rect">
@@ -27770,8 +27800,8 @@
           </p:sp>
         </mc:Fallback>
       </mc:AlternateContent>
-      <mc:AlternateContent xmlns:mc="http://schemas.openxmlformats.org/markup-compatibility/2006" xmlns:a14="http://schemas.microsoft.com/office/drawing/2010/main">
-        <mc:Choice Requires="a14">
+      <mc:AlternateContent xmlns:mc="http://schemas.openxmlformats.org/markup-compatibility/2006">
+        <mc:Choice xmlns:a14="http://schemas.microsoft.com/office/drawing/2010/main" Requires="a14">
           <p:sp>
             <p:nvSpPr>
               <p:cNvPr id="7" name="Speech Bubble: Rectangle with Corners Rounded 6" descr="alpha never becomes 0 = keeps learning forever">
@@ -27786,7 +27816,7 @@
             </p:nvSpPr>
             <p:spPr>
               <a:xfrm>
-                <a:off x="1707328" y="5264098"/>
+                <a:off x="1707328" y="4609764"/>
                 <a:ext cx="2048969" cy="625337"/>
               </a:xfrm>
               <a:prstGeom prst="wedgeRoundRectCallout">
@@ -27842,7 +27872,7 @@
             </p:txBody>
           </p:sp>
         </mc:Choice>
-        <mc:Fallback xmlns="">
+        <mc:Fallback>
           <p:sp>
             <p:nvSpPr>
               <p:cNvPr id="7" name="Speech Bubble: Rectangle with Corners Rounded 6" descr="alpha never becomes 0 = keeps learning forever">
@@ -27859,7 +27889,7 @@
             </p:nvSpPr>
             <p:spPr>
               <a:xfrm>
-                <a:off x="1707328" y="5264098"/>
+                <a:off x="1707328" y="4609764"/>
                 <a:ext cx="2048969" cy="625337"/>
               </a:xfrm>
               <a:prstGeom prst="wedgeRoundRectCallout">
@@ -27905,7 +27935,7 @@
         </p:nvSpPr>
         <p:spPr>
           <a:xfrm>
-            <a:off x="8641653" y="4789189"/>
+            <a:off x="8641653" y="4134855"/>
             <a:ext cx="2599545" cy="978192"/>
           </a:xfrm>
           <a:prstGeom prst="wedgeRoundRectCallout">
@@ -28039,7 +28069,7 @@
                                         <p:tgtEl>
                                           <p:spTgt spid="3">
                                             <p:txEl>
-                                              <p:pRg st="1" end="1"/>
+                                              <p:pRg st="2" end="2"/>
                                             </p:txEl>
                                           </p:spTgt>
                                         </p:tgtEl>
@@ -28088,7 +28118,7 @@
                                         <p:tgtEl>
                                           <p:spTgt spid="3">
                                             <p:txEl>
-                                              <p:pRg st="2" end="2"/>
+                                              <p:pRg st="6" end="6"/>
                                             </p:txEl>
                                           </p:spTgt>
                                         </p:tgtEl>
@@ -28137,7 +28167,7 @@
                                         <p:tgtEl>
                                           <p:spTgt spid="3">
                                             <p:txEl>
-                                              <p:pRg st="4" end="4"/>
+                                              <p:pRg st="7" end="7"/>
                                             </p:txEl>
                                           </p:spTgt>
                                         </p:tgtEl>
@@ -28275,55 +28305,6 @@
                                         </p:cTn>
                                         <p:tgtEl>
                                           <p:spTgt spid="8"/>
-                                        </p:tgtEl>
-                                        <p:attrNameLst>
-                                          <p:attrName>style.visibility</p:attrName>
-                                        </p:attrNameLst>
-                                      </p:cBhvr>
-                                      <p:to>
-                                        <p:strVal val="visible"/>
-                                      </p:to>
-                                    </p:set>
-                                  </p:childTnLst>
-                                </p:cTn>
-                              </p:par>
-                            </p:childTnLst>
-                          </p:cTn>
-                        </p:par>
-                      </p:childTnLst>
-                    </p:cTn>
-                  </p:par>
-                  <p:par>
-                    <p:cTn id="31" fill="hold">
-                      <p:stCondLst>
-                        <p:cond delay="indefinite"/>
-                      </p:stCondLst>
-                      <p:childTnLst>
-                        <p:par>
-                          <p:cTn id="32" fill="hold">
-                            <p:stCondLst>
-                              <p:cond delay="0"/>
-                            </p:stCondLst>
-                            <p:childTnLst>
-                              <p:par>
-                                <p:cTn id="33" presetID="1" presetClass="entr" presetSubtype="0" fill="hold" grpId="0" nodeType="clickEffect">
-                                  <p:stCondLst>
-                                    <p:cond delay="0"/>
-                                  </p:stCondLst>
-                                  <p:childTnLst>
-                                    <p:set>
-                                      <p:cBhvr>
-                                        <p:cTn id="34" dur="1" fill="hold">
-                                          <p:stCondLst>
-                                            <p:cond delay="0"/>
-                                          </p:stCondLst>
-                                        </p:cTn>
-                                        <p:tgtEl>
-                                          <p:spTgt spid="3">
-                                            <p:txEl>
-                                              <p:pRg st="8" end="8"/>
-                                            </p:txEl>
-                                          </p:spTgt>
                                         </p:tgtEl>
                                         <p:attrNameLst>
                                           <p:attrName>style.visibility</p:attrName>

</xml_diff>

<commit_message>
improved bias vs variance discussion.
</commit_message>
<xml_diff>
--- a/slides/Lecture_Chapter06.pptx
+++ b/slides/Lecture_Chapter06.pptx
@@ -145,7 +145,7 @@
             <p14:sldId id="478"/>
           </p14:sldIdLst>
         </p14:section>
-        <p14:section name="Idea of Remporal-Difference Learning" id="{2380860D-C062-4E40-AEF2-F4A84DAD8EB2}">
+        <p14:section name="What is Temporal-Difference Learning?" id="{2380860D-C062-4E40-AEF2-F4A84DAD8EB2}">
           <p14:sldIdLst>
             <p14:sldId id="480"/>
             <p14:sldId id="382"/>
@@ -286,7 +286,7 @@
           <a:p>
             <a:fld id="{2A92B22A-BE2A-43CB-B312-FF3A0A14567B}" type="datetimeFigureOut">
               <a:rPr lang="en-US" smtClean="0"/>
-              <a:t>10/23/2026</a:t>
+              <a:t>10/27/2026</a:t>
             </a:fld>
             <a:endParaRPr lang="en-US"/>
           </a:p>
@@ -784,7 +784,7 @@
           <a:p>
             <a:fld id="{3E22BF2E-04DA-469E-97C5-BB68A0368813}" type="datetimeFigureOut">
               <a:rPr lang="en-US" smtClean="0"/>
-              <a:t>10/23/2026</a:t>
+              <a:t>10/27/2026</a:t>
             </a:fld>
             <a:endParaRPr lang="en-US"/>
           </a:p>
@@ -982,7 +982,7 @@
           <a:p>
             <a:fld id="{3E22BF2E-04DA-469E-97C5-BB68A0368813}" type="datetimeFigureOut">
               <a:rPr lang="en-US" smtClean="0"/>
-              <a:t>10/23/2026</a:t>
+              <a:t>10/27/2026</a:t>
             </a:fld>
             <a:endParaRPr lang="en-US"/>
           </a:p>
@@ -1190,7 +1190,7 @@
           <a:p>
             <a:fld id="{3E22BF2E-04DA-469E-97C5-BB68A0368813}" type="datetimeFigureOut">
               <a:rPr lang="en-US" smtClean="0"/>
-              <a:t>10/23/2026</a:t>
+              <a:t>10/27/2026</a:t>
             </a:fld>
             <a:endParaRPr lang="en-US"/>
           </a:p>
@@ -1398,7 +1398,7 @@
           <a:p>
             <a:fld id="{3E22BF2E-04DA-469E-97C5-BB68A0368813}" type="datetimeFigureOut">
               <a:rPr lang="en-US" smtClean="0"/>
-              <a:t>10/23/2026</a:t>
+              <a:t>10/27/2026</a:t>
             </a:fld>
             <a:endParaRPr lang="en-US"/>
           </a:p>
@@ -1673,7 +1673,7 @@
           <a:p>
             <a:fld id="{3E22BF2E-04DA-469E-97C5-BB68A0368813}" type="datetimeFigureOut">
               <a:rPr lang="en-US" smtClean="0"/>
-              <a:t>10/23/2026</a:t>
+              <a:t>10/27/2026</a:t>
             </a:fld>
             <a:endParaRPr lang="en-US"/>
           </a:p>
@@ -1938,7 +1938,7 @@
           <a:p>
             <a:fld id="{3E22BF2E-04DA-469E-97C5-BB68A0368813}" type="datetimeFigureOut">
               <a:rPr lang="en-US" smtClean="0"/>
-              <a:t>10/23/2026</a:t>
+              <a:t>10/27/2026</a:t>
             </a:fld>
             <a:endParaRPr lang="en-US"/>
           </a:p>
@@ -2350,7 +2350,7 @@
           <a:p>
             <a:fld id="{3E22BF2E-04DA-469E-97C5-BB68A0368813}" type="datetimeFigureOut">
               <a:rPr lang="en-US" smtClean="0"/>
-              <a:t>10/23/2026</a:t>
+              <a:t>10/27/2026</a:t>
             </a:fld>
             <a:endParaRPr lang="en-US"/>
           </a:p>
@@ -2491,7 +2491,7 @@
           <a:p>
             <a:fld id="{3E22BF2E-04DA-469E-97C5-BB68A0368813}" type="datetimeFigureOut">
               <a:rPr lang="en-US" smtClean="0"/>
-              <a:t>10/23/2026</a:t>
+              <a:t>10/27/2026</a:t>
             </a:fld>
             <a:endParaRPr lang="en-US"/>
           </a:p>
@@ -2604,7 +2604,7 @@
           <a:p>
             <a:fld id="{3E22BF2E-04DA-469E-97C5-BB68A0368813}" type="datetimeFigureOut">
               <a:rPr lang="en-US" smtClean="0"/>
-              <a:t>10/23/2026</a:t>
+              <a:t>10/27/2026</a:t>
             </a:fld>
             <a:endParaRPr lang="en-US"/>
           </a:p>
@@ -2915,7 +2915,7 @@
           <a:p>
             <a:fld id="{3E22BF2E-04DA-469E-97C5-BB68A0368813}" type="datetimeFigureOut">
               <a:rPr lang="en-US" smtClean="0"/>
-              <a:t>10/23/2026</a:t>
+              <a:t>10/27/2026</a:t>
             </a:fld>
             <a:endParaRPr lang="en-US"/>
           </a:p>
@@ -3203,7 +3203,7 @@
           <a:p>
             <a:fld id="{3E22BF2E-04DA-469E-97C5-BB68A0368813}" type="datetimeFigureOut">
               <a:rPr lang="en-US" smtClean="0"/>
-              <a:t>10/23/2026</a:t>
+              <a:t>10/27/2026</a:t>
             </a:fld>
             <a:endParaRPr lang="en-US"/>
           </a:p>
@@ -3444,7 +3444,7 @@
           <a:p>
             <a:fld id="{3E22BF2E-04DA-469E-97C5-BB68A0368813}" type="datetimeFigureOut">
               <a:rPr lang="en-US" smtClean="0"/>
-              <a:t>10/23/2026</a:t>
+              <a:t>10/27/2026</a:t>
             </a:fld>
             <a:endParaRPr lang="en-US"/>
           </a:p>
@@ -4622,8 +4622,8 @@
           </a:p>
         </p:txBody>
       </p:sp>
-      <mc:AlternateContent xmlns:mc="http://schemas.openxmlformats.org/markup-compatibility/2006" xmlns:a14="http://schemas.microsoft.com/office/drawing/2010/main">
-        <mc:Choice Requires="a14">
+      <mc:AlternateContent xmlns:mc="http://schemas.openxmlformats.org/markup-compatibility/2006">
+        <mc:Choice xmlns:a14="http://schemas.microsoft.com/office/drawing/2010/main" Requires="a14">
           <p:sp>
             <p:nvSpPr>
               <p:cNvPr id="3" name="Content Placeholder 2" descr="True online updates: Updates at each step. Bootstraps using estimate V(S prime) for the value of V(S) . The estimate is biased. Model-free: Only needs samples. DP needs the transition probabilities!. Convergence: Converges typically faster than MC prediction. Reasons:. Less variance: Stochasticity in the environment produces large variance in the return of sampled episodes used by MC, but TD only samples the next reward and state. More frequent updates">
@@ -4785,7 +4785,7 @@
                 <a:pPr lvl="1"/>
                 <a:r>
                   <a:rPr lang="en-US" sz="2000" dirty="0"/>
-                  <a:t>Less variance: Stochasticity in the environment produces large variance in the return of sampled episodes used by MC, but TD only samples the next reward and state.</a:t>
+                  <a:t>Less sample variance: Stochasticity in the environment produces large variance in the return of sampled episodes used by MC, but TD only samples the next reward and state.</a:t>
                 </a:r>
               </a:p>
               <a:p>
@@ -4798,7 +4798,7 @@
             </p:txBody>
           </p:sp>
         </mc:Choice>
-        <mc:Fallback xmlns="">
+        <mc:Fallback>
           <p:sp>
             <p:nvSpPr>
               <p:cNvPr id="3" name="Content Placeholder 2" descr="True online updates: Updates at each step. Bootstraps using estimate V(S prime) for the value of V(S) . The estimate is biased. Model-free: Only needs samples. DP needs the transition probabilities!. Convergence: Converges typically faster than MC prediction. Reasons:. Less variance: Stochasticity in the environment produces large variance in the return of sampled episodes used by MC, but TD only samples the next reward and state. More frequent updates">
@@ -26686,7 +26686,7 @@
                 <a:pPr algn="ctr"/>
                 <a:r>
                   <a:rPr lang="en-US" sz="1400" b="1" dirty="0"/>
-                  <a:t>Note</a:t>
+                  <a:t>Delay</a:t>
                 </a:r>
                 <a:r>
                   <a:rPr lang="en-US" sz="1400" dirty="0"/>
@@ -26985,6 +26985,125 @@
           </a:p>
         </p:txBody>
       </p:sp>
+      <mc:AlternateContent xmlns:mc="http://schemas.openxmlformats.org/markup-compatibility/2006" xmlns:a14="http://schemas.microsoft.com/office/drawing/2010/main">
+        <mc:Choice Requires="a14">
+          <p:sp>
+            <p:nvSpPr>
+              <p:cNvPr id="7" name="Speech Bubble: Rectangle with Corners Rounded 6" descr="Note: We can only update for time t at time t plus 1 since we need to observe a complete S,A,R,S prime interaction and S prime is observed at t plus 1">
+                <a:extLst>
+                  <a:ext uri="{FF2B5EF4-FFF2-40B4-BE49-F238E27FC236}">
+                    <a16:creationId xmlns:a16="http://schemas.microsoft.com/office/drawing/2014/main" id="{C2358C87-2D6A-BBCD-12AA-7B1F435EEACB}"/>
+                  </a:ext>
+                </a:extLst>
+              </p:cNvPr>
+              <p:cNvSpPr/>
+              <p:nvPr/>
+            </p:nvSpPr>
+            <p:spPr>
+              <a:xfrm>
+                <a:off x="7980044" y="3086183"/>
+                <a:ext cx="2211806" cy="573117"/>
+              </a:xfrm>
+              <a:prstGeom prst="wedgeRoundRectCallout">
+                <a:avLst>
+                  <a:gd name="adj1" fmla="val -160936"/>
+                  <a:gd name="adj2" fmla="val 31907"/>
+                  <a:gd name="adj3" fmla="val 16667"/>
+                </a:avLst>
+              </a:prstGeom>
+            </p:spPr>
+            <p:style>
+              <a:lnRef idx="2">
+                <a:schemeClr val="accent1">
+                  <a:shade val="15000"/>
+                </a:schemeClr>
+              </a:lnRef>
+              <a:fillRef idx="1">
+                <a:schemeClr val="accent1"/>
+              </a:fillRef>
+              <a:effectRef idx="0">
+                <a:schemeClr val="accent1"/>
+              </a:effectRef>
+              <a:fontRef idx="minor">
+                <a:schemeClr val="lt1"/>
+              </a:fontRef>
+            </p:style>
+            <p:txBody>
+              <a:bodyPr rtlCol="0" anchor="ctr"/>
+              <a:lstStyle/>
+              <a:p>
+                <a:pPr algn="ctr"/>
+                <a:r>
+                  <a:rPr lang="en-US" sz="1400" dirty="0"/>
+                  <a:t>Only produces estimates for the states </a:t>
+                </a:r>
+                <a14:m>
+                  <m:oMath xmlns:m="http://schemas.openxmlformats.org/officeDocument/2006/math">
+                    <m:r>
+                      <a:rPr lang="en-US" sz="1400" b="0" i="1" smtClean="0">
+                        <a:latin typeface="Cambria Math" panose="02040503050406030204" pitchFamily="18" charset="0"/>
+                      </a:rPr>
+                      <m:t>𝜋</m:t>
+                    </m:r>
+                  </m:oMath>
+                </a14:m>
+                <a:r>
+                  <a:rPr lang="en-US" sz="1400" dirty="0"/>
+                  <a:t> visits.</a:t>
+                </a:r>
+              </a:p>
+            </p:txBody>
+          </p:sp>
+        </mc:Choice>
+        <mc:Fallback xmlns="">
+          <p:sp>
+            <p:nvSpPr>
+              <p:cNvPr id="7" name="Speech Bubble: Rectangle with Corners Rounded 6" descr="Note: We can only update for time t at time t plus 1 since we need to observe a complete S,A,R,S prime interaction and S prime is observed at t plus 1">
+                <a:extLst>
+                  <a:ext uri="{FF2B5EF4-FFF2-40B4-BE49-F238E27FC236}">
+                    <a16:creationId xmlns:a16="http://schemas.microsoft.com/office/drawing/2014/main" id="{C2358C87-2D6A-BBCD-12AA-7B1F435EEACB}"/>
+                  </a:ext>
+                </a:extLst>
+              </p:cNvPr>
+              <p:cNvSpPr>
+                <a:spLocks noRot="1" noChangeAspect="1" noMove="1" noResize="1" noEditPoints="1" noAdjustHandles="1" noChangeArrowheads="1" noChangeShapeType="1" noTextEdit="1"/>
+              </p:cNvSpPr>
+              <p:nvPr/>
+            </p:nvSpPr>
+            <p:spPr>
+              <a:xfrm>
+                <a:off x="7980044" y="3086183"/>
+                <a:ext cx="2211806" cy="573117"/>
+              </a:xfrm>
+              <a:prstGeom prst="wedgeRoundRectCallout">
+                <a:avLst>
+                  <a:gd name="adj1" fmla="val -160936"/>
+                  <a:gd name="adj2" fmla="val 31907"/>
+                  <a:gd name="adj3" fmla="val 16667"/>
+                </a:avLst>
+              </a:prstGeom>
+              <a:blipFill>
+                <a:blip r:embed="rId4"/>
+                <a:stretch>
+                  <a:fillRect b="-4124"/>
+                </a:stretch>
+              </a:blipFill>
+            </p:spPr>
+            <p:txBody>
+              <a:bodyPr/>
+              <a:lstStyle/>
+              <a:p>
+                <a:r>
+                  <a:rPr lang="en-US">
+                    <a:noFill/>
+                  </a:rPr>
+                  <a:t> </a:t>
+                </a:r>
+              </a:p>
+            </p:txBody>
+          </p:sp>
+        </mc:Fallback>
+      </mc:AlternateContent>
     </p:spTree>
     <p:extLst>
       <p:ext uri="{BB962C8B-B14F-4D97-AF65-F5344CB8AC3E}">
@@ -27074,6 +27193,51 @@
                                           </p:stCondLst>
                                         </p:cTn>
                                         <p:tgtEl>
+                                          <p:spTgt spid="7"/>
+                                        </p:tgtEl>
+                                        <p:attrNameLst>
+                                          <p:attrName>style.visibility</p:attrName>
+                                        </p:attrNameLst>
+                                      </p:cBhvr>
+                                      <p:to>
+                                        <p:strVal val="visible"/>
+                                      </p:to>
+                                    </p:set>
+                                  </p:childTnLst>
+                                </p:cTn>
+                              </p:par>
+                            </p:childTnLst>
+                          </p:cTn>
+                        </p:par>
+                      </p:childTnLst>
+                    </p:cTn>
+                  </p:par>
+                  <p:par>
+                    <p:cTn id="11" fill="hold">
+                      <p:stCondLst>
+                        <p:cond delay="indefinite"/>
+                      </p:stCondLst>
+                      <p:childTnLst>
+                        <p:par>
+                          <p:cTn id="12" fill="hold">
+                            <p:stCondLst>
+                              <p:cond delay="0"/>
+                            </p:stCondLst>
+                            <p:childTnLst>
+                              <p:par>
+                                <p:cTn id="13" presetID="1" presetClass="entr" presetSubtype="0" fill="hold" grpId="0" nodeType="clickEffect">
+                                  <p:stCondLst>
+                                    <p:cond delay="0"/>
+                                  </p:stCondLst>
+                                  <p:childTnLst>
+                                    <p:set>
+                                      <p:cBhvr>
+                                        <p:cTn id="14" dur="1" fill="hold">
+                                          <p:stCondLst>
+                                            <p:cond delay="0"/>
+                                          </p:stCondLst>
+                                        </p:cTn>
+                                        <p:tgtEl>
                                           <p:spTgt spid="3"/>
                                         </p:tgtEl>
                                         <p:attrNameLst>
@@ -27117,6 +27281,7 @@
     <p:bldLst>
       <p:bldP spid="3" grpId="0" animBg="1"/>
       <p:bldP spid="4" grpId="0" animBg="1"/>
+      <p:bldP spid="7" grpId="0" animBg="1"/>
     </p:bldLst>
   </p:timing>
 </p:sld>

</xml_diff>